<commit_message>
docs(pitch): add problem statement 01 slide after the title
Judges see which hackathon problem we chose, with the problem and challenge text and how INFRA-AI answers it. Later slides renumbered 3-7.

Co-Authored-By: Claude Sonnet 5.5 <noreply@anthropic.com>
</commit_message>
<xml_diff>
--- a/docs/INFRA-AI-pitch.pptx
+++ b/docs/INFRA-AI-pitch.pptx
@@ -6,6 +6,7 @@
   </p:sldMasterIdLst>
   <p:sldIdLst>
     <p:sldId id="256" r:id="rId2"/>
+    <p:sldId id="262" r:id="rId13"/>
     <p:sldId id="257" r:id="rId3"/>
     <p:sldId id="258" r:id="rId4"/>
     <p:sldId id="259" r:id="rId5"/>
@@ -3269,7 +3270,7 @@
                 <a:ea typeface="Calibri" pitchFamily="34" charset="-122"/>
                 <a:cs typeface="Calibri" pitchFamily="34" charset="-120"/>
               </a:rPr>
-              <a:t>2</a:t>
+              <a:t>3</a:t>
             </a:r>
             <a:endParaRPr lang="en-US" sz="1000" dirty="0"/>
           </a:p>
@@ -4947,7 +4948,7 @@
                 <a:ea typeface="Calibri" pitchFamily="34" charset="-122"/>
                 <a:cs typeface="Calibri" pitchFamily="34" charset="-120"/>
               </a:rPr>
-              <a:t>3</a:t>
+              <a:t>4</a:t>
             </a:r>
             <a:endParaRPr lang="en-US" sz="1000" dirty="0"/>
           </a:p>
@@ -5606,7 +5607,7 @@
                 <a:ea typeface="Calibri" pitchFamily="34" charset="-122"/>
                 <a:cs typeface="Calibri" pitchFamily="34" charset="-120"/>
               </a:rPr>
-              <a:t>4</a:t>
+              <a:t>5</a:t>
             </a:r>
             <a:endParaRPr lang="en-US" sz="1000" dirty="0"/>
           </a:p>
@@ -6702,7 +6703,7 @@
                 <a:ea typeface="Calibri" pitchFamily="34" charset="-122"/>
                 <a:cs typeface="Calibri" pitchFamily="34" charset="-120"/>
               </a:rPr>
-              <a:t>5</a:t>
+              <a:t>6</a:t>
             </a:r>
             <a:endParaRPr lang="en-US" sz="1000" dirty="0"/>
           </a:p>
@@ -7887,9 +7888,836 @@
                 <a:ea typeface="Calibri" pitchFamily="34" charset="-122"/>
                 <a:cs typeface="Calibri" pitchFamily="34" charset="-120"/>
               </a:rPr>
-              <a:t>6</a:t>
+              <a:t>7</a:t>
             </a:r>
             <a:endParaRPr lang="en-US" sz="1000" dirty="0"/>
+          </a:p>
+        </p:txBody>
+      </p:sp>
+    </p:spTree>
+  </p:cSld>
+  <p:clrMapOvr>
+    <a:masterClrMapping/>
+  </p:clrMapOvr>
+</p:sld>
+</file>
+
+<file path=ppt/slides/slide7.xml><?xml version="1.0" encoding="utf-8"?>
+<p:sld xmlns:a="http://schemas.openxmlformats.org/drawingml/2006/main" xmlns:p="http://schemas.openxmlformats.org/presentationml/2006/main" xmlns:r="http://schemas.openxmlformats.org/officeDocument/2006/relationships">
+  <p:cSld>
+    <p:bg>
+      <p:bgPr>
+        <a:solidFill>
+          <a:srgbClr val="FFFFFF"/>
+        </a:solidFill>
+        <a:effectLst/>
+      </p:bgPr>
+    </p:bg>
+    <p:spTree>
+      <p:nvGrpSpPr>
+        <p:cNvPr id="1" name=""/>
+        <p:cNvGrpSpPr/>
+        <p:nvPr/>
+      </p:nvGrpSpPr>
+      <p:grpSpPr/>
+      <p:sp>
+        <p:nvSpPr>
+          <p:cNvPr id="2" name="TextBox 1"/>
+          <p:cNvSpPr txBox="1"/>
+          <p:nvPr/>
+        </p:nvSpPr>
+        <p:spPr>
+          <a:xfrm>
+            <a:off x="548640" y="365760"/>
+            <a:ext cx="11064240" cy="777240"/>
+          </a:xfrm>
+          <a:prstGeom prst="rect">
+            <a:avLst/>
+          </a:prstGeom>
+          <a:noFill/>
+        </p:spPr>
+        <p:txBody>
+          <a:bodyPr wrap="square" anchor="ctr" lIns="0" rIns="0" tIns="0" bIns="0">
+            <a:spAutoFit/>
+          </a:bodyPr>
+          <a:lstStyle/>
+          <a:p>
+            <a:pPr>
+              <a:spcAft>
+                <a:spcPts val="0"/>
+              </a:spcAft>
+            </a:pPr>
+            <a:r>
+              <a:rPr sz="3000" b="1">
+                <a:solidFill>
+                  <a:srgbClr val="14232B"/>
+                </a:solidFill>
+                <a:latin typeface="Cambria"/>
+              </a:rPr>
+              <a:t>Problem statement 01: AI for Digital Public Infrastructure &amp; Governance</a:t>
+            </a:r>
+          </a:p>
+        </p:txBody>
+      </p:sp>
+      <p:sp>
+        <p:nvSpPr>
+          <p:cNvPr id="3" name="TextBox 2"/>
+          <p:cNvSpPr txBox="1"/>
+          <p:nvPr/>
+        </p:nvSpPr>
+        <p:spPr>
+          <a:xfrm>
+            <a:off x="548640" y="1115568"/>
+            <a:ext cx="11064240" cy="365760"/>
+          </a:xfrm>
+          <a:prstGeom prst="rect">
+            <a:avLst/>
+          </a:prstGeom>
+          <a:noFill/>
+        </p:spPr>
+        <p:txBody>
+          <a:bodyPr wrap="square" anchor="ctr" lIns="0" rIns="0" tIns="0" bIns="0">
+            <a:spAutoFit/>
+          </a:bodyPr>
+          <a:lstStyle/>
+          <a:p>
+            <a:pPr>
+              <a:spcAft>
+                <a:spcPts val="0"/>
+              </a:spcAft>
+            </a:pPr>
+            <a:r>
+              <a:rPr sz="1500" b="0">
+                <a:solidFill>
+                  <a:srgbClr val="5B6B72"/>
+                </a:solidFill>
+                <a:latin typeface="Calibri"/>
+              </a:rPr>
+              <a:t>Build with AI: Code for Communities, Second Edition  ·  Theme: Innovation  ·  Our chosen problem</a:t>
+            </a:r>
+          </a:p>
+        </p:txBody>
+      </p:sp>
+      <p:sp>
+        <p:nvSpPr>
+          <p:cNvPr id="4" name="Rounded Rectangle 3"/>
+          <p:cNvSpPr/>
+          <p:nvPr/>
+        </p:nvSpPr>
+        <p:spPr>
+          <a:xfrm>
+            <a:off x="548640" y="1737360"/>
+            <a:ext cx="7040880" cy="1600200"/>
+          </a:xfrm>
+          <a:prstGeom prst="roundRect">
+            <a:avLst>
+              <a:gd name="adj" fmla="val 4000"/>
+            </a:avLst>
+          </a:prstGeom>
+          <a:solidFill>
+            <a:srgbClr val="EAF2F3"/>
+          </a:solidFill>
+          <a:ln>
+            <a:noFill/>
+          </a:ln>
+          <a:effectLst/>
+        </p:spPr>
+        <p:style>
+          <a:lnRef idx="1">
+            <a:schemeClr val="accent1"/>
+          </a:lnRef>
+          <a:fillRef idx="3">
+            <a:schemeClr val="accent1"/>
+          </a:fillRef>
+          <a:effectRef idx="2">
+            <a:schemeClr val="accent1"/>
+          </a:effectRef>
+          <a:fontRef idx="minor">
+            <a:schemeClr val="lt1"/>
+          </a:fontRef>
+        </p:style>
+        <p:txBody>
+          <a:bodyPr rtlCol="0" anchor="ctr"/>
+          <a:lstStyle/>
+          <a:p>
+            <a:pPr algn="ctr"/>
+          </a:p>
+        </p:txBody>
+      </p:sp>
+      <p:sp>
+        <p:nvSpPr>
+          <p:cNvPr id="5" name="TextBox 4"/>
+          <p:cNvSpPr txBox="1"/>
+          <p:nvPr/>
+        </p:nvSpPr>
+        <p:spPr>
+          <a:xfrm>
+            <a:off x="777240" y="1874519"/>
+            <a:ext cx="6583680" cy="274320"/>
+          </a:xfrm>
+          <a:prstGeom prst="rect">
+            <a:avLst/>
+          </a:prstGeom>
+          <a:noFill/>
+        </p:spPr>
+        <p:txBody>
+          <a:bodyPr wrap="square" anchor="t" lIns="0" rIns="0" tIns="0" bIns="0">
+            <a:spAutoFit/>
+          </a:bodyPr>
+          <a:lstStyle/>
+          <a:p>
+            <a:pPr>
+              <a:spcAft>
+                <a:spcPts val="0"/>
+              </a:spcAft>
+            </a:pPr>
+            <a:r>
+              <a:rPr sz="1200" b="1">
+                <a:solidFill>
+                  <a:srgbClr val="0B4F5C"/>
+                </a:solidFill>
+                <a:latin typeface="Calibri"/>
+              </a:rPr>
+              <a:t>THE PROBLEM</a:t>
+            </a:r>
+          </a:p>
+        </p:txBody>
+      </p:sp>
+      <p:sp>
+        <p:nvSpPr>
+          <p:cNvPr id="6" name="TextBox 5"/>
+          <p:cNvSpPr txBox="1"/>
+          <p:nvPr/>
+        </p:nvSpPr>
+        <p:spPr>
+          <a:xfrm>
+            <a:off x="777240" y="2194560"/>
+            <a:ext cx="6583680" cy="1097280"/>
+          </a:xfrm>
+          <a:prstGeom prst="rect">
+            <a:avLst/>
+          </a:prstGeom>
+          <a:noFill/>
+        </p:spPr>
+        <p:txBody>
+          <a:bodyPr wrap="square" anchor="t" lIns="0" rIns="0" tIns="0" bIns="0">
+            <a:spAutoFit/>
+          </a:bodyPr>
+          <a:lstStyle/>
+          <a:p>
+            <a:pPr>
+              <a:spcAft>
+                <a:spcPts val="0"/>
+              </a:spcAft>
+            </a:pPr>
+            <a:r>
+              <a:rPr sz="1400" b="0">
+                <a:solidFill>
+                  <a:srgbClr val="14232B"/>
+                </a:solidFill>
+                <a:latin typeface="Calibri"/>
+              </a:rPr>
+              <a:t>Governments across India struggle to consolidate citizen feedback and align it with national infrastructure priorities. Development requests live in fragmented systems, leading to misaligned public spending, unaddressed infrastructure gaps, and no way to measure the impact of large-scale digital public infrastructure initiatives.</a:t>
+            </a:r>
+          </a:p>
+        </p:txBody>
+      </p:sp>
+      <p:sp>
+        <p:nvSpPr>
+          <p:cNvPr id="7" name="Rounded Rectangle 6"/>
+          <p:cNvSpPr/>
+          <p:nvPr/>
+        </p:nvSpPr>
+        <p:spPr>
+          <a:xfrm>
+            <a:off x="548640" y="3520440"/>
+            <a:ext cx="7040880" cy="2651760"/>
+          </a:xfrm>
+          <a:prstGeom prst="roundRect">
+            <a:avLst>
+              <a:gd name="adj" fmla="val 4000"/>
+            </a:avLst>
+          </a:prstGeom>
+          <a:solidFill>
+            <a:srgbClr val="EAF2F3"/>
+          </a:solidFill>
+          <a:ln>
+            <a:noFill/>
+          </a:ln>
+          <a:effectLst/>
+        </p:spPr>
+        <p:style>
+          <a:lnRef idx="1">
+            <a:schemeClr val="accent1"/>
+          </a:lnRef>
+          <a:fillRef idx="3">
+            <a:schemeClr val="accent1"/>
+          </a:fillRef>
+          <a:effectRef idx="2">
+            <a:schemeClr val="accent1"/>
+          </a:effectRef>
+          <a:fontRef idx="minor">
+            <a:schemeClr val="lt1"/>
+          </a:fontRef>
+        </p:style>
+        <p:txBody>
+          <a:bodyPr rtlCol="0" anchor="ctr"/>
+          <a:lstStyle/>
+          <a:p>
+            <a:pPr algn="ctr"/>
+          </a:p>
+        </p:txBody>
+      </p:sp>
+      <p:sp>
+        <p:nvSpPr>
+          <p:cNvPr id="8" name="TextBox 7"/>
+          <p:cNvSpPr txBox="1"/>
+          <p:nvPr/>
+        </p:nvSpPr>
+        <p:spPr>
+          <a:xfrm>
+            <a:off x="777240" y="3657600"/>
+            <a:ext cx="6583680" cy="274320"/>
+          </a:xfrm>
+          <a:prstGeom prst="rect">
+            <a:avLst/>
+          </a:prstGeom>
+          <a:noFill/>
+        </p:spPr>
+        <p:txBody>
+          <a:bodyPr wrap="square" anchor="t" lIns="0" rIns="0" tIns="0" bIns="0">
+            <a:spAutoFit/>
+          </a:bodyPr>
+          <a:lstStyle/>
+          <a:p>
+            <a:pPr>
+              <a:spcAft>
+                <a:spcPts val="0"/>
+              </a:spcAft>
+            </a:pPr>
+            <a:r>
+              <a:rPr sz="1200" b="1">
+                <a:solidFill>
+                  <a:srgbClr val="0B4F5C"/>
+                </a:solidFill>
+                <a:latin typeface="Calibri"/>
+              </a:rPr>
+              <a:t>THE CHALLENGE</a:t>
+            </a:r>
+          </a:p>
+        </p:txBody>
+      </p:sp>
+      <p:sp>
+        <p:nvSpPr>
+          <p:cNvPr id="9" name="TextBox 8"/>
+          <p:cNvSpPr txBox="1"/>
+          <p:nvPr/>
+        </p:nvSpPr>
+        <p:spPr>
+          <a:xfrm>
+            <a:off x="777240" y="3977639"/>
+            <a:ext cx="6583680" cy="2103120"/>
+          </a:xfrm>
+          <a:prstGeom prst="rect">
+            <a:avLst/>
+          </a:prstGeom>
+          <a:noFill/>
+        </p:spPr>
+        <p:txBody>
+          <a:bodyPr wrap="square" anchor="t" lIns="0" rIns="0" tIns="0" bIns="0">
+            <a:spAutoFit/>
+          </a:bodyPr>
+          <a:lstStyle/>
+          <a:p>
+            <a:pPr>
+              <a:spcAft>
+                <a:spcPts val="0"/>
+              </a:spcAft>
+            </a:pPr>
+            <a:r>
+              <a:rPr sz="1400" b="0">
+                <a:solidFill>
+                  <a:srgbClr val="14232B"/>
+                </a:solidFill>
+                <a:latin typeface="Calibri"/>
+              </a:rPr>
+              <a:t>Build a scalable, multilingual AI platform, designed as a Digital Public Good, that aggregates citizen development requests via voice, text, and messaging apps across diverse linguistic regions of India. The system should analyse large datasets combining citizen feedback with national demographic data, infrastructure indices, and public investment plans, surfacing demand hotspots and recommending high-priority development projects to national policymakers.</a:t>
+            </a:r>
+          </a:p>
+        </p:txBody>
+      </p:sp>
+      <p:sp>
+        <p:nvSpPr>
+          <p:cNvPr id="10" name="Rounded Rectangle 9"/>
+          <p:cNvSpPr/>
+          <p:nvPr/>
+        </p:nvSpPr>
+        <p:spPr>
+          <a:xfrm>
+            <a:off x="7863840" y="1737360"/>
+            <a:ext cx="3776472" cy="4434840"/>
+          </a:xfrm>
+          <a:prstGeom prst="roundRect">
+            <a:avLst>
+              <a:gd name="adj" fmla="val 4000"/>
+            </a:avLst>
+          </a:prstGeom>
+          <a:solidFill>
+            <a:srgbClr val="0B4F5C"/>
+          </a:solidFill>
+          <a:ln>
+            <a:noFill/>
+          </a:ln>
+          <a:effectLst/>
+        </p:spPr>
+        <p:style>
+          <a:lnRef idx="1">
+            <a:schemeClr val="accent1"/>
+          </a:lnRef>
+          <a:fillRef idx="3">
+            <a:schemeClr val="accent1"/>
+          </a:fillRef>
+          <a:effectRef idx="2">
+            <a:schemeClr val="accent1"/>
+          </a:effectRef>
+          <a:fontRef idx="minor">
+            <a:schemeClr val="lt1"/>
+          </a:fontRef>
+        </p:style>
+        <p:txBody>
+          <a:bodyPr rtlCol="0" anchor="ctr"/>
+          <a:lstStyle/>
+          <a:p>
+            <a:pPr algn="ctr"/>
+          </a:p>
+        </p:txBody>
+      </p:sp>
+      <p:sp>
+        <p:nvSpPr>
+          <p:cNvPr id="11" name="TextBox 10"/>
+          <p:cNvSpPr txBox="1"/>
+          <p:nvPr/>
+        </p:nvSpPr>
+        <p:spPr>
+          <a:xfrm>
+            <a:off x="8092440" y="1874519"/>
+            <a:ext cx="3337560" cy="365760"/>
+          </a:xfrm>
+          <a:prstGeom prst="rect">
+            <a:avLst/>
+          </a:prstGeom>
+          <a:noFill/>
+        </p:spPr>
+        <p:txBody>
+          <a:bodyPr wrap="square" anchor="t" lIns="0" rIns="0" tIns="0" bIns="0">
+            <a:spAutoFit/>
+          </a:bodyPr>
+          <a:lstStyle/>
+          <a:p>
+            <a:pPr>
+              <a:spcAft>
+                <a:spcPts val="0"/>
+              </a:spcAft>
+            </a:pPr>
+            <a:r>
+              <a:rPr sz="1800" b="1">
+                <a:solidFill>
+                  <a:srgbClr val="FFFFFF"/>
+                </a:solidFill>
+                <a:latin typeface="Cambria"/>
+              </a:rPr>
+              <a:t>How INFRA-AI answers it</a:t>
+            </a:r>
+          </a:p>
+        </p:txBody>
+      </p:sp>
+      <p:sp>
+        <p:nvSpPr>
+          <p:cNvPr id="12" name="TextBox 11"/>
+          <p:cNvSpPr txBox="1"/>
+          <p:nvPr/>
+        </p:nvSpPr>
+        <p:spPr>
+          <a:xfrm>
+            <a:off x="8092440" y="2423160"/>
+            <a:ext cx="3337560" cy="274320"/>
+          </a:xfrm>
+          <a:prstGeom prst="rect">
+            <a:avLst/>
+          </a:prstGeom>
+          <a:noFill/>
+        </p:spPr>
+        <p:txBody>
+          <a:bodyPr wrap="square" anchor="t" lIns="0" rIns="0" tIns="0" bIns="0">
+            <a:spAutoFit/>
+          </a:bodyPr>
+          <a:lstStyle/>
+          <a:p>
+            <a:pPr>
+              <a:spcAft>
+                <a:spcPts val="0"/>
+              </a:spcAft>
+            </a:pPr>
+            <a:r>
+              <a:rPr sz="1400" b="1">
+                <a:solidFill>
+                  <a:srgbClr val="FFFFFF"/>
+                </a:solidFill>
+                <a:latin typeface="Calibri"/>
+              </a:rPr>
+              <a:t>Every request, every language</a:t>
+            </a:r>
+          </a:p>
+        </p:txBody>
+      </p:sp>
+      <p:sp>
+        <p:nvSpPr>
+          <p:cNvPr id="13" name="TextBox 12"/>
+          <p:cNvSpPr txBox="1"/>
+          <p:nvPr/>
+        </p:nvSpPr>
+        <p:spPr>
+          <a:xfrm>
+            <a:off x="8092440" y="2715768"/>
+            <a:ext cx="3337560" cy="548640"/>
+          </a:xfrm>
+          <a:prstGeom prst="rect">
+            <a:avLst/>
+          </a:prstGeom>
+          <a:noFill/>
+        </p:spPr>
+        <p:txBody>
+          <a:bodyPr wrap="square" anchor="t" lIns="0" rIns="0" tIns="0" bIns="0">
+            <a:spAutoFit/>
+          </a:bodyPr>
+          <a:lstStyle/>
+          <a:p>
+            <a:pPr>
+              <a:spcAft>
+                <a:spcPts val="0"/>
+              </a:spcAft>
+            </a:pPr>
+            <a:r>
+              <a:rPr sz="1200" b="0">
+                <a:solidFill>
+                  <a:srgbClr val="CADCE0"/>
+                </a:solidFill>
+                <a:latin typeface="Calibri"/>
+              </a:rPr>
+              <a:t>Voice, text and messaging intake in 22 languages</a:t>
+            </a:r>
+          </a:p>
+        </p:txBody>
+      </p:sp>
+      <p:sp>
+        <p:nvSpPr>
+          <p:cNvPr id="14" name="TextBox 13"/>
+          <p:cNvSpPr txBox="1"/>
+          <p:nvPr/>
+        </p:nvSpPr>
+        <p:spPr>
+          <a:xfrm>
+            <a:off x="8092440" y="3355848"/>
+            <a:ext cx="3337560" cy="274320"/>
+          </a:xfrm>
+          <a:prstGeom prst="rect">
+            <a:avLst/>
+          </a:prstGeom>
+          <a:noFill/>
+        </p:spPr>
+        <p:txBody>
+          <a:bodyPr wrap="square" anchor="t" lIns="0" rIns="0" tIns="0" bIns="0">
+            <a:spAutoFit/>
+          </a:bodyPr>
+          <a:lstStyle/>
+          <a:p>
+            <a:pPr>
+              <a:spcAft>
+                <a:spcPts val="0"/>
+              </a:spcAft>
+            </a:pPr>
+            <a:r>
+              <a:rPr sz="1400" b="1">
+                <a:solidFill>
+                  <a:srgbClr val="FFFFFF"/>
+                </a:solidFill>
+                <a:latin typeface="Calibri"/>
+              </a:rPr>
+              <a:t>One view of a place</a:t>
+            </a:r>
+          </a:p>
+        </p:txBody>
+      </p:sp>
+      <p:sp>
+        <p:nvSpPr>
+          <p:cNvPr id="15" name="TextBox 14"/>
+          <p:cNvSpPr txBox="1"/>
+          <p:nvPr/>
+        </p:nvSpPr>
+        <p:spPr>
+          <a:xfrm>
+            <a:off x="8092440" y="3648456"/>
+            <a:ext cx="3337560" cy="548640"/>
+          </a:xfrm>
+          <a:prstGeom prst="rect">
+            <a:avLst/>
+          </a:prstGeom>
+          <a:noFill/>
+        </p:spPr>
+        <p:txBody>
+          <a:bodyPr wrap="square" anchor="t" lIns="0" rIns="0" tIns="0" bIns="0">
+            <a:spAutoFit/>
+          </a:bodyPr>
+          <a:lstStyle/>
+          <a:p>
+            <a:pPr>
+              <a:spcAft>
+                <a:spcPts val="0"/>
+              </a:spcAft>
+            </a:pPr>
+            <a:r>
+              <a:rPr sz="1200" b="0">
+                <a:solidFill>
+                  <a:srgbClr val="CADCE0"/>
+                </a:solidFill>
+                <a:latin typeface="Calibri"/>
+              </a:rPr>
+              <a:t>Requests joined to demographics, infrastructure and investment plans</a:t>
+            </a:r>
+          </a:p>
+        </p:txBody>
+      </p:sp>
+      <p:sp>
+        <p:nvSpPr>
+          <p:cNvPr id="16" name="TextBox 15"/>
+          <p:cNvSpPr txBox="1"/>
+          <p:nvPr/>
+        </p:nvSpPr>
+        <p:spPr>
+          <a:xfrm>
+            <a:off x="8092440" y="4288536"/>
+            <a:ext cx="3337560" cy="274320"/>
+          </a:xfrm>
+          <a:prstGeom prst="rect">
+            <a:avLst/>
+          </a:prstGeom>
+          <a:noFill/>
+        </p:spPr>
+        <p:txBody>
+          <a:bodyPr wrap="square" anchor="t" lIns="0" rIns="0" tIns="0" bIns="0">
+            <a:spAutoFit/>
+          </a:bodyPr>
+          <a:lstStyle/>
+          <a:p>
+            <a:pPr>
+              <a:spcAft>
+                <a:spcPts val="0"/>
+              </a:spcAft>
+            </a:pPr>
+            <a:r>
+              <a:rPr sz="1400" b="1">
+                <a:solidFill>
+                  <a:srgbClr val="FFFFFF"/>
+                </a:solidFill>
+                <a:latin typeface="Calibri"/>
+              </a:rPr>
+              <a:t>Hotspots and priorities</a:t>
+            </a:r>
+          </a:p>
+        </p:txBody>
+      </p:sp>
+      <p:sp>
+        <p:nvSpPr>
+          <p:cNvPr id="17" name="TextBox 16"/>
+          <p:cNvSpPr txBox="1"/>
+          <p:nvPr/>
+        </p:nvSpPr>
+        <p:spPr>
+          <a:xfrm>
+            <a:off x="8092440" y="4581144"/>
+            <a:ext cx="3337560" cy="548640"/>
+          </a:xfrm>
+          <a:prstGeom prst="rect">
+            <a:avLst/>
+          </a:prstGeom>
+          <a:noFill/>
+        </p:spPr>
+        <p:txBody>
+          <a:bodyPr wrap="square" anchor="t" lIns="0" rIns="0" tIns="0" bIns="0">
+            <a:spAutoFit/>
+          </a:bodyPr>
+          <a:lstStyle/>
+          <a:p>
+            <a:pPr>
+              <a:spcAft>
+                <a:spcPts val="0"/>
+              </a:spcAft>
+            </a:pPr>
+            <a:r>
+              <a:rPr sz="1200" b="0">
+                <a:solidFill>
+                  <a:srgbClr val="CADCE0"/>
+                </a:solidFill>
+                <a:latin typeface="Calibri"/>
+              </a:rPr>
+              <a:t>Explainable scores for policymakers, each with cited facts</a:t>
+            </a:r>
+          </a:p>
+        </p:txBody>
+      </p:sp>
+      <p:sp>
+        <p:nvSpPr>
+          <p:cNvPr id="18" name="TextBox 17"/>
+          <p:cNvSpPr txBox="1"/>
+          <p:nvPr/>
+        </p:nvSpPr>
+        <p:spPr>
+          <a:xfrm>
+            <a:off x="8092440" y="5221223"/>
+            <a:ext cx="3337560" cy="274320"/>
+          </a:xfrm>
+          <a:prstGeom prst="rect">
+            <a:avLst/>
+          </a:prstGeom>
+          <a:noFill/>
+        </p:spPr>
+        <p:txBody>
+          <a:bodyPr wrap="square" anchor="t" lIns="0" rIns="0" tIns="0" bIns="0">
+            <a:spAutoFit/>
+          </a:bodyPr>
+          <a:lstStyle/>
+          <a:p>
+            <a:pPr>
+              <a:spcAft>
+                <a:spcPts val="0"/>
+              </a:spcAft>
+            </a:pPr>
+            <a:r>
+              <a:rPr sz="1400" b="1">
+                <a:solidFill>
+                  <a:srgbClr val="FFFFFF"/>
+                </a:solidFill>
+                <a:latin typeface="Calibri"/>
+              </a:rPr>
+              <a:t>Open by design</a:t>
+            </a:r>
+          </a:p>
+        </p:txBody>
+      </p:sp>
+      <p:sp>
+        <p:nvSpPr>
+          <p:cNvPr id="19" name="TextBox 18"/>
+          <p:cNvSpPr txBox="1"/>
+          <p:nvPr/>
+        </p:nvSpPr>
+        <p:spPr>
+          <a:xfrm>
+            <a:off x="8092440" y="5513831"/>
+            <a:ext cx="3337560" cy="548640"/>
+          </a:xfrm>
+          <a:prstGeom prst="rect">
+            <a:avLst/>
+          </a:prstGeom>
+          <a:noFill/>
+        </p:spPr>
+        <p:txBody>
+          <a:bodyPr wrap="square" anchor="t" lIns="0" rIns="0" tIns="0" bIns="0">
+            <a:spAutoFit/>
+          </a:bodyPr>
+          <a:lstStyle/>
+          <a:p>
+            <a:pPr>
+              <a:spcAft>
+                <a:spcPts val="0"/>
+              </a:spcAft>
+            </a:pPr>
+            <a:r>
+              <a:rPr sz="1200" b="0">
+                <a:solidFill>
+                  <a:srgbClr val="CADCE0"/>
+                </a:solidFill>
+                <a:latin typeface="Calibri"/>
+              </a:rPr>
+              <a:t>A Digital Public Good: open data, open code, privacy by default</a:t>
+            </a:r>
+          </a:p>
+        </p:txBody>
+      </p:sp>
+      <p:sp>
+        <p:nvSpPr>
+          <p:cNvPr id="20" name="TextBox 19"/>
+          <p:cNvSpPr txBox="1"/>
+          <p:nvPr/>
+        </p:nvSpPr>
+        <p:spPr>
+          <a:xfrm>
+            <a:off x="548640" y="6446520"/>
+            <a:ext cx="5486400" cy="274320"/>
+          </a:xfrm>
+          <a:prstGeom prst="rect">
+            <a:avLst/>
+          </a:prstGeom>
+          <a:noFill/>
+        </p:spPr>
+        <p:txBody>
+          <a:bodyPr wrap="square" anchor="t" lIns="0" rIns="0" tIns="0" bIns="0">
+            <a:spAutoFit/>
+          </a:bodyPr>
+          <a:lstStyle/>
+          <a:p>
+            <a:pPr>
+              <a:spcAft>
+                <a:spcPts val="0"/>
+              </a:spcAft>
+            </a:pPr>
+            <a:r>
+              <a:rPr sz="1000" b="0">
+                <a:solidFill>
+                  <a:srgbClr val="5B6B72"/>
+                </a:solidFill>
+                <a:latin typeface="Calibri"/>
+              </a:rPr>
+              <a:t>INFRA-AI  ·  Digital Public Good</a:t>
+            </a:r>
+          </a:p>
+        </p:txBody>
+      </p:sp>
+      <p:sp>
+        <p:nvSpPr>
+          <p:cNvPr id="21" name="TextBox 20"/>
+          <p:cNvSpPr txBox="1"/>
+          <p:nvPr/>
+        </p:nvSpPr>
+        <p:spPr>
+          <a:xfrm>
+            <a:off x="11091672" y="6446520"/>
+            <a:ext cx="548640" cy="274320"/>
+          </a:xfrm>
+          <a:prstGeom prst="rect">
+            <a:avLst/>
+          </a:prstGeom>
+          <a:noFill/>
+        </p:spPr>
+        <p:txBody>
+          <a:bodyPr wrap="square" anchor="t" lIns="0" rIns="0" tIns="0" bIns="0">
+            <a:spAutoFit/>
+          </a:bodyPr>
+          <a:lstStyle/>
+          <a:p>
+            <a:pPr algn="r">
+              <a:spcAft>
+                <a:spcPts val="0"/>
+              </a:spcAft>
+            </a:pPr>
+            <a:r>
+              <a:rPr sz="1000" b="0">
+                <a:solidFill>
+                  <a:srgbClr val="5B6B72"/>
+                </a:solidFill>
+                <a:latin typeface="Calibri"/>
+              </a:rPr>
+              <a:t>2</a:t>
+            </a:r>
           </a:p>
         </p:txBody>
       </p:sp>

</xml_diff>

<commit_message>
docs(pitch): add Team Predators opening slide
First slide names the team, the chosen problem statement and the four members; later slides renumbered 3-8.

Co-Authored-By: Claude Sonnet 5.5 <noreply@anthropic.com>
</commit_message>
<xml_diff>
--- a/docs/INFRA-AI-pitch.pptx
+++ b/docs/INFRA-AI-pitch.pptx
@@ -5,6 +5,7 @@
     <p:sldMasterId id="2147483648" r:id="rId1"/>
   </p:sldMasterIdLst>
   <p:sldIdLst>
+    <p:sldId id="263" r:id="rId14"/>
     <p:sldId id="256" r:id="rId2"/>
     <p:sldId id="262" r:id="rId13"/>
     <p:sldId id="257" r:id="rId3"/>
@@ -1899,6 +1900,833 @@
 </file>
 
 <file path=ppt/slides/slide2.xml><?xml version="1.0" encoding="utf-8"?>
+<p:sld xmlns:a="http://schemas.openxmlformats.org/drawingml/2006/main" xmlns:p="http://schemas.openxmlformats.org/presentationml/2006/main" xmlns:r="http://schemas.openxmlformats.org/officeDocument/2006/relationships">
+  <p:cSld>
+    <p:bg>
+      <p:bgPr>
+        <a:solidFill>
+          <a:srgbClr val="FFFFFF"/>
+        </a:solidFill>
+        <a:effectLst/>
+      </p:bgPr>
+    </p:bg>
+    <p:spTree>
+      <p:nvGrpSpPr>
+        <p:cNvPr id="1" name=""/>
+        <p:cNvGrpSpPr/>
+        <p:nvPr/>
+      </p:nvGrpSpPr>
+      <p:grpSpPr/>
+      <p:sp>
+        <p:nvSpPr>
+          <p:cNvPr id="2" name="TextBox 1"/>
+          <p:cNvSpPr txBox="1"/>
+          <p:nvPr/>
+        </p:nvSpPr>
+        <p:spPr>
+          <a:xfrm>
+            <a:off x="548640" y="365760"/>
+            <a:ext cx="11064240" cy="777240"/>
+          </a:xfrm>
+          <a:prstGeom prst="rect">
+            <a:avLst/>
+          </a:prstGeom>
+          <a:noFill/>
+        </p:spPr>
+        <p:txBody>
+          <a:bodyPr wrap="square" anchor="ctr" lIns="0" rIns="0" tIns="0" bIns="0">
+            <a:spAutoFit/>
+          </a:bodyPr>
+          <a:lstStyle/>
+          <a:p>
+            <a:pPr>
+              <a:spcAft>
+                <a:spcPts val="0"/>
+              </a:spcAft>
+            </a:pPr>
+            <a:r>
+              <a:rPr sz="3000" b="1">
+                <a:solidFill>
+                  <a:srgbClr val="14232B"/>
+                </a:solidFill>
+                <a:latin typeface="Cambria"/>
+              </a:rPr>
+              <a:t>Problem statement 01: AI for Digital Public Infrastructure &amp; Governance</a:t>
+            </a:r>
+          </a:p>
+        </p:txBody>
+      </p:sp>
+      <p:sp>
+        <p:nvSpPr>
+          <p:cNvPr id="3" name="TextBox 2"/>
+          <p:cNvSpPr txBox="1"/>
+          <p:nvPr/>
+        </p:nvSpPr>
+        <p:spPr>
+          <a:xfrm>
+            <a:off x="548640" y="1115568"/>
+            <a:ext cx="11064240" cy="365760"/>
+          </a:xfrm>
+          <a:prstGeom prst="rect">
+            <a:avLst/>
+          </a:prstGeom>
+          <a:noFill/>
+        </p:spPr>
+        <p:txBody>
+          <a:bodyPr wrap="square" anchor="ctr" lIns="0" rIns="0" tIns="0" bIns="0">
+            <a:spAutoFit/>
+          </a:bodyPr>
+          <a:lstStyle/>
+          <a:p>
+            <a:pPr>
+              <a:spcAft>
+                <a:spcPts val="0"/>
+              </a:spcAft>
+            </a:pPr>
+            <a:r>
+              <a:rPr sz="1500" b="0">
+                <a:solidFill>
+                  <a:srgbClr val="5B6B72"/>
+                </a:solidFill>
+                <a:latin typeface="Calibri"/>
+              </a:rPr>
+              <a:t>Build with AI: Code for Communities, Second Edition  ·  Theme: Innovation  ·  Our chosen problem</a:t>
+            </a:r>
+          </a:p>
+        </p:txBody>
+      </p:sp>
+      <p:sp>
+        <p:nvSpPr>
+          <p:cNvPr id="4" name="Rounded Rectangle 3"/>
+          <p:cNvSpPr/>
+          <p:nvPr/>
+        </p:nvSpPr>
+        <p:spPr>
+          <a:xfrm>
+            <a:off x="548640" y="1737360"/>
+            <a:ext cx="7040880" cy="1600200"/>
+          </a:xfrm>
+          <a:prstGeom prst="roundRect">
+            <a:avLst>
+              <a:gd name="adj" fmla="val 4000"/>
+            </a:avLst>
+          </a:prstGeom>
+          <a:solidFill>
+            <a:srgbClr val="EAF2F3"/>
+          </a:solidFill>
+          <a:ln>
+            <a:noFill/>
+          </a:ln>
+          <a:effectLst/>
+        </p:spPr>
+        <p:style>
+          <a:lnRef idx="1">
+            <a:schemeClr val="accent1"/>
+          </a:lnRef>
+          <a:fillRef idx="3">
+            <a:schemeClr val="accent1"/>
+          </a:fillRef>
+          <a:effectRef idx="2">
+            <a:schemeClr val="accent1"/>
+          </a:effectRef>
+          <a:fontRef idx="minor">
+            <a:schemeClr val="lt1"/>
+          </a:fontRef>
+        </p:style>
+        <p:txBody>
+          <a:bodyPr rtlCol="0" anchor="ctr"/>
+          <a:lstStyle/>
+          <a:p>
+            <a:pPr algn="ctr"/>
+          </a:p>
+        </p:txBody>
+      </p:sp>
+      <p:sp>
+        <p:nvSpPr>
+          <p:cNvPr id="5" name="TextBox 4"/>
+          <p:cNvSpPr txBox="1"/>
+          <p:nvPr/>
+        </p:nvSpPr>
+        <p:spPr>
+          <a:xfrm>
+            <a:off x="777240" y="1874519"/>
+            <a:ext cx="6583680" cy="274320"/>
+          </a:xfrm>
+          <a:prstGeom prst="rect">
+            <a:avLst/>
+          </a:prstGeom>
+          <a:noFill/>
+        </p:spPr>
+        <p:txBody>
+          <a:bodyPr wrap="square" anchor="t" lIns="0" rIns="0" tIns="0" bIns="0">
+            <a:spAutoFit/>
+          </a:bodyPr>
+          <a:lstStyle/>
+          <a:p>
+            <a:pPr>
+              <a:spcAft>
+                <a:spcPts val="0"/>
+              </a:spcAft>
+            </a:pPr>
+            <a:r>
+              <a:rPr sz="1200" b="1">
+                <a:solidFill>
+                  <a:srgbClr val="0B4F5C"/>
+                </a:solidFill>
+                <a:latin typeface="Calibri"/>
+              </a:rPr>
+              <a:t>THE PROBLEM</a:t>
+            </a:r>
+          </a:p>
+        </p:txBody>
+      </p:sp>
+      <p:sp>
+        <p:nvSpPr>
+          <p:cNvPr id="6" name="TextBox 5"/>
+          <p:cNvSpPr txBox="1"/>
+          <p:nvPr/>
+        </p:nvSpPr>
+        <p:spPr>
+          <a:xfrm>
+            <a:off x="777240" y="2194560"/>
+            <a:ext cx="6583680" cy="1097280"/>
+          </a:xfrm>
+          <a:prstGeom prst="rect">
+            <a:avLst/>
+          </a:prstGeom>
+          <a:noFill/>
+        </p:spPr>
+        <p:txBody>
+          <a:bodyPr wrap="square" anchor="t" lIns="0" rIns="0" tIns="0" bIns="0">
+            <a:spAutoFit/>
+          </a:bodyPr>
+          <a:lstStyle/>
+          <a:p>
+            <a:pPr>
+              <a:spcAft>
+                <a:spcPts val="0"/>
+              </a:spcAft>
+            </a:pPr>
+            <a:r>
+              <a:rPr sz="1400" b="0">
+                <a:solidFill>
+                  <a:srgbClr val="14232B"/>
+                </a:solidFill>
+                <a:latin typeface="Calibri"/>
+              </a:rPr>
+              <a:t>Governments across India struggle to consolidate citizen feedback and align it with national infrastructure priorities. Development requests live in fragmented systems, leading to misaligned public spending, unaddressed infrastructure gaps, and no way to measure the impact of large-scale digital public infrastructure initiatives.</a:t>
+            </a:r>
+          </a:p>
+        </p:txBody>
+      </p:sp>
+      <p:sp>
+        <p:nvSpPr>
+          <p:cNvPr id="7" name="Rounded Rectangle 6"/>
+          <p:cNvSpPr/>
+          <p:nvPr/>
+        </p:nvSpPr>
+        <p:spPr>
+          <a:xfrm>
+            <a:off x="548640" y="3520440"/>
+            <a:ext cx="7040880" cy="2651760"/>
+          </a:xfrm>
+          <a:prstGeom prst="roundRect">
+            <a:avLst>
+              <a:gd name="adj" fmla="val 4000"/>
+            </a:avLst>
+          </a:prstGeom>
+          <a:solidFill>
+            <a:srgbClr val="EAF2F3"/>
+          </a:solidFill>
+          <a:ln>
+            <a:noFill/>
+          </a:ln>
+          <a:effectLst/>
+        </p:spPr>
+        <p:style>
+          <a:lnRef idx="1">
+            <a:schemeClr val="accent1"/>
+          </a:lnRef>
+          <a:fillRef idx="3">
+            <a:schemeClr val="accent1"/>
+          </a:fillRef>
+          <a:effectRef idx="2">
+            <a:schemeClr val="accent1"/>
+          </a:effectRef>
+          <a:fontRef idx="minor">
+            <a:schemeClr val="lt1"/>
+          </a:fontRef>
+        </p:style>
+        <p:txBody>
+          <a:bodyPr rtlCol="0" anchor="ctr"/>
+          <a:lstStyle/>
+          <a:p>
+            <a:pPr algn="ctr"/>
+          </a:p>
+        </p:txBody>
+      </p:sp>
+      <p:sp>
+        <p:nvSpPr>
+          <p:cNvPr id="8" name="TextBox 7"/>
+          <p:cNvSpPr txBox="1"/>
+          <p:nvPr/>
+        </p:nvSpPr>
+        <p:spPr>
+          <a:xfrm>
+            <a:off x="777240" y="3657600"/>
+            <a:ext cx="6583680" cy="274320"/>
+          </a:xfrm>
+          <a:prstGeom prst="rect">
+            <a:avLst/>
+          </a:prstGeom>
+          <a:noFill/>
+        </p:spPr>
+        <p:txBody>
+          <a:bodyPr wrap="square" anchor="t" lIns="0" rIns="0" tIns="0" bIns="0">
+            <a:spAutoFit/>
+          </a:bodyPr>
+          <a:lstStyle/>
+          <a:p>
+            <a:pPr>
+              <a:spcAft>
+                <a:spcPts val="0"/>
+              </a:spcAft>
+            </a:pPr>
+            <a:r>
+              <a:rPr sz="1200" b="1">
+                <a:solidFill>
+                  <a:srgbClr val="0B4F5C"/>
+                </a:solidFill>
+                <a:latin typeface="Calibri"/>
+              </a:rPr>
+              <a:t>THE CHALLENGE</a:t>
+            </a:r>
+          </a:p>
+        </p:txBody>
+      </p:sp>
+      <p:sp>
+        <p:nvSpPr>
+          <p:cNvPr id="9" name="TextBox 8"/>
+          <p:cNvSpPr txBox="1"/>
+          <p:nvPr/>
+        </p:nvSpPr>
+        <p:spPr>
+          <a:xfrm>
+            <a:off x="777240" y="3977639"/>
+            <a:ext cx="6583680" cy="2103120"/>
+          </a:xfrm>
+          <a:prstGeom prst="rect">
+            <a:avLst/>
+          </a:prstGeom>
+          <a:noFill/>
+        </p:spPr>
+        <p:txBody>
+          <a:bodyPr wrap="square" anchor="t" lIns="0" rIns="0" tIns="0" bIns="0">
+            <a:spAutoFit/>
+          </a:bodyPr>
+          <a:lstStyle/>
+          <a:p>
+            <a:pPr>
+              <a:spcAft>
+                <a:spcPts val="0"/>
+              </a:spcAft>
+            </a:pPr>
+            <a:r>
+              <a:rPr sz="1400" b="0">
+                <a:solidFill>
+                  <a:srgbClr val="14232B"/>
+                </a:solidFill>
+                <a:latin typeface="Calibri"/>
+              </a:rPr>
+              <a:t>Build a scalable, multilingual AI platform, designed as a Digital Public Good, that aggregates citizen development requests via voice, text, and messaging apps across diverse linguistic regions of India. The system should analyse large datasets combining citizen feedback with national demographic data, infrastructure indices, and public investment plans, surfacing demand hotspots and recommending high-priority development projects to national policymakers.</a:t>
+            </a:r>
+          </a:p>
+        </p:txBody>
+      </p:sp>
+      <p:sp>
+        <p:nvSpPr>
+          <p:cNvPr id="10" name="Rounded Rectangle 9"/>
+          <p:cNvSpPr/>
+          <p:nvPr/>
+        </p:nvSpPr>
+        <p:spPr>
+          <a:xfrm>
+            <a:off x="7863840" y="1737360"/>
+            <a:ext cx="3776472" cy="4434840"/>
+          </a:xfrm>
+          <a:prstGeom prst="roundRect">
+            <a:avLst>
+              <a:gd name="adj" fmla="val 4000"/>
+            </a:avLst>
+          </a:prstGeom>
+          <a:solidFill>
+            <a:srgbClr val="0B4F5C"/>
+          </a:solidFill>
+          <a:ln>
+            <a:noFill/>
+          </a:ln>
+          <a:effectLst/>
+        </p:spPr>
+        <p:style>
+          <a:lnRef idx="1">
+            <a:schemeClr val="accent1"/>
+          </a:lnRef>
+          <a:fillRef idx="3">
+            <a:schemeClr val="accent1"/>
+          </a:fillRef>
+          <a:effectRef idx="2">
+            <a:schemeClr val="accent1"/>
+          </a:effectRef>
+          <a:fontRef idx="minor">
+            <a:schemeClr val="lt1"/>
+          </a:fontRef>
+        </p:style>
+        <p:txBody>
+          <a:bodyPr rtlCol="0" anchor="ctr"/>
+          <a:lstStyle/>
+          <a:p>
+            <a:pPr algn="ctr"/>
+          </a:p>
+        </p:txBody>
+      </p:sp>
+      <p:sp>
+        <p:nvSpPr>
+          <p:cNvPr id="11" name="TextBox 10"/>
+          <p:cNvSpPr txBox="1"/>
+          <p:nvPr/>
+        </p:nvSpPr>
+        <p:spPr>
+          <a:xfrm>
+            <a:off x="8092440" y="1874519"/>
+            <a:ext cx="3337560" cy="365760"/>
+          </a:xfrm>
+          <a:prstGeom prst="rect">
+            <a:avLst/>
+          </a:prstGeom>
+          <a:noFill/>
+        </p:spPr>
+        <p:txBody>
+          <a:bodyPr wrap="square" anchor="t" lIns="0" rIns="0" tIns="0" bIns="0">
+            <a:spAutoFit/>
+          </a:bodyPr>
+          <a:lstStyle/>
+          <a:p>
+            <a:pPr>
+              <a:spcAft>
+                <a:spcPts val="0"/>
+              </a:spcAft>
+            </a:pPr>
+            <a:r>
+              <a:rPr sz="1800" b="1">
+                <a:solidFill>
+                  <a:srgbClr val="FFFFFF"/>
+                </a:solidFill>
+                <a:latin typeface="Cambria"/>
+              </a:rPr>
+              <a:t>How INFRA-AI answers it</a:t>
+            </a:r>
+          </a:p>
+        </p:txBody>
+      </p:sp>
+      <p:sp>
+        <p:nvSpPr>
+          <p:cNvPr id="12" name="TextBox 11"/>
+          <p:cNvSpPr txBox="1"/>
+          <p:nvPr/>
+        </p:nvSpPr>
+        <p:spPr>
+          <a:xfrm>
+            <a:off x="8092440" y="2423160"/>
+            <a:ext cx="3337560" cy="274320"/>
+          </a:xfrm>
+          <a:prstGeom prst="rect">
+            <a:avLst/>
+          </a:prstGeom>
+          <a:noFill/>
+        </p:spPr>
+        <p:txBody>
+          <a:bodyPr wrap="square" anchor="t" lIns="0" rIns="0" tIns="0" bIns="0">
+            <a:spAutoFit/>
+          </a:bodyPr>
+          <a:lstStyle/>
+          <a:p>
+            <a:pPr>
+              <a:spcAft>
+                <a:spcPts val="0"/>
+              </a:spcAft>
+            </a:pPr>
+            <a:r>
+              <a:rPr sz="1400" b="1">
+                <a:solidFill>
+                  <a:srgbClr val="FFFFFF"/>
+                </a:solidFill>
+                <a:latin typeface="Calibri"/>
+              </a:rPr>
+              <a:t>Every request, every language</a:t>
+            </a:r>
+          </a:p>
+        </p:txBody>
+      </p:sp>
+      <p:sp>
+        <p:nvSpPr>
+          <p:cNvPr id="13" name="TextBox 12"/>
+          <p:cNvSpPr txBox="1"/>
+          <p:nvPr/>
+        </p:nvSpPr>
+        <p:spPr>
+          <a:xfrm>
+            <a:off x="8092440" y="2715768"/>
+            <a:ext cx="3337560" cy="548640"/>
+          </a:xfrm>
+          <a:prstGeom prst="rect">
+            <a:avLst/>
+          </a:prstGeom>
+          <a:noFill/>
+        </p:spPr>
+        <p:txBody>
+          <a:bodyPr wrap="square" anchor="t" lIns="0" rIns="0" tIns="0" bIns="0">
+            <a:spAutoFit/>
+          </a:bodyPr>
+          <a:lstStyle/>
+          <a:p>
+            <a:pPr>
+              <a:spcAft>
+                <a:spcPts val="0"/>
+              </a:spcAft>
+            </a:pPr>
+            <a:r>
+              <a:rPr sz="1200" b="0">
+                <a:solidFill>
+                  <a:srgbClr val="CADCE0"/>
+                </a:solidFill>
+                <a:latin typeface="Calibri"/>
+              </a:rPr>
+              <a:t>Voice, text and messaging intake in 22 languages</a:t>
+            </a:r>
+          </a:p>
+        </p:txBody>
+      </p:sp>
+      <p:sp>
+        <p:nvSpPr>
+          <p:cNvPr id="14" name="TextBox 13"/>
+          <p:cNvSpPr txBox="1"/>
+          <p:nvPr/>
+        </p:nvSpPr>
+        <p:spPr>
+          <a:xfrm>
+            <a:off x="8092440" y="3355848"/>
+            <a:ext cx="3337560" cy="274320"/>
+          </a:xfrm>
+          <a:prstGeom prst="rect">
+            <a:avLst/>
+          </a:prstGeom>
+          <a:noFill/>
+        </p:spPr>
+        <p:txBody>
+          <a:bodyPr wrap="square" anchor="t" lIns="0" rIns="0" tIns="0" bIns="0">
+            <a:spAutoFit/>
+          </a:bodyPr>
+          <a:lstStyle/>
+          <a:p>
+            <a:pPr>
+              <a:spcAft>
+                <a:spcPts val="0"/>
+              </a:spcAft>
+            </a:pPr>
+            <a:r>
+              <a:rPr sz="1400" b="1">
+                <a:solidFill>
+                  <a:srgbClr val="FFFFFF"/>
+                </a:solidFill>
+                <a:latin typeface="Calibri"/>
+              </a:rPr>
+              <a:t>One view of a place</a:t>
+            </a:r>
+          </a:p>
+        </p:txBody>
+      </p:sp>
+      <p:sp>
+        <p:nvSpPr>
+          <p:cNvPr id="15" name="TextBox 14"/>
+          <p:cNvSpPr txBox="1"/>
+          <p:nvPr/>
+        </p:nvSpPr>
+        <p:spPr>
+          <a:xfrm>
+            <a:off x="8092440" y="3648456"/>
+            <a:ext cx="3337560" cy="548640"/>
+          </a:xfrm>
+          <a:prstGeom prst="rect">
+            <a:avLst/>
+          </a:prstGeom>
+          <a:noFill/>
+        </p:spPr>
+        <p:txBody>
+          <a:bodyPr wrap="square" anchor="t" lIns="0" rIns="0" tIns="0" bIns="0">
+            <a:spAutoFit/>
+          </a:bodyPr>
+          <a:lstStyle/>
+          <a:p>
+            <a:pPr>
+              <a:spcAft>
+                <a:spcPts val="0"/>
+              </a:spcAft>
+            </a:pPr>
+            <a:r>
+              <a:rPr sz="1200" b="0">
+                <a:solidFill>
+                  <a:srgbClr val="CADCE0"/>
+                </a:solidFill>
+                <a:latin typeface="Calibri"/>
+              </a:rPr>
+              <a:t>Requests joined to demographics, infrastructure and investment plans</a:t>
+            </a:r>
+          </a:p>
+        </p:txBody>
+      </p:sp>
+      <p:sp>
+        <p:nvSpPr>
+          <p:cNvPr id="16" name="TextBox 15"/>
+          <p:cNvSpPr txBox="1"/>
+          <p:nvPr/>
+        </p:nvSpPr>
+        <p:spPr>
+          <a:xfrm>
+            <a:off x="8092440" y="4288536"/>
+            <a:ext cx="3337560" cy="274320"/>
+          </a:xfrm>
+          <a:prstGeom prst="rect">
+            <a:avLst/>
+          </a:prstGeom>
+          <a:noFill/>
+        </p:spPr>
+        <p:txBody>
+          <a:bodyPr wrap="square" anchor="t" lIns="0" rIns="0" tIns="0" bIns="0">
+            <a:spAutoFit/>
+          </a:bodyPr>
+          <a:lstStyle/>
+          <a:p>
+            <a:pPr>
+              <a:spcAft>
+                <a:spcPts val="0"/>
+              </a:spcAft>
+            </a:pPr>
+            <a:r>
+              <a:rPr sz="1400" b="1">
+                <a:solidFill>
+                  <a:srgbClr val="FFFFFF"/>
+                </a:solidFill>
+                <a:latin typeface="Calibri"/>
+              </a:rPr>
+              <a:t>Hotspots and priorities</a:t>
+            </a:r>
+          </a:p>
+        </p:txBody>
+      </p:sp>
+      <p:sp>
+        <p:nvSpPr>
+          <p:cNvPr id="17" name="TextBox 16"/>
+          <p:cNvSpPr txBox="1"/>
+          <p:nvPr/>
+        </p:nvSpPr>
+        <p:spPr>
+          <a:xfrm>
+            <a:off x="8092440" y="4581144"/>
+            <a:ext cx="3337560" cy="548640"/>
+          </a:xfrm>
+          <a:prstGeom prst="rect">
+            <a:avLst/>
+          </a:prstGeom>
+          <a:noFill/>
+        </p:spPr>
+        <p:txBody>
+          <a:bodyPr wrap="square" anchor="t" lIns="0" rIns="0" tIns="0" bIns="0">
+            <a:spAutoFit/>
+          </a:bodyPr>
+          <a:lstStyle/>
+          <a:p>
+            <a:pPr>
+              <a:spcAft>
+                <a:spcPts val="0"/>
+              </a:spcAft>
+            </a:pPr>
+            <a:r>
+              <a:rPr sz="1200" b="0">
+                <a:solidFill>
+                  <a:srgbClr val="CADCE0"/>
+                </a:solidFill>
+                <a:latin typeface="Calibri"/>
+              </a:rPr>
+              <a:t>Explainable scores for policymakers, each with cited facts</a:t>
+            </a:r>
+          </a:p>
+        </p:txBody>
+      </p:sp>
+      <p:sp>
+        <p:nvSpPr>
+          <p:cNvPr id="18" name="TextBox 17"/>
+          <p:cNvSpPr txBox="1"/>
+          <p:nvPr/>
+        </p:nvSpPr>
+        <p:spPr>
+          <a:xfrm>
+            <a:off x="8092440" y="5221223"/>
+            <a:ext cx="3337560" cy="274320"/>
+          </a:xfrm>
+          <a:prstGeom prst="rect">
+            <a:avLst/>
+          </a:prstGeom>
+          <a:noFill/>
+        </p:spPr>
+        <p:txBody>
+          <a:bodyPr wrap="square" anchor="t" lIns="0" rIns="0" tIns="0" bIns="0">
+            <a:spAutoFit/>
+          </a:bodyPr>
+          <a:lstStyle/>
+          <a:p>
+            <a:pPr>
+              <a:spcAft>
+                <a:spcPts val="0"/>
+              </a:spcAft>
+            </a:pPr>
+            <a:r>
+              <a:rPr sz="1400" b="1">
+                <a:solidFill>
+                  <a:srgbClr val="FFFFFF"/>
+                </a:solidFill>
+                <a:latin typeface="Calibri"/>
+              </a:rPr>
+              <a:t>Open by design</a:t>
+            </a:r>
+          </a:p>
+        </p:txBody>
+      </p:sp>
+      <p:sp>
+        <p:nvSpPr>
+          <p:cNvPr id="19" name="TextBox 18"/>
+          <p:cNvSpPr txBox="1"/>
+          <p:nvPr/>
+        </p:nvSpPr>
+        <p:spPr>
+          <a:xfrm>
+            <a:off x="8092440" y="5513831"/>
+            <a:ext cx="3337560" cy="548640"/>
+          </a:xfrm>
+          <a:prstGeom prst="rect">
+            <a:avLst/>
+          </a:prstGeom>
+          <a:noFill/>
+        </p:spPr>
+        <p:txBody>
+          <a:bodyPr wrap="square" anchor="t" lIns="0" rIns="0" tIns="0" bIns="0">
+            <a:spAutoFit/>
+          </a:bodyPr>
+          <a:lstStyle/>
+          <a:p>
+            <a:pPr>
+              <a:spcAft>
+                <a:spcPts val="0"/>
+              </a:spcAft>
+            </a:pPr>
+            <a:r>
+              <a:rPr sz="1200" b="0">
+                <a:solidFill>
+                  <a:srgbClr val="CADCE0"/>
+                </a:solidFill>
+                <a:latin typeface="Calibri"/>
+              </a:rPr>
+              <a:t>A Digital Public Good: open data, open code, privacy by default</a:t>
+            </a:r>
+          </a:p>
+        </p:txBody>
+      </p:sp>
+      <p:sp>
+        <p:nvSpPr>
+          <p:cNvPr id="20" name="TextBox 19"/>
+          <p:cNvSpPr txBox="1"/>
+          <p:nvPr/>
+        </p:nvSpPr>
+        <p:spPr>
+          <a:xfrm>
+            <a:off x="548640" y="6446520"/>
+            <a:ext cx="5486400" cy="274320"/>
+          </a:xfrm>
+          <a:prstGeom prst="rect">
+            <a:avLst/>
+          </a:prstGeom>
+          <a:noFill/>
+        </p:spPr>
+        <p:txBody>
+          <a:bodyPr wrap="square" anchor="t" lIns="0" rIns="0" tIns="0" bIns="0">
+            <a:spAutoFit/>
+          </a:bodyPr>
+          <a:lstStyle/>
+          <a:p>
+            <a:pPr>
+              <a:spcAft>
+                <a:spcPts val="0"/>
+              </a:spcAft>
+            </a:pPr>
+            <a:r>
+              <a:rPr sz="1000" b="0">
+                <a:solidFill>
+                  <a:srgbClr val="5B6B72"/>
+                </a:solidFill>
+                <a:latin typeface="Calibri"/>
+              </a:rPr>
+              <a:t>INFRA-AI  ·  Digital Public Good</a:t>
+            </a:r>
+          </a:p>
+        </p:txBody>
+      </p:sp>
+      <p:sp>
+        <p:nvSpPr>
+          <p:cNvPr id="21" name="TextBox 20"/>
+          <p:cNvSpPr txBox="1"/>
+          <p:nvPr/>
+        </p:nvSpPr>
+        <p:spPr>
+          <a:xfrm>
+            <a:off x="11091672" y="6446520"/>
+            <a:ext cx="548640" cy="274320"/>
+          </a:xfrm>
+          <a:prstGeom prst="rect">
+            <a:avLst/>
+          </a:prstGeom>
+          <a:noFill/>
+        </p:spPr>
+        <p:txBody>
+          <a:bodyPr wrap="square" anchor="t" lIns="0" rIns="0" tIns="0" bIns="0">
+            <a:spAutoFit/>
+          </a:bodyPr>
+          <a:lstStyle/>
+          <a:p>
+            <a:pPr algn="r">
+              <a:spcAft>
+                <a:spcPts val="0"/>
+              </a:spcAft>
+            </a:pPr>
+            <a:r>
+              <a:rPr sz="1000" b="0">
+                <a:solidFill>
+                  <a:srgbClr val="5B6B72"/>
+                </a:solidFill>
+                <a:latin typeface="Calibri"/>
+              </a:rPr>
+              <a:t>3</a:t>
+            </a:r>
+          </a:p>
+        </p:txBody>
+      </p:sp>
+    </p:spTree>
+  </p:cSld>
+  <p:clrMapOvr>
+    <a:masterClrMapping/>
+  </p:clrMapOvr>
+</p:sld>
+</file>
+
+<file path=ppt/slides/slide3.xml><?xml version="1.0" encoding="utf-8"?>
 <p:sld xmlns:a="http://schemas.openxmlformats.org/drawingml/2006/main" xmlns:r="http://schemas.openxmlformats.org/officeDocument/2006/relationships" xmlns:p="http://schemas.openxmlformats.org/presentationml/2006/main">
   <p:cSld name="Slide 2">
     <p:bg>
@@ -3270,7 +4098,7 @@
                 <a:ea typeface="Calibri" pitchFamily="34" charset="-122"/>
                 <a:cs typeface="Calibri" pitchFamily="34" charset="-120"/>
               </a:rPr>
-              <a:t>3</a:t>
+              <a:t>4</a:t>
             </a:r>
             <a:endParaRPr lang="en-US" sz="1000" dirty="0"/>
           </a:p>
@@ -3284,7 +4112,7 @@
 </p:sld>
 </file>
 
-<file path=ppt/slides/slide3.xml><?xml version="1.0" encoding="utf-8"?>
+<file path=ppt/slides/slide4.xml><?xml version="1.0" encoding="utf-8"?>
 <p:sld xmlns:a="http://schemas.openxmlformats.org/drawingml/2006/main" xmlns:r="http://schemas.openxmlformats.org/officeDocument/2006/relationships" xmlns:p="http://schemas.openxmlformats.org/presentationml/2006/main">
   <p:cSld name="Slide 3">
     <p:bg>
@@ -4948,7 +5776,7 @@
                 <a:ea typeface="Calibri" pitchFamily="34" charset="-122"/>
                 <a:cs typeface="Calibri" pitchFamily="34" charset="-120"/>
               </a:rPr>
-              <a:t>4</a:t>
+              <a:t>5</a:t>
             </a:r>
             <a:endParaRPr lang="en-US" sz="1000" dirty="0"/>
           </a:p>
@@ -4962,7 +5790,7 @@
 </p:sld>
 </file>
 
-<file path=ppt/slides/slide4.xml><?xml version="1.0" encoding="utf-8"?>
+<file path=ppt/slides/slide5.xml><?xml version="1.0" encoding="utf-8"?>
 <p:sld xmlns:a="http://schemas.openxmlformats.org/drawingml/2006/main" xmlns:r="http://schemas.openxmlformats.org/officeDocument/2006/relationships" xmlns:p="http://schemas.openxmlformats.org/presentationml/2006/main">
   <p:cSld name="Slide 4">
     <p:bg>
@@ -5607,7 +6435,7 @@
                 <a:ea typeface="Calibri" pitchFamily="34" charset="-122"/>
                 <a:cs typeface="Calibri" pitchFamily="34" charset="-120"/>
               </a:rPr>
-              <a:t>5</a:t>
+              <a:t>6</a:t>
             </a:r>
             <a:endParaRPr lang="en-US" sz="1000" dirty="0"/>
           </a:p>
@@ -5621,7 +6449,7 @@
 </p:sld>
 </file>
 
-<file path=ppt/slides/slide5.xml><?xml version="1.0" encoding="utf-8"?>
+<file path=ppt/slides/slide6.xml><?xml version="1.0" encoding="utf-8"?>
 <p:sld xmlns:a="http://schemas.openxmlformats.org/drawingml/2006/main" xmlns:r="http://schemas.openxmlformats.org/officeDocument/2006/relationships" xmlns:p="http://schemas.openxmlformats.org/presentationml/2006/main">
   <p:cSld name="Slide 5">
     <p:bg>
@@ -6703,7 +7531,7 @@
                 <a:ea typeface="Calibri" pitchFamily="34" charset="-122"/>
                 <a:cs typeface="Calibri" pitchFamily="34" charset="-120"/>
               </a:rPr>
-              <a:t>6</a:t>
+              <a:t>7</a:t>
             </a:r>
             <a:endParaRPr lang="en-US" sz="1000" dirty="0"/>
           </a:p>
@@ -6717,7 +7545,7 @@
 </p:sld>
 </file>
 
-<file path=ppt/slides/slide6.xml><?xml version="1.0" encoding="utf-8"?>
+<file path=ppt/slides/slide7.xml><?xml version="1.0" encoding="utf-8"?>
 <p:sld xmlns:a="http://schemas.openxmlformats.org/drawingml/2006/main" xmlns:r="http://schemas.openxmlformats.org/officeDocument/2006/relationships" xmlns:p="http://schemas.openxmlformats.org/presentationml/2006/main">
   <p:cSld name="Slide 6">
     <p:bg>
@@ -7888,7 +8716,7 @@
                 <a:ea typeface="Calibri" pitchFamily="34" charset="-122"/>
                 <a:cs typeface="Calibri" pitchFamily="34" charset="-120"/>
               </a:rPr>
-              <a:t>7</a:t>
+              <a:t>8</a:t>
             </a:r>
             <a:endParaRPr lang="en-US" sz="1000" dirty="0"/>
           </a:p>
@@ -7902,13 +8730,13 @@
 </p:sld>
 </file>
 
-<file path=ppt/slides/slide7.xml><?xml version="1.0" encoding="utf-8"?>
+<file path=ppt/slides/slide8.xml><?xml version="1.0" encoding="utf-8"?>
 <p:sld xmlns:a="http://schemas.openxmlformats.org/drawingml/2006/main" xmlns:p="http://schemas.openxmlformats.org/presentationml/2006/main" xmlns:r="http://schemas.openxmlformats.org/officeDocument/2006/relationships">
   <p:cSld>
     <p:bg>
       <p:bgPr>
         <a:solidFill>
-          <a:srgbClr val="FFFFFF"/>
+          <a:srgbClr val="072C34"/>
         </a:solidFill>
         <a:effectLst/>
       </p:bgPr>
@@ -7928,33 +8756,28 @@
         </p:nvSpPr>
         <p:spPr>
           <a:xfrm>
-            <a:off x="548640" y="365760"/>
-            <a:ext cx="11064240" cy="777240"/>
-          </a:xfrm>
-          <a:prstGeom prst="rect">
-            <a:avLst/>
-          </a:prstGeom>
-          <a:noFill/>
-        </p:spPr>
-        <p:txBody>
-          <a:bodyPr wrap="square" anchor="ctr" lIns="0" rIns="0" tIns="0" bIns="0">
+            <a:off x="548640" y="640080"/>
+            <a:ext cx="5120640" cy="320040"/>
+          </a:xfrm>
+          <a:prstGeom prst="rect">
+            <a:avLst/>
+          </a:prstGeom>
+          <a:noFill/>
+        </p:spPr>
+        <p:txBody>
+          <a:bodyPr wrap="square" anchor="t" lIns="0" rIns="0" tIns="0" bIns="0">
             <a:spAutoFit/>
           </a:bodyPr>
           <a:lstStyle/>
           <a:p>
-            <a:pPr>
-              <a:spcAft>
-                <a:spcPts val="0"/>
-              </a:spcAft>
-            </a:pPr>
-            <a:r>
-              <a:rPr sz="3000" b="1">
-                <a:solidFill>
-                  <a:srgbClr val="14232B"/>
-                </a:solidFill>
-                <a:latin typeface="Cambria"/>
-              </a:rPr>
-              <a:t>Problem statement 01: AI for Digital Public Infrastructure &amp; Governance</a:t>
+            <a:r>
+              <a:rPr sz="1200" b="1" spc="100">
+                <a:solidFill>
+                  <a:srgbClr val="E08A1E"/>
+                </a:solidFill>
+                <a:latin typeface="Calibri"/>
+              </a:rPr>
+              <a:t>BUILD WITH AI: CODE FOR COMMUNITIES  ·  SECOND EDITION</a:t>
             </a:r>
           </a:p>
         </p:txBody>
@@ -7967,55 +8790,152 @@
         </p:nvSpPr>
         <p:spPr>
           <a:xfrm>
-            <a:off x="548640" y="1115568"/>
-            <a:ext cx="11064240" cy="365760"/>
-          </a:xfrm>
-          <a:prstGeom prst="rect">
-            <a:avLst/>
-          </a:prstGeom>
-          <a:noFill/>
-        </p:spPr>
-        <p:txBody>
-          <a:bodyPr wrap="square" anchor="ctr" lIns="0" rIns="0" tIns="0" bIns="0">
+            <a:off x="548640" y="1188720"/>
+            <a:ext cx="5120640" cy="1097280"/>
+          </a:xfrm>
+          <a:prstGeom prst="rect">
+            <a:avLst/>
+          </a:prstGeom>
+          <a:noFill/>
+        </p:spPr>
+        <p:txBody>
+          <a:bodyPr wrap="square" anchor="t" lIns="0" rIns="0" tIns="0" bIns="0">
             <a:spAutoFit/>
           </a:bodyPr>
           <a:lstStyle/>
           <a:p>
-            <a:pPr>
-              <a:spcAft>
-                <a:spcPts val="0"/>
-              </a:spcAft>
-            </a:pPr>
-            <a:r>
-              <a:rPr sz="1500" b="0">
-                <a:solidFill>
-                  <a:srgbClr val="5B6B72"/>
+            <a:r>
+              <a:rPr sz="4800" b="1">
+                <a:solidFill>
+                  <a:srgbClr val="FFFFFF"/>
+                </a:solidFill>
+                <a:latin typeface="Cambria"/>
+              </a:rPr>
+              <a:t>Team Predators</a:t>
+            </a:r>
+          </a:p>
+        </p:txBody>
+      </p:sp>
+      <p:sp>
+        <p:nvSpPr>
+          <p:cNvPr id="4" name="TextBox 3"/>
+          <p:cNvSpPr txBox="1"/>
+          <p:nvPr/>
+        </p:nvSpPr>
+        <p:spPr>
+          <a:xfrm>
+            <a:off x="548640" y="2514600"/>
+            <a:ext cx="5120640" cy="1280160"/>
+          </a:xfrm>
+          <a:prstGeom prst="rect">
+            <a:avLst/>
+          </a:prstGeom>
+          <a:noFill/>
+        </p:spPr>
+        <p:txBody>
+          <a:bodyPr wrap="square" anchor="t" lIns="0" rIns="0" tIns="0" bIns="0">
+            <a:spAutoFit/>
+          </a:bodyPr>
+          <a:lstStyle/>
+          <a:p>
+            <a:r>
+              <a:rPr sz="2000" b="0">
+                <a:solidFill>
+                  <a:srgbClr val="CFE3E6"/>
                 </a:solidFill>
                 <a:latin typeface="Calibri"/>
               </a:rPr>
-              <a:t>Build with AI: Code for Communities, Second Edition  ·  Theme: Innovation  ·  Our chosen problem</a:t>
-            </a:r>
-          </a:p>
-        </p:txBody>
-      </p:sp>
-      <p:sp>
-        <p:nvSpPr>
-          <p:cNvPr id="4" name="Rounded Rectangle 3"/>
+              <a:t>Problem statement 01: AI for Digital Public Infrastructure &amp; Governance</a:t>
+            </a:r>
+          </a:p>
+        </p:txBody>
+      </p:sp>
+      <p:sp>
+        <p:nvSpPr>
+          <p:cNvPr id="5" name="TextBox 4"/>
+          <p:cNvSpPr txBox="1"/>
+          <p:nvPr/>
+        </p:nvSpPr>
+        <p:spPr>
+          <a:xfrm>
+            <a:off x="548640" y="4206240"/>
+            <a:ext cx="5120640" cy="457200"/>
+          </a:xfrm>
+          <a:prstGeom prst="rect">
+            <a:avLst/>
+          </a:prstGeom>
+          <a:noFill/>
+        </p:spPr>
+        <p:txBody>
+          <a:bodyPr wrap="square" anchor="t" lIns="0" rIns="0" tIns="0" bIns="0">
+            <a:spAutoFit/>
+          </a:bodyPr>
+          <a:lstStyle/>
+          <a:p>
+            <a:r>
+              <a:rPr sz="1800" b="1">
+                <a:solidFill>
+                  <a:srgbClr val="FFFFFF"/>
+                </a:solidFill>
+                <a:latin typeface="Cambria"/>
+              </a:rPr>
+              <a:t>Our solution: INFRA-AI</a:t>
+            </a:r>
+          </a:p>
+        </p:txBody>
+      </p:sp>
+      <p:sp>
+        <p:nvSpPr>
+          <p:cNvPr id="6" name="TextBox 5"/>
+          <p:cNvSpPr txBox="1"/>
+          <p:nvPr/>
+        </p:nvSpPr>
+        <p:spPr>
+          <a:xfrm>
+            <a:off x="548640" y="4617720"/>
+            <a:ext cx="5120640" cy="731520"/>
+          </a:xfrm>
+          <a:prstGeom prst="rect">
+            <a:avLst/>
+          </a:prstGeom>
+          <a:noFill/>
+        </p:spPr>
+        <p:txBody>
+          <a:bodyPr wrap="square" anchor="t" lIns="0" rIns="0" tIns="0" bIns="0">
+            <a:spAutoFit/>
+          </a:bodyPr>
+          <a:lstStyle/>
+          <a:p>
+            <a:r>
+              <a:rPr sz="1400" b="0">
+                <a:solidFill>
+                  <a:srgbClr val="CFE3E6"/>
+                </a:solidFill>
+                <a:latin typeface="Calibri"/>
+              </a:rPr>
+              <a:t>A multilingual, location-first infrastructure intelligence platform for India, built as a Digital Public Good.</a:t>
+            </a:r>
+          </a:p>
+        </p:txBody>
+      </p:sp>
+      <p:sp>
+        <p:nvSpPr>
+          <p:cNvPr id="7" name="Rounded Rectangle 6"/>
           <p:cNvSpPr/>
           <p:nvPr/>
         </p:nvSpPr>
         <p:spPr>
           <a:xfrm>
-            <a:off x="548640" y="1737360"/>
-            <a:ext cx="7040880" cy="1600200"/>
+            <a:off x="6062472" y="1554480"/>
+            <a:ext cx="2697480" cy="2103120"/>
           </a:xfrm>
           <a:prstGeom prst="roundRect">
             <a:avLst>
-              <a:gd name="adj" fmla="val 4000"/>
+              <a:gd name="adj" fmla="val 5000"/>
             </a:avLst>
           </a:prstGeom>
           <a:solidFill>
-            <a:srgbClr val="EAF2F3"/>
+            <a:srgbClr val="0B4F5C"/>
           </a:solidFill>
           <a:ln>
             <a:noFill/>
@@ -8046,100 +8966,20 @@
       </p:sp>
       <p:sp>
         <p:nvSpPr>
-          <p:cNvPr id="5" name="TextBox 4"/>
-          <p:cNvSpPr txBox="1"/>
-          <p:nvPr/>
-        </p:nvSpPr>
-        <p:spPr>
-          <a:xfrm>
-            <a:off x="777240" y="1874519"/>
-            <a:ext cx="6583680" cy="274320"/>
-          </a:xfrm>
-          <a:prstGeom prst="rect">
-            <a:avLst/>
-          </a:prstGeom>
-          <a:noFill/>
-        </p:spPr>
-        <p:txBody>
-          <a:bodyPr wrap="square" anchor="t" lIns="0" rIns="0" tIns="0" bIns="0">
-            <a:spAutoFit/>
-          </a:bodyPr>
-          <a:lstStyle/>
-          <a:p>
-            <a:pPr>
-              <a:spcAft>
-                <a:spcPts val="0"/>
-              </a:spcAft>
-            </a:pPr>
-            <a:r>
-              <a:rPr sz="1200" b="1">
-                <a:solidFill>
-                  <a:srgbClr val="0B4F5C"/>
-                </a:solidFill>
-                <a:latin typeface="Calibri"/>
-              </a:rPr>
-              <a:t>THE PROBLEM</a:t>
-            </a:r>
-          </a:p>
-        </p:txBody>
-      </p:sp>
-      <p:sp>
-        <p:nvSpPr>
-          <p:cNvPr id="6" name="TextBox 5"/>
-          <p:cNvSpPr txBox="1"/>
-          <p:nvPr/>
-        </p:nvSpPr>
-        <p:spPr>
-          <a:xfrm>
-            <a:off x="777240" y="2194560"/>
-            <a:ext cx="6583680" cy="1097280"/>
-          </a:xfrm>
-          <a:prstGeom prst="rect">
-            <a:avLst/>
-          </a:prstGeom>
-          <a:noFill/>
-        </p:spPr>
-        <p:txBody>
-          <a:bodyPr wrap="square" anchor="t" lIns="0" rIns="0" tIns="0" bIns="0">
-            <a:spAutoFit/>
-          </a:bodyPr>
-          <a:lstStyle/>
-          <a:p>
-            <a:pPr>
-              <a:spcAft>
-                <a:spcPts val="0"/>
-              </a:spcAft>
-            </a:pPr>
-            <a:r>
-              <a:rPr sz="1400" b="0">
-                <a:solidFill>
-                  <a:srgbClr val="14232B"/>
-                </a:solidFill>
-                <a:latin typeface="Calibri"/>
-              </a:rPr>
-              <a:t>Governments across India struggle to consolidate citizen feedback and align it with national infrastructure priorities. Development requests live in fragmented systems, leading to misaligned public spending, unaddressed infrastructure gaps, and no way to measure the impact of large-scale digital public infrastructure initiatives.</a:t>
-            </a:r>
-          </a:p>
-        </p:txBody>
-      </p:sp>
-      <p:sp>
-        <p:nvSpPr>
-          <p:cNvPr id="7" name="Rounded Rectangle 6"/>
+          <p:cNvPr id="8" name="Oval 7"/>
           <p:cNvSpPr/>
           <p:nvPr/>
         </p:nvSpPr>
         <p:spPr>
           <a:xfrm>
-            <a:off x="548640" y="3520440"/>
-            <a:ext cx="7040880" cy="2651760"/>
-          </a:xfrm>
-          <a:prstGeom prst="roundRect">
-            <a:avLst>
-              <a:gd name="adj" fmla="val 4000"/>
-            </a:avLst>
+            <a:off x="6291072" y="1783080"/>
+            <a:ext cx="640080" cy="640080"/>
+          </a:xfrm>
+          <a:prstGeom prst="ellipse">
+            <a:avLst/>
           </a:prstGeom>
           <a:solidFill>
-            <a:srgbClr val="EAF2F3"/>
+            <a:srgbClr val="E08A1E"/>
           </a:solidFill>
           <a:ln>
             <a:noFill/>
@@ -8170,14 +9010,49 @@
       </p:sp>
       <p:sp>
         <p:nvSpPr>
-          <p:cNvPr id="8" name="TextBox 7"/>
-          <p:cNvSpPr txBox="1"/>
-          <p:nvPr/>
-        </p:nvSpPr>
-        <p:spPr>
-          <a:xfrm>
-            <a:off x="777240" y="3657600"/>
-            <a:ext cx="6583680" cy="274320"/>
+          <p:cNvPr id="9" name="TextBox 8"/>
+          <p:cNvSpPr txBox="1"/>
+          <p:nvPr/>
+        </p:nvSpPr>
+        <p:spPr>
+          <a:xfrm>
+            <a:off x="6291072" y="1783080"/>
+            <a:ext cx="640080" cy="640080"/>
+          </a:xfrm>
+          <a:prstGeom prst="rect">
+            <a:avLst/>
+          </a:prstGeom>
+          <a:noFill/>
+        </p:spPr>
+        <p:txBody>
+          <a:bodyPr wrap="square" anchor="ctr" lIns="0" rIns="0" tIns="0" bIns="0">
+            <a:spAutoFit/>
+          </a:bodyPr>
+          <a:lstStyle/>
+          <a:p>
+            <a:pPr algn="ctr"/>
+            <a:r>
+              <a:rPr sz="1600" b="1">
+                <a:solidFill>
+                  <a:srgbClr val="072C34"/>
+                </a:solidFill>
+                <a:latin typeface="Calibri"/>
+              </a:rPr>
+              <a:t>PS</a:t>
+            </a:r>
+          </a:p>
+        </p:txBody>
+      </p:sp>
+      <p:sp>
+        <p:nvSpPr>
+          <p:cNvPr id="10" name="TextBox 9"/>
+          <p:cNvSpPr txBox="1"/>
+          <p:nvPr/>
+        </p:nvSpPr>
+        <p:spPr>
+          <a:xfrm>
+            <a:off x="6291072" y="2606039"/>
+            <a:ext cx="2331720" cy="320040"/>
           </a:xfrm>
           <a:prstGeom prst="rect">
             <a:avLst/>
@@ -8190,33 +9065,28 @@
           </a:bodyPr>
           <a:lstStyle/>
           <a:p>
-            <a:pPr>
-              <a:spcAft>
-                <a:spcPts val="0"/>
-              </a:spcAft>
-            </a:pPr>
-            <a:r>
-              <a:rPr sz="1200" b="1">
-                <a:solidFill>
-                  <a:srgbClr val="0B4F5C"/>
+            <a:r>
+              <a:rPr sz="1700" b="1">
+                <a:solidFill>
+                  <a:srgbClr val="FFFFFF"/>
                 </a:solidFill>
                 <a:latin typeface="Calibri"/>
               </a:rPr>
-              <a:t>THE CHALLENGE</a:t>
-            </a:r>
-          </a:p>
-        </p:txBody>
-      </p:sp>
-      <p:sp>
-        <p:nvSpPr>
-          <p:cNvPr id="9" name="TextBox 8"/>
-          <p:cNvSpPr txBox="1"/>
-          <p:nvPr/>
-        </p:nvSpPr>
-        <p:spPr>
-          <a:xfrm>
-            <a:off x="777240" y="3977639"/>
-            <a:ext cx="6583680" cy="2103120"/>
+              <a:t>Punya Surana</a:t>
+            </a:r>
+          </a:p>
+        </p:txBody>
+      </p:sp>
+      <p:sp>
+        <p:nvSpPr>
+          <p:cNvPr id="11" name="TextBox 10"/>
+          <p:cNvSpPr txBox="1"/>
+          <p:nvPr/>
+        </p:nvSpPr>
+        <p:spPr>
+          <a:xfrm>
+            <a:off x="6291072" y="2944368"/>
+            <a:ext cx="2331720" cy="274320"/>
           </a:xfrm>
           <a:prstGeom prst="rect">
             <a:avLst/>
@@ -8229,37 +9099,66 @@
           </a:bodyPr>
           <a:lstStyle/>
           <a:p>
-            <a:pPr>
-              <a:spcAft>
-                <a:spcPts val="0"/>
-              </a:spcAft>
-            </a:pPr>
-            <a:r>
-              <a:rPr sz="1400" b="0">
-                <a:solidFill>
-                  <a:srgbClr val="14232B"/>
+            <a:r>
+              <a:rPr sz="1100" b="1">
+                <a:solidFill>
+                  <a:srgbClr val="E08A1E"/>
                 </a:solidFill>
                 <a:latin typeface="Calibri"/>
               </a:rPr>
-              <a:t>Build a scalable, multilingual AI platform, designed as a Digital Public Good, that aggregates citizen development requests via voice, text, and messaging apps across diverse linguistic regions of India. The system should analyse large datasets combining citizen feedback with national demographic data, infrastructure indices, and public investment plans, surfacing demand hotspots and recommending high-priority development projects to national policymakers.</a:t>
-            </a:r>
-          </a:p>
-        </p:txBody>
-      </p:sp>
-      <p:sp>
-        <p:nvSpPr>
-          <p:cNvPr id="10" name="Rounded Rectangle 9"/>
+              <a:t>Team Leader</a:t>
+            </a:r>
+          </a:p>
+        </p:txBody>
+      </p:sp>
+      <p:sp>
+        <p:nvSpPr>
+          <p:cNvPr id="12" name="TextBox 11"/>
+          <p:cNvSpPr txBox="1"/>
+          <p:nvPr/>
+        </p:nvSpPr>
+        <p:spPr>
+          <a:xfrm>
+            <a:off x="6291072" y="3246120"/>
+            <a:ext cx="2331720" cy="274320"/>
+          </a:xfrm>
+          <a:prstGeom prst="rect">
+            <a:avLst/>
+          </a:prstGeom>
+          <a:noFill/>
+        </p:spPr>
+        <p:txBody>
+          <a:bodyPr wrap="square" anchor="t" lIns="0" rIns="0" tIns="0" bIns="0">
+            <a:spAutoFit/>
+          </a:bodyPr>
+          <a:lstStyle/>
+          <a:p>
+            <a:r>
+              <a:rPr sz="1100" b="0">
+                <a:solidFill>
+                  <a:srgbClr val="CFE3E6"/>
+                </a:solidFill>
+                <a:latin typeface="Calibri"/>
+              </a:rPr>
+              <a:t>punyasurana23@gmail.com</a:t>
+            </a:r>
+          </a:p>
+        </p:txBody>
+      </p:sp>
+      <p:sp>
+        <p:nvSpPr>
+          <p:cNvPr id="13" name="Rounded Rectangle 12"/>
           <p:cNvSpPr/>
           <p:nvPr/>
         </p:nvSpPr>
         <p:spPr>
           <a:xfrm>
-            <a:off x="7863840" y="1737360"/>
-            <a:ext cx="3776472" cy="4434840"/>
+            <a:off x="8942832" y="1554480"/>
+            <a:ext cx="2697480" cy="2103120"/>
           </a:xfrm>
           <a:prstGeom prst="roundRect">
             <a:avLst>
-              <a:gd name="adj" fmla="val 4000"/>
+              <a:gd name="adj" fmla="val 5000"/>
             </a:avLst>
           </a:prstGeom>
           <a:solidFill>
@@ -8294,14 +9193,93 @@
       </p:sp>
       <p:sp>
         <p:nvSpPr>
-          <p:cNvPr id="11" name="TextBox 10"/>
-          <p:cNvSpPr txBox="1"/>
-          <p:nvPr/>
-        </p:nvSpPr>
-        <p:spPr>
-          <a:xfrm>
-            <a:off x="8092440" y="1874519"/>
-            <a:ext cx="3337560" cy="365760"/>
+          <p:cNvPr id="14" name="Oval 13"/>
+          <p:cNvSpPr/>
+          <p:nvPr/>
+        </p:nvSpPr>
+        <p:spPr>
+          <a:xfrm>
+            <a:off x="9171432" y="1783080"/>
+            <a:ext cx="640080" cy="640080"/>
+          </a:xfrm>
+          <a:prstGeom prst="ellipse">
+            <a:avLst/>
+          </a:prstGeom>
+          <a:solidFill>
+            <a:srgbClr val="072C34"/>
+          </a:solidFill>
+          <a:ln>
+            <a:noFill/>
+          </a:ln>
+          <a:effectLst/>
+        </p:spPr>
+        <p:style>
+          <a:lnRef idx="1">
+            <a:schemeClr val="accent1"/>
+          </a:lnRef>
+          <a:fillRef idx="3">
+            <a:schemeClr val="accent1"/>
+          </a:fillRef>
+          <a:effectRef idx="2">
+            <a:schemeClr val="accent1"/>
+          </a:effectRef>
+          <a:fontRef idx="minor">
+            <a:schemeClr val="lt1"/>
+          </a:fontRef>
+        </p:style>
+        <p:txBody>
+          <a:bodyPr rtlCol="0" anchor="ctr"/>
+          <a:lstStyle/>
+          <a:p>
+            <a:pPr algn="ctr"/>
+          </a:p>
+        </p:txBody>
+      </p:sp>
+      <p:sp>
+        <p:nvSpPr>
+          <p:cNvPr id="15" name="TextBox 14"/>
+          <p:cNvSpPr txBox="1"/>
+          <p:nvPr/>
+        </p:nvSpPr>
+        <p:spPr>
+          <a:xfrm>
+            <a:off x="9171432" y="1783080"/>
+            <a:ext cx="640080" cy="640080"/>
+          </a:xfrm>
+          <a:prstGeom prst="rect">
+            <a:avLst/>
+          </a:prstGeom>
+          <a:noFill/>
+        </p:spPr>
+        <p:txBody>
+          <a:bodyPr wrap="square" anchor="ctr" lIns="0" rIns="0" tIns="0" bIns="0">
+            <a:spAutoFit/>
+          </a:bodyPr>
+          <a:lstStyle/>
+          <a:p>
+            <a:pPr algn="ctr"/>
+            <a:r>
+              <a:rPr sz="1600" b="1">
+                <a:solidFill>
+                  <a:srgbClr val="FFFFFF"/>
+                </a:solidFill>
+                <a:latin typeface="Calibri"/>
+              </a:rPr>
+              <a:t>SP</a:t>
+            </a:r>
+          </a:p>
+        </p:txBody>
+      </p:sp>
+      <p:sp>
+        <p:nvSpPr>
+          <p:cNvPr id="16" name="TextBox 15"/>
+          <p:cNvSpPr txBox="1"/>
+          <p:nvPr/>
+        </p:nvSpPr>
+        <p:spPr>
+          <a:xfrm>
+            <a:off x="9171432" y="2606039"/>
+            <a:ext cx="2331720" cy="320040"/>
           </a:xfrm>
           <a:prstGeom prst="rect">
             <a:avLst/>
@@ -8314,33 +9292,28 @@
           </a:bodyPr>
           <a:lstStyle/>
           <a:p>
-            <a:pPr>
-              <a:spcAft>
-                <a:spcPts val="0"/>
-              </a:spcAft>
-            </a:pPr>
-            <a:r>
-              <a:rPr sz="1800" b="1">
+            <a:r>
+              <a:rPr sz="1700" b="1">
                 <a:solidFill>
                   <a:srgbClr val="FFFFFF"/>
                 </a:solidFill>
-                <a:latin typeface="Cambria"/>
-              </a:rPr>
-              <a:t>How INFRA-AI answers it</a:t>
-            </a:r>
-          </a:p>
-        </p:txBody>
-      </p:sp>
-      <p:sp>
-        <p:nvSpPr>
-          <p:cNvPr id="12" name="TextBox 11"/>
-          <p:cNvSpPr txBox="1"/>
-          <p:nvPr/>
-        </p:nvSpPr>
-        <p:spPr>
-          <a:xfrm>
-            <a:off x="8092440" y="2423160"/>
-            <a:ext cx="3337560" cy="274320"/>
+                <a:latin typeface="Calibri"/>
+              </a:rPr>
+              <a:t>Shreyam Pandey</a:t>
+            </a:r>
+          </a:p>
+        </p:txBody>
+      </p:sp>
+      <p:sp>
+        <p:nvSpPr>
+          <p:cNvPr id="17" name="TextBox 16"/>
+          <p:cNvSpPr txBox="1"/>
+          <p:nvPr/>
+        </p:nvSpPr>
+        <p:spPr>
+          <a:xfrm>
+            <a:off x="9171432" y="2944368"/>
+            <a:ext cx="2331720" cy="274320"/>
           </a:xfrm>
           <a:prstGeom prst="rect">
             <a:avLst/>
@@ -8353,33 +9326,28 @@
           </a:bodyPr>
           <a:lstStyle/>
           <a:p>
-            <a:pPr>
-              <a:spcAft>
-                <a:spcPts val="0"/>
-              </a:spcAft>
-            </a:pPr>
-            <a:r>
-              <a:rPr sz="1400" b="1">
-                <a:solidFill>
-                  <a:srgbClr val="FFFFFF"/>
+            <a:r>
+              <a:rPr sz="1100" b="0">
+                <a:solidFill>
+                  <a:srgbClr val="CFE3E6"/>
                 </a:solidFill>
                 <a:latin typeface="Calibri"/>
               </a:rPr>
-              <a:t>Every request, every language</a:t>
-            </a:r>
-          </a:p>
-        </p:txBody>
-      </p:sp>
-      <p:sp>
-        <p:nvSpPr>
-          <p:cNvPr id="13" name="TextBox 12"/>
-          <p:cNvSpPr txBox="1"/>
-          <p:nvPr/>
-        </p:nvSpPr>
-        <p:spPr>
-          <a:xfrm>
-            <a:off x="8092440" y="2715768"/>
-            <a:ext cx="3337560" cy="548640"/>
+              <a:t>Team Member</a:t>
+            </a:r>
+          </a:p>
+        </p:txBody>
+      </p:sp>
+      <p:sp>
+        <p:nvSpPr>
+          <p:cNvPr id="18" name="TextBox 17"/>
+          <p:cNvSpPr txBox="1"/>
+          <p:nvPr/>
+        </p:nvSpPr>
+        <p:spPr>
+          <a:xfrm>
+            <a:off x="9171432" y="3246120"/>
+            <a:ext cx="2331720" cy="274320"/>
           </a:xfrm>
           <a:prstGeom prst="rect">
             <a:avLst/>
@@ -8392,33 +9360,153 @@
           </a:bodyPr>
           <a:lstStyle/>
           <a:p>
-            <a:pPr>
-              <a:spcAft>
-                <a:spcPts val="0"/>
-              </a:spcAft>
-            </a:pPr>
-            <a:r>
-              <a:rPr sz="1200" b="0">
-                <a:solidFill>
-                  <a:srgbClr val="CADCE0"/>
+            <a:r>
+              <a:rPr sz="1100" b="0">
+                <a:solidFill>
+                  <a:srgbClr val="CFE3E6"/>
                 </a:solidFill>
                 <a:latin typeface="Calibri"/>
               </a:rPr>
-              <a:t>Voice, text and messaging intake in 22 languages</a:t>
-            </a:r>
-          </a:p>
-        </p:txBody>
-      </p:sp>
-      <p:sp>
-        <p:nvSpPr>
-          <p:cNvPr id="14" name="TextBox 13"/>
-          <p:cNvSpPr txBox="1"/>
-          <p:nvPr/>
-        </p:nvSpPr>
-        <p:spPr>
-          <a:xfrm>
-            <a:off x="8092440" y="3355848"/>
-            <a:ext cx="3337560" cy="274320"/>
+              <a:t>p.shreyambbk@gmail.com</a:t>
+            </a:r>
+          </a:p>
+        </p:txBody>
+      </p:sp>
+      <p:sp>
+        <p:nvSpPr>
+          <p:cNvPr id="19" name="Rounded Rectangle 18"/>
+          <p:cNvSpPr/>
+          <p:nvPr/>
+        </p:nvSpPr>
+        <p:spPr>
+          <a:xfrm>
+            <a:off x="6062472" y="3840480"/>
+            <a:ext cx="2697480" cy="2103120"/>
+          </a:xfrm>
+          <a:prstGeom prst="roundRect">
+            <a:avLst>
+              <a:gd name="adj" fmla="val 5000"/>
+            </a:avLst>
+          </a:prstGeom>
+          <a:solidFill>
+            <a:srgbClr val="0B4F5C"/>
+          </a:solidFill>
+          <a:ln>
+            <a:noFill/>
+          </a:ln>
+          <a:effectLst/>
+        </p:spPr>
+        <p:style>
+          <a:lnRef idx="1">
+            <a:schemeClr val="accent1"/>
+          </a:lnRef>
+          <a:fillRef idx="3">
+            <a:schemeClr val="accent1"/>
+          </a:fillRef>
+          <a:effectRef idx="2">
+            <a:schemeClr val="accent1"/>
+          </a:effectRef>
+          <a:fontRef idx="minor">
+            <a:schemeClr val="lt1"/>
+          </a:fontRef>
+        </p:style>
+        <p:txBody>
+          <a:bodyPr rtlCol="0" anchor="ctr"/>
+          <a:lstStyle/>
+          <a:p>
+            <a:pPr algn="ctr"/>
+          </a:p>
+        </p:txBody>
+      </p:sp>
+      <p:sp>
+        <p:nvSpPr>
+          <p:cNvPr id="20" name="Oval 19"/>
+          <p:cNvSpPr/>
+          <p:nvPr/>
+        </p:nvSpPr>
+        <p:spPr>
+          <a:xfrm>
+            <a:off x="6291072" y="4069080"/>
+            <a:ext cx="640080" cy="640080"/>
+          </a:xfrm>
+          <a:prstGeom prst="ellipse">
+            <a:avLst/>
+          </a:prstGeom>
+          <a:solidFill>
+            <a:srgbClr val="072C34"/>
+          </a:solidFill>
+          <a:ln>
+            <a:noFill/>
+          </a:ln>
+          <a:effectLst/>
+        </p:spPr>
+        <p:style>
+          <a:lnRef idx="1">
+            <a:schemeClr val="accent1"/>
+          </a:lnRef>
+          <a:fillRef idx="3">
+            <a:schemeClr val="accent1"/>
+          </a:fillRef>
+          <a:effectRef idx="2">
+            <a:schemeClr val="accent1"/>
+          </a:effectRef>
+          <a:fontRef idx="minor">
+            <a:schemeClr val="lt1"/>
+          </a:fontRef>
+        </p:style>
+        <p:txBody>
+          <a:bodyPr rtlCol="0" anchor="ctr"/>
+          <a:lstStyle/>
+          <a:p>
+            <a:pPr algn="ctr"/>
+          </a:p>
+        </p:txBody>
+      </p:sp>
+      <p:sp>
+        <p:nvSpPr>
+          <p:cNvPr id="21" name="TextBox 20"/>
+          <p:cNvSpPr txBox="1"/>
+          <p:nvPr/>
+        </p:nvSpPr>
+        <p:spPr>
+          <a:xfrm>
+            <a:off x="6291072" y="4069080"/>
+            <a:ext cx="640080" cy="640080"/>
+          </a:xfrm>
+          <a:prstGeom prst="rect">
+            <a:avLst/>
+          </a:prstGeom>
+          <a:noFill/>
+        </p:spPr>
+        <p:txBody>
+          <a:bodyPr wrap="square" anchor="ctr" lIns="0" rIns="0" tIns="0" bIns="0">
+            <a:spAutoFit/>
+          </a:bodyPr>
+          <a:lstStyle/>
+          <a:p>
+            <a:pPr algn="ctr"/>
+            <a:r>
+              <a:rPr sz="1600" b="1">
+                <a:solidFill>
+                  <a:srgbClr val="FFFFFF"/>
+                </a:solidFill>
+                <a:latin typeface="Calibri"/>
+              </a:rPr>
+              <a:t>SV</a:t>
+            </a:r>
+          </a:p>
+        </p:txBody>
+      </p:sp>
+      <p:sp>
+        <p:nvSpPr>
+          <p:cNvPr id="22" name="TextBox 21"/>
+          <p:cNvSpPr txBox="1"/>
+          <p:nvPr/>
+        </p:nvSpPr>
+        <p:spPr>
+          <a:xfrm>
+            <a:off x="6291072" y="4892040"/>
+            <a:ext cx="2331720" cy="320040"/>
           </a:xfrm>
           <a:prstGeom prst="rect">
             <a:avLst/>
@@ -8431,33 +9519,28 @@
           </a:bodyPr>
           <a:lstStyle/>
           <a:p>
-            <a:pPr>
-              <a:spcAft>
-                <a:spcPts val="0"/>
-              </a:spcAft>
-            </a:pPr>
-            <a:r>
-              <a:rPr sz="1400" b="1">
+            <a:r>
+              <a:rPr sz="1700" b="1">
                 <a:solidFill>
                   <a:srgbClr val="FFFFFF"/>
                 </a:solidFill>
                 <a:latin typeface="Calibri"/>
               </a:rPr>
-              <a:t>One view of a place</a:t>
-            </a:r>
-          </a:p>
-        </p:txBody>
-      </p:sp>
-      <p:sp>
-        <p:nvSpPr>
-          <p:cNvPr id="15" name="TextBox 14"/>
-          <p:cNvSpPr txBox="1"/>
-          <p:nvPr/>
-        </p:nvSpPr>
-        <p:spPr>
-          <a:xfrm>
-            <a:off x="8092440" y="3648456"/>
-            <a:ext cx="3337560" cy="548640"/>
+              <a:t>Shubham Veer</a:t>
+            </a:r>
+          </a:p>
+        </p:txBody>
+      </p:sp>
+      <p:sp>
+        <p:nvSpPr>
+          <p:cNvPr id="23" name="TextBox 22"/>
+          <p:cNvSpPr txBox="1"/>
+          <p:nvPr/>
+        </p:nvSpPr>
+        <p:spPr>
+          <a:xfrm>
+            <a:off x="6291072" y="5230368"/>
+            <a:ext cx="2331720" cy="274320"/>
           </a:xfrm>
           <a:prstGeom prst="rect">
             <a:avLst/>
@@ -8470,33 +9553,28 @@
           </a:bodyPr>
           <a:lstStyle/>
           <a:p>
-            <a:pPr>
-              <a:spcAft>
-                <a:spcPts val="0"/>
-              </a:spcAft>
-            </a:pPr>
-            <a:r>
-              <a:rPr sz="1200" b="0">
-                <a:solidFill>
-                  <a:srgbClr val="CADCE0"/>
+            <a:r>
+              <a:rPr sz="1100" b="0">
+                <a:solidFill>
+                  <a:srgbClr val="CFE3E6"/>
                 </a:solidFill>
                 <a:latin typeface="Calibri"/>
               </a:rPr>
-              <a:t>Requests joined to demographics, infrastructure and investment plans</a:t>
-            </a:r>
-          </a:p>
-        </p:txBody>
-      </p:sp>
-      <p:sp>
-        <p:nvSpPr>
-          <p:cNvPr id="16" name="TextBox 15"/>
-          <p:cNvSpPr txBox="1"/>
-          <p:nvPr/>
-        </p:nvSpPr>
-        <p:spPr>
-          <a:xfrm>
-            <a:off x="8092440" y="4288536"/>
-            <a:ext cx="3337560" cy="274320"/>
+              <a:t>Team Member</a:t>
+            </a:r>
+          </a:p>
+        </p:txBody>
+      </p:sp>
+      <p:sp>
+        <p:nvSpPr>
+          <p:cNvPr id="24" name="TextBox 23"/>
+          <p:cNvSpPr txBox="1"/>
+          <p:nvPr/>
+        </p:nvSpPr>
+        <p:spPr>
+          <a:xfrm>
+            <a:off x="6291072" y="5532120"/>
+            <a:ext cx="2331720" cy="274320"/>
           </a:xfrm>
           <a:prstGeom prst="rect">
             <a:avLst/>
@@ -8509,33 +9587,153 @@
           </a:bodyPr>
           <a:lstStyle/>
           <a:p>
-            <a:pPr>
-              <a:spcAft>
-                <a:spcPts val="0"/>
-              </a:spcAft>
-            </a:pPr>
-            <a:r>
-              <a:rPr sz="1400" b="1">
+            <a:r>
+              <a:rPr sz="1100" b="0">
+                <a:solidFill>
+                  <a:srgbClr val="CFE3E6"/>
+                </a:solidFill>
+                <a:latin typeface="Calibri"/>
+              </a:rPr>
+              <a:t>shubham.veer24@pcu.edu.in</a:t>
+            </a:r>
+          </a:p>
+        </p:txBody>
+      </p:sp>
+      <p:sp>
+        <p:nvSpPr>
+          <p:cNvPr id="25" name="Rounded Rectangle 24"/>
+          <p:cNvSpPr/>
+          <p:nvPr/>
+        </p:nvSpPr>
+        <p:spPr>
+          <a:xfrm>
+            <a:off x="8942832" y="3840480"/>
+            <a:ext cx="2697480" cy="2103120"/>
+          </a:xfrm>
+          <a:prstGeom prst="roundRect">
+            <a:avLst>
+              <a:gd name="adj" fmla="val 5000"/>
+            </a:avLst>
+          </a:prstGeom>
+          <a:solidFill>
+            <a:srgbClr val="0B4F5C"/>
+          </a:solidFill>
+          <a:ln>
+            <a:noFill/>
+          </a:ln>
+          <a:effectLst/>
+        </p:spPr>
+        <p:style>
+          <a:lnRef idx="1">
+            <a:schemeClr val="accent1"/>
+          </a:lnRef>
+          <a:fillRef idx="3">
+            <a:schemeClr val="accent1"/>
+          </a:fillRef>
+          <a:effectRef idx="2">
+            <a:schemeClr val="accent1"/>
+          </a:effectRef>
+          <a:fontRef idx="minor">
+            <a:schemeClr val="lt1"/>
+          </a:fontRef>
+        </p:style>
+        <p:txBody>
+          <a:bodyPr rtlCol="0" anchor="ctr"/>
+          <a:lstStyle/>
+          <a:p>
+            <a:pPr algn="ctr"/>
+          </a:p>
+        </p:txBody>
+      </p:sp>
+      <p:sp>
+        <p:nvSpPr>
+          <p:cNvPr id="26" name="Oval 25"/>
+          <p:cNvSpPr/>
+          <p:nvPr/>
+        </p:nvSpPr>
+        <p:spPr>
+          <a:xfrm>
+            <a:off x="9171432" y="4069080"/>
+            <a:ext cx="640080" cy="640080"/>
+          </a:xfrm>
+          <a:prstGeom prst="ellipse">
+            <a:avLst/>
+          </a:prstGeom>
+          <a:solidFill>
+            <a:srgbClr val="072C34"/>
+          </a:solidFill>
+          <a:ln>
+            <a:noFill/>
+          </a:ln>
+          <a:effectLst/>
+        </p:spPr>
+        <p:style>
+          <a:lnRef idx="1">
+            <a:schemeClr val="accent1"/>
+          </a:lnRef>
+          <a:fillRef idx="3">
+            <a:schemeClr val="accent1"/>
+          </a:fillRef>
+          <a:effectRef idx="2">
+            <a:schemeClr val="accent1"/>
+          </a:effectRef>
+          <a:fontRef idx="minor">
+            <a:schemeClr val="lt1"/>
+          </a:fontRef>
+        </p:style>
+        <p:txBody>
+          <a:bodyPr rtlCol="0" anchor="ctr"/>
+          <a:lstStyle/>
+          <a:p>
+            <a:pPr algn="ctr"/>
+          </a:p>
+        </p:txBody>
+      </p:sp>
+      <p:sp>
+        <p:nvSpPr>
+          <p:cNvPr id="27" name="TextBox 26"/>
+          <p:cNvSpPr txBox="1"/>
+          <p:nvPr/>
+        </p:nvSpPr>
+        <p:spPr>
+          <a:xfrm>
+            <a:off x="9171432" y="4069080"/>
+            <a:ext cx="640080" cy="640080"/>
+          </a:xfrm>
+          <a:prstGeom prst="rect">
+            <a:avLst/>
+          </a:prstGeom>
+          <a:noFill/>
+        </p:spPr>
+        <p:txBody>
+          <a:bodyPr wrap="square" anchor="ctr" lIns="0" rIns="0" tIns="0" bIns="0">
+            <a:spAutoFit/>
+          </a:bodyPr>
+          <a:lstStyle/>
+          <a:p>
+            <a:pPr algn="ctr"/>
+            <a:r>
+              <a:rPr sz="1600" b="1">
                 <a:solidFill>
                   <a:srgbClr val="FFFFFF"/>
                 </a:solidFill>
                 <a:latin typeface="Calibri"/>
               </a:rPr>
-              <a:t>Hotspots and priorities</a:t>
-            </a:r>
-          </a:p>
-        </p:txBody>
-      </p:sp>
-      <p:sp>
-        <p:nvSpPr>
-          <p:cNvPr id="17" name="TextBox 16"/>
-          <p:cNvSpPr txBox="1"/>
-          <p:nvPr/>
-        </p:nvSpPr>
-        <p:spPr>
-          <a:xfrm>
-            <a:off x="8092440" y="4581144"/>
-            <a:ext cx="3337560" cy="548640"/>
+              <a:t>LS</a:t>
+            </a:r>
+          </a:p>
+        </p:txBody>
+      </p:sp>
+      <p:sp>
+        <p:nvSpPr>
+          <p:cNvPr id="28" name="TextBox 27"/>
+          <p:cNvSpPr txBox="1"/>
+          <p:nvPr/>
+        </p:nvSpPr>
+        <p:spPr>
+          <a:xfrm>
+            <a:off x="9171432" y="4892040"/>
+            <a:ext cx="2331720" cy="320040"/>
           </a:xfrm>
           <a:prstGeom prst="rect">
             <a:avLst/>
@@ -8548,33 +9746,28 @@
           </a:bodyPr>
           <a:lstStyle/>
           <a:p>
-            <a:pPr>
-              <a:spcAft>
-                <a:spcPts val="0"/>
-              </a:spcAft>
-            </a:pPr>
-            <a:r>
-              <a:rPr sz="1200" b="0">
-                <a:solidFill>
-                  <a:srgbClr val="CADCE0"/>
+            <a:r>
+              <a:rPr sz="1700" b="1">
+                <a:solidFill>
+                  <a:srgbClr val="FFFFFF"/>
                 </a:solidFill>
                 <a:latin typeface="Calibri"/>
               </a:rPr>
-              <a:t>Explainable scores for policymakers, each with cited facts</a:t>
-            </a:r>
-          </a:p>
-        </p:txBody>
-      </p:sp>
-      <p:sp>
-        <p:nvSpPr>
-          <p:cNvPr id="18" name="TextBox 17"/>
-          <p:cNvSpPr txBox="1"/>
-          <p:nvPr/>
-        </p:nvSpPr>
-        <p:spPr>
-          <a:xfrm>
-            <a:off x="8092440" y="5221223"/>
-            <a:ext cx="3337560" cy="274320"/>
+              <a:t>Laksh Sorathiya</a:t>
+            </a:r>
+          </a:p>
+        </p:txBody>
+      </p:sp>
+      <p:sp>
+        <p:nvSpPr>
+          <p:cNvPr id="29" name="TextBox 28"/>
+          <p:cNvSpPr txBox="1"/>
+          <p:nvPr/>
+        </p:nvSpPr>
+        <p:spPr>
+          <a:xfrm>
+            <a:off x="9171432" y="5230368"/>
+            <a:ext cx="2331720" cy="274320"/>
           </a:xfrm>
           <a:prstGeom prst="rect">
             <a:avLst/>
@@ -8587,33 +9780,28 @@
           </a:bodyPr>
           <a:lstStyle/>
           <a:p>
-            <a:pPr>
-              <a:spcAft>
-                <a:spcPts val="0"/>
-              </a:spcAft>
-            </a:pPr>
-            <a:r>
-              <a:rPr sz="1400" b="1">
-                <a:solidFill>
-                  <a:srgbClr val="FFFFFF"/>
+            <a:r>
+              <a:rPr sz="1100" b="0">
+                <a:solidFill>
+                  <a:srgbClr val="CFE3E6"/>
                 </a:solidFill>
                 <a:latin typeface="Calibri"/>
               </a:rPr>
-              <a:t>Open by design</a:t>
-            </a:r>
-          </a:p>
-        </p:txBody>
-      </p:sp>
-      <p:sp>
-        <p:nvSpPr>
-          <p:cNvPr id="19" name="TextBox 18"/>
-          <p:cNvSpPr txBox="1"/>
-          <p:nvPr/>
-        </p:nvSpPr>
-        <p:spPr>
-          <a:xfrm>
-            <a:off x="8092440" y="5513831"/>
-            <a:ext cx="3337560" cy="548640"/>
+              <a:t>Team Member</a:t>
+            </a:r>
+          </a:p>
+        </p:txBody>
+      </p:sp>
+      <p:sp>
+        <p:nvSpPr>
+          <p:cNvPr id="30" name="TextBox 29"/>
+          <p:cNvSpPr txBox="1"/>
+          <p:nvPr/>
+        </p:nvSpPr>
+        <p:spPr>
+          <a:xfrm>
+            <a:off x="9171432" y="5532120"/>
+            <a:ext cx="2331720" cy="274320"/>
           </a:xfrm>
           <a:prstGeom prst="rect">
             <a:avLst/>
@@ -8626,97 +9814,14 @@
           </a:bodyPr>
           <a:lstStyle/>
           <a:p>
-            <a:pPr>
-              <a:spcAft>
-                <a:spcPts val="0"/>
-              </a:spcAft>
-            </a:pPr>
-            <a:r>
-              <a:rPr sz="1200" b="0">
-                <a:solidFill>
-                  <a:srgbClr val="CADCE0"/>
+            <a:r>
+              <a:rPr sz="1100" b="0">
+                <a:solidFill>
+                  <a:srgbClr val="CFE3E6"/>
                 </a:solidFill>
                 <a:latin typeface="Calibri"/>
               </a:rPr>
-              <a:t>A Digital Public Good: open data, open code, privacy by default</a:t>
-            </a:r>
-          </a:p>
-        </p:txBody>
-      </p:sp>
-      <p:sp>
-        <p:nvSpPr>
-          <p:cNvPr id="20" name="TextBox 19"/>
-          <p:cNvSpPr txBox="1"/>
-          <p:nvPr/>
-        </p:nvSpPr>
-        <p:spPr>
-          <a:xfrm>
-            <a:off x="548640" y="6446520"/>
-            <a:ext cx="5486400" cy="274320"/>
-          </a:xfrm>
-          <a:prstGeom prst="rect">
-            <a:avLst/>
-          </a:prstGeom>
-          <a:noFill/>
-        </p:spPr>
-        <p:txBody>
-          <a:bodyPr wrap="square" anchor="t" lIns="0" rIns="0" tIns="0" bIns="0">
-            <a:spAutoFit/>
-          </a:bodyPr>
-          <a:lstStyle/>
-          <a:p>
-            <a:pPr>
-              <a:spcAft>
-                <a:spcPts val="0"/>
-              </a:spcAft>
-            </a:pPr>
-            <a:r>
-              <a:rPr sz="1000" b="0">
-                <a:solidFill>
-                  <a:srgbClr val="5B6B72"/>
-                </a:solidFill>
-                <a:latin typeface="Calibri"/>
-              </a:rPr>
-              <a:t>INFRA-AI  ·  Digital Public Good</a:t>
-            </a:r>
-          </a:p>
-        </p:txBody>
-      </p:sp>
-      <p:sp>
-        <p:nvSpPr>
-          <p:cNvPr id="21" name="TextBox 20"/>
-          <p:cNvSpPr txBox="1"/>
-          <p:nvPr/>
-        </p:nvSpPr>
-        <p:spPr>
-          <a:xfrm>
-            <a:off x="11091672" y="6446520"/>
-            <a:ext cx="548640" cy="274320"/>
-          </a:xfrm>
-          <a:prstGeom prst="rect">
-            <a:avLst/>
-          </a:prstGeom>
-          <a:noFill/>
-        </p:spPr>
-        <p:txBody>
-          <a:bodyPr wrap="square" anchor="t" lIns="0" rIns="0" tIns="0" bIns="0">
-            <a:spAutoFit/>
-          </a:bodyPr>
-          <a:lstStyle/>
-          <a:p>
-            <a:pPr algn="r">
-              <a:spcAft>
-                <a:spcPts val="0"/>
-              </a:spcAft>
-            </a:pPr>
-            <a:r>
-              <a:rPr sz="1000" b="0">
-                <a:solidFill>
-                  <a:srgbClr val="5B6B72"/>
-                </a:solidFill>
-                <a:latin typeface="Calibri"/>
-              </a:rPr>
-              <a:t>2</a:t>
+              <a:t>sorathiyalaksh37@gmail.com</a:t>
             </a:r>
           </a:p>
         </p:txBody>

</xml_diff>

<commit_message>
docs(pitch): add BRICS slide (proposed, not built) before the roadmap
Shows why the platform can travel to BRICS members, what can be done, and what
should come first (ADR for scope, per-country licences, boundaries, privacy law,
language gold sets). Roadmap footer renumbered to 9.

Co-Authored-By: Claude Sonnet 5.5 <noreply@anthropic.com>
</commit_message>
<xml_diff>
--- a/docs/INFRA-AI-pitch.pptx
+++ b/docs/INFRA-AI-pitch.pptx
@@ -12,6 +12,7 @@
     <p:sldId id="258" r:id="rId4"/>
     <p:sldId id="259" r:id="rId5"/>
     <p:sldId id="260" r:id="rId6"/>
+    <p:sldId id="264" r:id="rId15"/>
     <p:sldId id="261" r:id="rId7"/>
   </p:sldIdLst>
   <p:notesMasterIdLst>
@@ -984,6 +985,76 @@
         <p14:creationId xmlns:p14="http://schemas.microsoft.com/office/powerpoint/2010/main" val="1024086991"/>
       </p:ext>
     </p:extLst>
+  </p:cSld>
+  <p:clrMapOvr>
+    <a:masterClrMapping/>
+  </p:clrMapOvr>
+</p:notes>
+</file>
+
+<file path=ppt/notesSlides/notesSlide7.xml><?xml version="1.0" encoding="utf-8"?>
+<p:notes xmlns:a="http://schemas.openxmlformats.org/drawingml/2006/main" xmlns:p="http://schemas.openxmlformats.org/presentationml/2006/main" xmlns:r="http://schemas.openxmlformats.org/officeDocument/2006/relationships">
+  <p:cSld>
+    <p:spTree>
+      <p:nvGrpSpPr>
+        <p:cNvPr id="1" name=""/>
+        <p:cNvGrpSpPr/>
+        <p:nvPr/>
+      </p:nvGrpSpPr>
+      <p:grpSpPr>
+        <a:xfrm>
+          <a:off x="0" y="0"/>
+          <a:ext cx="0" cy="0"/>
+          <a:chOff x="0" y="0"/>
+          <a:chExt cx="0" cy="0"/>
+        </a:xfrm>
+      </p:grpSpPr>
+      <p:sp>
+        <p:nvSpPr>
+          <p:cNvPr id="2" name="Slide Image Placeholder 1"/>
+          <p:cNvSpPr>
+            <a:spLocks noGrp="1"/>
+          </p:cNvSpPr>
+          <p:nvPr>
+            <p:ph type="sldImg" idx="2"/>
+          </p:nvPr>
+        </p:nvSpPr>
+        <p:spPr/>
+      </p:sp>
+      <p:sp>
+        <p:nvSpPr>
+          <p:cNvPr id="3" name="Notes Placeholder 2"/>
+          <p:cNvSpPr>
+            <a:spLocks noGrp="1"/>
+          </p:cNvSpPr>
+          <p:nvPr>
+            <p:ph type="body" idx="3" sz="quarter"/>
+          </p:nvPr>
+        </p:nvSpPr>
+        <p:spPr/>
+        <p:txBody>
+          <a:bodyPr/>
+          <a:lstStyle/>
+          <a:p>
+            <a:r>
+              <a:t>BRICS is a proposal, not implemented. Why it can travel: the core is city/field-agnostic (AGENTS.md invariant 8), uses global open data, and the UI language picker already has a BRICS / international group (pt, ru, zh). Should-do list comes from the invariants: ADR before changing scope (ADR-0013), licences before data (ADR-0012), official boundaries per country (ADR-0007 is Survey of India for India), privacy law per country (ADR-0011 is DPDP-aligned), gold-set evaluation for languages (ADR-0008/0009).</a:t>
+            </a:r>
+          </a:p>
+        </p:txBody>
+      </p:sp>
+      <p:sp>
+        <p:nvSpPr>
+          <p:cNvPr id="4" name="Slide Number Placeholder 3"/>
+          <p:cNvSpPr>
+            <a:spLocks noGrp="1"/>
+          </p:cNvSpPr>
+          <p:nvPr>
+            <p:ph type="sldNum" idx="5" sz="quarter"/>
+          </p:nvPr>
+        </p:nvSpPr>
+        <p:spPr/>
+      </p:sp>
+    </p:spTree>
   </p:cSld>
   <p:clrMapOvr>
     <a:masterClrMapping/>
@@ -1299,6 +1370,1110 @@
 </file>
 
 <file path=ppt/slides/slide1.xml><?xml version="1.0" encoding="utf-8"?>
+<p:sld xmlns:a="http://schemas.openxmlformats.org/drawingml/2006/main" xmlns:p="http://schemas.openxmlformats.org/presentationml/2006/main" xmlns:r="http://schemas.openxmlformats.org/officeDocument/2006/relationships">
+  <p:cSld>
+    <p:bg>
+      <p:bgPr>
+        <a:solidFill>
+          <a:srgbClr val="072C34"/>
+        </a:solidFill>
+        <a:effectLst/>
+      </p:bgPr>
+    </p:bg>
+    <p:spTree>
+      <p:nvGrpSpPr>
+        <p:cNvPr id="1" name=""/>
+        <p:cNvGrpSpPr/>
+        <p:nvPr/>
+      </p:nvGrpSpPr>
+      <p:grpSpPr/>
+      <p:sp>
+        <p:nvSpPr>
+          <p:cNvPr id="2" name="TextBox 1"/>
+          <p:cNvSpPr txBox="1"/>
+          <p:nvPr/>
+        </p:nvSpPr>
+        <p:spPr>
+          <a:xfrm>
+            <a:off x="548640" y="640080"/>
+            <a:ext cx="5120640" cy="320040"/>
+          </a:xfrm>
+          <a:prstGeom prst="rect">
+            <a:avLst/>
+          </a:prstGeom>
+          <a:noFill/>
+        </p:spPr>
+        <p:txBody>
+          <a:bodyPr wrap="square" anchor="t" lIns="0" rIns="0" tIns="0" bIns="0">
+            <a:spAutoFit/>
+          </a:bodyPr>
+          <a:lstStyle/>
+          <a:p>
+            <a:r>
+              <a:rPr sz="1200" b="1" spc="100">
+                <a:solidFill>
+                  <a:srgbClr val="E08A1E"/>
+                </a:solidFill>
+                <a:latin typeface="Calibri"/>
+              </a:rPr>
+              <a:t>BUILD WITH AI: CODE FOR COMMUNITIES  ·  SECOND EDITION</a:t>
+            </a:r>
+          </a:p>
+        </p:txBody>
+      </p:sp>
+      <p:sp>
+        <p:nvSpPr>
+          <p:cNvPr id="3" name="TextBox 2"/>
+          <p:cNvSpPr txBox="1"/>
+          <p:nvPr/>
+        </p:nvSpPr>
+        <p:spPr>
+          <a:xfrm>
+            <a:off x="548640" y="1188720"/>
+            <a:ext cx="5120640" cy="1097280"/>
+          </a:xfrm>
+          <a:prstGeom prst="rect">
+            <a:avLst/>
+          </a:prstGeom>
+          <a:noFill/>
+        </p:spPr>
+        <p:txBody>
+          <a:bodyPr wrap="square" anchor="t" lIns="0" rIns="0" tIns="0" bIns="0">
+            <a:spAutoFit/>
+          </a:bodyPr>
+          <a:lstStyle/>
+          <a:p>
+            <a:r>
+              <a:rPr sz="4800" b="1">
+                <a:solidFill>
+                  <a:srgbClr val="FFFFFF"/>
+                </a:solidFill>
+                <a:latin typeface="Cambria"/>
+              </a:rPr>
+              <a:t>Team Predators</a:t>
+            </a:r>
+          </a:p>
+        </p:txBody>
+      </p:sp>
+      <p:sp>
+        <p:nvSpPr>
+          <p:cNvPr id="4" name="TextBox 3"/>
+          <p:cNvSpPr txBox="1"/>
+          <p:nvPr/>
+        </p:nvSpPr>
+        <p:spPr>
+          <a:xfrm>
+            <a:off x="548640" y="2514600"/>
+            <a:ext cx="5120640" cy="1280160"/>
+          </a:xfrm>
+          <a:prstGeom prst="rect">
+            <a:avLst/>
+          </a:prstGeom>
+          <a:noFill/>
+        </p:spPr>
+        <p:txBody>
+          <a:bodyPr wrap="square" anchor="t" lIns="0" rIns="0" tIns="0" bIns="0">
+            <a:spAutoFit/>
+          </a:bodyPr>
+          <a:lstStyle/>
+          <a:p>
+            <a:r>
+              <a:rPr sz="2000" b="0">
+                <a:solidFill>
+                  <a:srgbClr val="CFE3E6"/>
+                </a:solidFill>
+                <a:latin typeface="Calibri"/>
+              </a:rPr>
+              <a:t>Problem statement 01: AI for Digital Public Infrastructure &amp; Governance</a:t>
+            </a:r>
+          </a:p>
+        </p:txBody>
+      </p:sp>
+      <p:sp>
+        <p:nvSpPr>
+          <p:cNvPr id="5" name="TextBox 4"/>
+          <p:cNvSpPr txBox="1"/>
+          <p:nvPr/>
+        </p:nvSpPr>
+        <p:spPr>
+          <a:xfrm>
+            <a:off x="548640" y="4206240"/>
+            <a:ext cx="5120640" cy="457200"/>
+          </a:xfrm>
+          <a:prstGeom prst="rect">
+            <a:avLst/>
+          </a:prstGeom>
+          <a:noFill/>
+        </p:spPr>
+        <p:txBody>
+          <a:bodyPr wrap="square" anchor="t" lIns="0" rIns="0" tIns="0" bIns="0">
+            <a:spAutoFit/>
+          </a:bodyPr>
+          <a:lstStyle/>
+          <a:p>
+            <a:r>
+              <a:rPr sz="1800" b="1">
+                <a:solidFill>
+                  <a:srgbClr val="FFFFFF"/>
+                </a:solidFill>
+                <a:latin typeface="Cambria"/>
+              </a:rPr>
+              <a:t>Our solution: INFRA-AI</a:t>
+            </a:r>
+          </a:p>
+        </p:txBody>
+      </p:sp>
+      <p:sp>
+        <p:nvSpPr>
+          <p:cNvPr id="6" name="TextBox 5"/>
+          <p:cNvSpPr txBox="1"/>
+          <p:nvPr/>
+        </p:nvSpPr>
+        <p:spPr>
+          <a:xfrm>
+            <a:off x="548640" y="4617720"/>
+            <a:ext cx="5120640" cy="731520"/>
+          </a:xfrm>
+          <a:prstGeom prst="rect">
+            <a:avLst/>
+          </a:prstGeom>
+          <a:noFill/>
+        </p:spPr>
+        <p:txBody>
+          <a:bodyPr wrap="square" anchor="t" lIns="0" rIns="0" tIns="0" bIns="0">
+            <a:spAutoFit/>
+          </a:bodyPr>
+          <a:lstStyle/>
+          <a:p>
+            <a:r>
+              <a:rPr sz="1400" b="0">
+                <a:solidFill>
+                  <a:srgbClr val="CFE3E6"/>
+                </a:solidFill>
+                <a:latin typeface="Calibri"/>
+              </a:rPr>
+              <a:t>A multilingual, location-first infrastructure intelligence platform for India, built as a Digital Public Good.</a:t>
+            </a:r>
+          </a:p>
+        </p:txBody>
+      </p:sp>
+      <p:sp>
+        <p:nvSpPr>
+          <p:cNvPr id="7" name="Rounded Rectangle 6"/>
+          <p:cNvSpPr/>
+          <p:nvPr/>
+        </p:nvSpPr>
+        <p:spPr>
+          <a:xfrm>
+            <a:off x="6062472" y="1554480"/>
+            <a:ext cx="2697480" cy="2103120"/>
+          </a:xfrm>
+          <a:prstGeom prst="roundRect">
+            <a:avLst>
+              <a:gd name="adj" fmla="val 5000"/>
+            </a:avLst>
+          </a:prstGeom>
+          <a:solidFill>
+            <a:srgbClr val="0B4F5C"/>
+          </a:solidFill>
+          <a:ln>
+            <a:noFill/>
+          </a:ln>
+          <a:effectLst/>
+        </p:spPr>
+        <p:style>
+          <a:lnRef idx="1">
+            <a:schemeClr val="accent1"/>
+          </a:lnRef>
+          <a:fillRef idx="3">
+            <a:schemeClr val="accent1"/>
+          </a:fillRef>
+          <a:effectRef idx="2">
+            <a:schemeClr val="accent1"/>
+          </a:effectRef>
+          <a:fontRef idx="minor">
+            <a:schemeClr val="lt1"/>
+          </a:fontRef>
+        </p:style>
+        <p:txBody>
+          <a:bodyPr rtlCol="0" anchor="ctr"/>
+          <a:lstStyle/>
+          <a:p>
+            <a:pPr algn="ctr"/>
+          </a:p>
+        </p:txBody>
+      </p:sp>
+      <p:sp>
+        <p:nvSpPr>
+          <p:cNvPr id="8" name="Oval 7"/>
+          <p:cNvSpPr/>
+          <p:nvPr/>
+        </p:nvSpPr>
+        <p:spPr>
+          <a:xfrm>
+            <a:off x="6291072" y="1783080"/>
+            <a:ext cx="640080" cy="640080"/>
+          </a:xfrm>
+          <a:prstGeom prst="ellipse">
+            <a:avLst/>
+          </a:prstGeom>
+          <a:solidFill>
+            <a:srgbClr val="E08A1E"/>
+          </a:solidFill>
+          <a:ln>
+            <a:noFill/>
+          </a:ln>
+          <a:effectLst/>
+        </p:spPr>
+        <p:style>
+          <a:lnRef idx="1">
+            <a:schemeClr val="accent1"/>
+          </a:lnRef>
+          <a:fillRef idx="3">
+            <a:schemeClr val="accent1"/>
+          </a:fillRef>
+          <a:effectRef idx="2">
+            <a:schemeClr val="accent1"/>
+          </a:effectRef>
+          <a:fontRef idx="minor">
+            <a:schemeClr val="lt1"/>
+          </a:fontRef>
+        </p:style>
+        <p:txBody>
+          <a:bodyPr rtlCol="0" anchor="ctr"/>
+          <a:lstStyle/>
+          <a:p>
+            <a:pPr algn="ctr"/>
+          </a:p>
+        </p:txBody>
+      </p:sp>
+      <p:sp>
+        <p:nvSpPr>
+          <p:cNvPr id="9" name="TextBox 8"/>
+          <p:cNvSpPr txBox="1"/>
+          <p:nvPr/>
+        </p:nvSpPr>
+        <p:spPr>
+          <a:xfrm>
+            <a:off x="6291072" y="1783080"/>
+            <a:ext cx="640080" cy="640080"/>
+          </a:xfrm>
+          <a:prstGeom prst="rect">
+            <a:avLst/>
+          </a:prstGeom>
+          <a:noFill/>
+        </p:spPr>
+        <p:txBody>
+          <a:bodyPr wrap="square" anchor="ctr" lIns="0" rIns="0" tIns="0" bIns="0">
+            <a:spAutoFit/>
+          </a:bodyPr>
+          <a:lstStyle/>
+          <a:p>
+            <a:pPr algn="ctr"/>
+            <a:r>
+              <a:rPr sz="1600" b="1">
+                <a:solidFill>
+                  <a:srgbClr val="072C34"/>
+                </a:solidFill>
+                <a:latin typeface="Calibri"/>
+              </a:rPr>
+              <a:t>PS</a:t>
+            </a:r>
+          </a:p>
+        </p:txBody>
+      </p:sp>
+      <p:sp>
+        <p:nvSpPr>
+          <p:cNvPr id="10" name="TextBox 9"/>
+          <p:cNvSpPr txBox="1"/>
+          <p:nvPr/>
+        </p:nvSpPr>
+        <p:spPr>
+          <a:xfrm>
+            <a:off x="6291072" y="2606039"/>
+            <a:ext cx="2331720" cy="320040"/>
+          </a:xfrm>
+          <a:prstGeom prst="rect">
+            <a:avLst/>
+          </a:prstGeom>
+          <a:noFill/>
+        </p:spPr>
+        <p:txBody>
+          <a:bodyPr wrap="square" anchor="t" lIns="0" rIns="0" tIns="0" bIns="0">
+            <a:spAutoFit/>
+          </a:bodyPr>
+          <a:lstStyle/>
+          <a:p>
+            <a:r>
+              <a:rPr sz="1700" b="1">
+                <a:solidFill>
+                  <a:srgbClr val="FFFFFF"/>
+                </a:solidFill>
+                <a:latin typeface="Calibri"/>
+              </a:rPr>
+              <a:t>Punya Surana</a:t>
+            </a:r>
+          </a:p>
+        </p:txBody>
+      </p:sp>
+      <p:sp>
+        <p:nvSpPr>
+          <p:cNvPr id="11" name="TextBox 10"/>
+          <p:cNvSpPr txBox="1"/>
+          <p:nvPr/>
+        </p:nvSpPr>
+        <p:spPr>
+          <a:xfrm>
+            <a:off x="6291072" y="2944368"/>
+            <a:ext cx="2331720" cy="274320"/>
+          </a:xfrm>
+          <a:prstGeom prst="rect">
+            <a:avLst/>
+          </a:prstGeom>
+          <a:noFill/>
+        </p:spPr>
+        <p:txBody>
+          <a:bodyPr wrap="square" anchor="t" lIns="0" rIns="0" tIns="0" bIns="0">
+            <a:spAutoFit/>
+          </a:bodyPr>
+          <a:lstStyle/>
+          <a:p>
+            <a:r>
+              <a:rPr sz="1100" b="1">
+                <a:solidFill>
+                  <a:srgbClr val="E08A1E"/>
+                </a:solidFill>
+                <a:latin typeface="Calibri"/>
+              </a:rPr>
+              <a:t>Team Leader</a:t>
+            </a:r>
+          </a:p>
+        </p:txBody>
+      </p:sp>
+      <p:sp>
+        <p:nvSpPr>
+          <p:cNvPr id="12" name="TextBox 11"/>
+          <p:cNvSpPr txBox="1"/>
+          <p:nvPr/>
+        </p:nvSpPr>
+        <p:spPr>
+          <a:xfrm>
+            <a:off x="6291072" y="3246120"/>
+            <a:ext cx="2331720" cy="274320"/>
+          </a:xfrm>
+          <a:prstGeom prst="rect">
+            <a:avLst/>
+          </a:prstGeom>
+          <a:noFill/>
+        </p:spPr>
+        <p:txBody>
+          <a:bodyPr wrap="square" anchor="t" lIns="0" rIns="0" tIns="0" bIns="0">
+            <a:spAutoFit/>
+          </a:bodyPr>
+          <a:lstStyle/>
+          <a:p>
+            <a:r>
+              <a:rPr sz="1100" b="0">
+                <a:solidFill>
+                  <a:srgbClr val="CFE3E6"/>
+                </a:solidFill>
+                <a:latin typeface="Calibri"/>
+              </a:rPr>
+              <a:t>punyasurana23@gmail.com</a:t>
+            </a:r>
+          </a:p>
+        </p:txBody>
+      </p:sp>
+      <p:sp>
+        <p:nvSpPr>
+          <p:cNvPr id="13" name="Rounded Rectangle 12"/>
+          <p:cNvSpPr/>
+          <p:nvPr/>
+        </p:nvSpPr>
+        <p:spPr>
+          <a:xfrm>
+            <a:off x="8942832" y="1554480"/>
+            <a:ext cx="2697480" cy="2103120"/>
+          </a:xfrm>
+          <a:prstGeom prst="roundRect">
+            <a:avLst>
+              <a:gd name="adj" fmla="val 5000"/>
+            </a:avLst>
+          </a:prstGeom>
+          <a:solidFill>
+            <a:srgbClr val="0B4F5C"/>
+          </a:solidFill>
+          <a:ln>
+            <a:noFill/>
+          </a:ln>
+          <a:effectLst/>
+        </p:spPr>
+        <p:style>
+          <a:lnRef idx="1">
+            <a:schemeClr val="accent1"/>
+          </a:lnRef>
+          <a:fillRef idx="3">
+            <a:schemeClr val="accent1"/>
+          </a:fillRef>
+          <a:effectRef idx="2">
+            <a:schemeClr val="accent1"/>
+          </a:effectRef>
+          <a:fontRef idx="minor">
+            <a:schemeClr val="lt1"/>
+          </a:fontRef>
+        </p:style>
+        <p:txBody>
+          <a:bodyPr rtlCol="0" anchor="ctr"/>
+          <a:lstStyle/>
+          <a:p>
+            <a:pPr algn="ctr"/>
+          </a:p>
+        </p:txBody>
+      </p:sp>
+      <p:sp>
+        <p:nvSpPr>
+          <p:cNvPr id="14" name="Oval 13"/>
+          <p:cNvSpPr/>
+          <p:nvPr/>
+        </p:nvSpPr>
+        <p:spPr>
+          <a:xfrm>
+            <a:off x="9171432" y="1783080"/>
+            <a:ext cx="640080" cy="640080"/>
+          </a:xfrm>
+          <a:prstGeom prst="ellipse">
+            <a:avLst/>
+          </a:prstGeom>
+          <a:solidFill>
+            <a:srgbClr val="072C34"/>
+          </a:solidFill>
+          <a:ln>
+            <a:noFill/>
+          </a:ln>
+          <a:effectLst/>
+        </p:spPr>
+        <p:style>
+          <a:lnRef idx="1">
+            <a:schemeClr val="accent1"/>
+          </a:lnRef>
+          <a:fillRef idx="3">
+            <a:schemeClr val="accent1"/>
+          </a:fillRef>
+          <a:effectRef idx="2">
+            <a:schemeClr val="accent1"/>
+          </a:effectRef>
+          <a:fontRef idx="minor">
+            <a:schemeClr val="lt1"/>
+          </a:fontRef>
+        </p:style>
+        <p:txBody>
+          <a:bodyPr rtlCol="0" anchor="ctr"/>
+          <a:lstStyle/>
+          <a:p>
+            <a:pPr algn="ctr"/>
+          </a:p>
+        </p:txBody>
+      </p:sp>
+      <p:sp>
+        <p:nvSpPr>
+          <p:cNvPr id="15" name="TextBox 14"/>
+          <p:cNvSpPr txBox="1"/>
+          <p:nvPr/>
+        </p:nvSpPr>
+        <p:spPr>
+          <a:xfrm>
+            <a:off x="9171432" y="1783080"/>
+            <a:ext cx="640080" cy="640080"/>
+          </a:xfrm>
+          <a:prstGeom prst="rect">
+            <a:avLst/>
+          </a:prstGeom>
+          <a:noFill/>
+        </p:spPr>
+        <p:txBody>
+          <a:bodyPr wrap="square" anchor="ctr" lIns="0" rIns="0" tIns="0" bIns="0">
+            <a:spAutoFit/>
+          </a:bodyPr>
+          <a:lstStyle/>
+          <a:p>
+            <a:pPr algn="ctr"/>
+            <a:r>
+              <a:rPr sz="1600" b="1">
+                <a:solidFill>
+                  <a:srgbClr val="FFFFFF"/>
+                </a:solidFill>
+                <a:latin typeface="Calibri"/>
+              </a:rPr>
+              <a:t>SP</a:t>
+            </a:r>
+          </a:p>
+        </p:txBody>
+      </p:sp>
+      <p:sp>
+        <p:nvSpPr>
+          <p:cNvPr id="16" name="TextBox 15"/>
+          <p:cNvSpPr txBox="1"/>
+          <p:nvPr/>
+        </p:nvSpPr>
+        <p:spPr>
+          <a:xfrm>
+            <a:off x="9171432" y="2606039"/>
+            <a:ext cx="2331720" cy="320040"/>
+          </a:xfrm>
+          <a:prstGeom prst="rect">
+            <a:avLst/>
+          </a:prstGeom>
+          <a:noFill/>
+        </p:spPr>
+        <p:txBody>
+          <a:bodyPr wrap="square" anchor="t" lIns="0" rIns="0" tIns="0" bIns="0">
+            <a:spAutoFit/>
+          </a:bodyPr>
+          <a:lstStyle/>
+          <a:p>
+            <a:r>
+              <a:rPr sz="1700" b="1">
+                <a:solidFill>
+                  <a:srgbClr val="FFFFFF"/>
+                </a:solidFill>
+                <a:latin typeface="Calibri"/>
+              </a:rPr>
+              <a:t>Shreyam Pandey</a:t>
+            </a:r>
+          </a:p>
+        </p:txBody>
+      </p:sp>
+      <p:sp>
+        <p:nvSpPr>
+          <p:cNvPr id="17" name="TextBox 16"/>
+          <p:cNvSpPr txBox="1"/>
+          <p:nvPr/>
+        </p:nvSpPr>
+        <p:spPr>
+          <a:xfrm>
+            <a:off x="9171432" y="2944368"/>
+            <a:ext cx="2331720" cy="274320"/>
+          </a:xfrm>
+          <a:prstGeom prst="rect">
+            <a:avLst/>
+          </a:prstGeom>
+          <a:noFill/>
+        </p:spPr>
+        <p:txBody>
+          <a:bodyPr wrap="square" anchor="t" lIns="0" rIns="0" tIns="0" bIns="0">
+            <a:spAutoFit/>
+          </a:bodyPr>
+          <a:lstStyle/>
+          <a:p>
+            <a:r>
+              <a:rPr sz="1100" b="0">
+                <a:solidFill>
+                  <a:srgbClr val="CFE3E6"/>
+                </a:solidFill>
+                <a:latin typeface="Calibri"/>
+              </a:rPr>
+              <a:t>Team Member</a:t>
+            </a:r>
+          </a:p>
+        </p:txBody>
+      </p:sp>
+      <p:sp>
+        <p:nvSpPr>
+          <p:cNvPr id="18" name="TextBox 17"/>
+          <p:cNvSpPr txBox="1"/>
+          <p:nvPr/>
+        </p:nvSpPr>
+        <p:spPr>
+          <a:xfrm>
+            <a:off x="9171432" y="3246120"/>
+            <a:ext cx="2331720" cy="274320"/>
+          </a:xfrm>
+          <a:prstGeom prst="rect">
+            <a:avLst/>
+          </a:prstGeom>
+          <a:noFill/>
+        </p:spPr>
+        <p:txBody>
+          <a:bodyPr wrap="square" anchor="t" lIns="0" rIns="0" tIns="0" bIns="0">
+            <a:spAutoFit/>
+          </a:bodyPr>
+          <a:lstStyle/>
+          <a:p>
+            <a:r>
+              <a:rPr sz="1100" b="0">
+                <a:solidFill>
+                  <a:srgbClr val="CFE3E6"/>
+                </a:solidFill>
+                <a:latin typeface="Calibri"/>
+              </a:rPr>
+              <a:t>p.shreyambbk@gmail.com</a:t>
+            </a:r>
+          </a:p>
+        </p:txBody>
+      </p:sp>
+      <p:sp>
+        <p:nvSpPr>
+          <p:cNvPr id="19" name="Rounded Rectangle 18"/>
+          <p:cNvSpPr/>
+          <p:nvPr/>
+        </p:nvSpPr>
+        <p:spPr>
+          <a:xfrm>
+            <a:off x="6062472" y="3840480"/>
+            <a:ext cx="2697480" cy="2103120"/>
+          </a:xfrm>
+          <a:prstGeom prst="roundRect">
+            <a:avLst>
+              <a:gd name="adj" fmla="val 5000"/>
+            </a:avLst>
+          </a:prstGeom>
+          <a:solidFill>
+            <a:srgbClr val="0B4F5C"/>
+          </a:solidFill>
+          <a:ln>
+            <a:noFill/>
+          </a:ln>
+          <a:effectLst/>
+        </p:spPr>
+        <p:style>
+          <a:lnRef idx="1">
+            <a:schemeClr val="accent1"/>
+          </a:lnRef>
+          <a:fillRef idx="3">
+            <a:schemeClr val="accent1"/>
+          </a:fillRef>
+          <a:effectRef idx="2">
+            <a:schemeClr val="accent1"/>
+          </a:effectRef>
+          <a:fontRef idx="minor">
+            <a:schemeClr val="lt1"/>
+          </a:fontRef>
+        </p:style>
+        <p:txBody>
+          <a:bodyPr rtlCol="0" anchor="ctr"/>
+          <a:lstStyle/>
+          <a:p>
+            <a:pPr algn="ctr"/>
+          </a:p>
+        </p:txBody>
+      </p:sp>
+      <p:sp>
+        <p:nvSpPr>
+          <p:cNvPr id="20" name="Oval 19"/>
+          <p:cNvSpPr/>
+          <p:nvPr/>
+        </p:nvSpPr>
+        <p:spPr>
+          <a:xfrm>
+            <a:off x="6291072" y="4069080"/>
+            <a:ext cx="640080" cy="640080"/>
+          </a:xfrm>
+          <a:prstGeom prst="ellipse">
+            <a:avLst/>
+          </a:prstGeom>
+          <a:solidFill>
+            <a:srgbClr val="072C34"/>
+          </a:solidFill>
+          <a:ln>
+            <a:noFill/>
+          </a:ln>
+          <a:effectLst/>
+        </p:spPr>
+        <p:style>
+          <a:lnRef idx="1">
+            <a:schemeClr val="accent1"/>
+          </a:lnRef>
+          <a:fillRef idx="3">
+            <a:schemeClr val="accent1"/>
+          </a:fillRef>
+          <a:effectRef idx="2">
+            <a:schemeClr val="accent1"/>
+          </a:effectRef>
+          <a:fontRef idx="minor">
+            <a:schemeClr val="lt1"/>
+          </a:fontRef>
+        </p:style>
+        <p:txBody>
+          <a:bodyPr rtlCol="0" anchor="ctr"/>
+          <a:lstStyle/>
+          <a:p>
+            <a:pPr algn="ctr"/>
+          </a:p>
+        </p:txBody>
+      </p:sp>
+      <p:sp>
+        <p:nvSpPr>
+          <p:cNvPr id="21" name="TextBox 20"/>
+          <p:cNvSpPr txBox="1"/>
+          <p:nvPr/>
+        </p:nvSpPr>
+        <p:spPr>
+          <a:xfrm>
+            <a:off x="6291072" y="4069080"/>
+            <a:ext cx="640080" cy="640080"/>
+          </a:xfrm>
+          <a:prstGeom prst="rect">
+            <a:avLst/>
+          </a:prstGeom>
+          <a:noFill/>
+        </p:spPr>
+        <p:txBody>
+          <a:bodyPr wrap="square" anchor="ctr" lIns="0" rIns="0" tIns="0" bIns="0">
+            <a:spAutoFit/>
+          </a:bodyPr>
+          <a:lstStyle/>
+          <a:p>
+            <a:pPr algn="ctr"/>
+            <a:r>
+              <a:rPr sz="1600" b="1">
+                <a:solidFill>
+                  <a:srgbClr val="FFFFFF"/>
+                </a:solidFill>
+                <a:latin typeface="Calibri"/>
+              </a:rPr>
+              <a:t>SV</a:t>
+            </a:r>
+          </a:p>
+        </p:txBody>
+      </p:sp>
+      <p:sp>
+        <p:nvSpPr>
+          <p:cNvPr id="22" name="TextBox 21"/>
+          <p:cNvSpPr txBox="1"/>
+          <p:nvPr/>
+        </p:nvSpPr>
+        <p:spPr>
+          <a:xfrm>
+            <a:off x="6291072" y="4892040"/>
+            <a:ext cx="2331720" cy="320040"/>
+          </a:xfrm>
+          <a:prstGeom prst="rect">
+            <a:avLst/>
+          </a:prstGeom>
+          <a:noFill/>
+        </p:spPr>
+        <p:txBody>
+          <a:bodyPr wrap="square" anchor="t" lIns="0" rIns="0" tIns="0" bIns="0">
+            <a:spAutoFit/>
+          </a:bodyPr>
+          <a:lstStyle/>
+          <a:p>
+            <a:r>
+              <a:rPr sz="1700" b="1">
+                <a:solidFill>
+                  <a:srgbClr val="FFFFFF"/>
+                </a:solidFill>
+                <a:latin typeface="Calibri"/>
+              </a:rPr>
+              <a:t>Shubham Veer</a:t>
+            </a:r>
+          </a:p>
+        </p:txBody>
+      </p:sp>
+      <p:sp>
+        <p:nvSpPr>
+          <p:cNvPr id="23" name="TextBox 22"/>
+          <p:cNvSpPr txBox="1"/>
+          <p:nvPr/>
+        </p:nvSpPr>
+        <p:spPr>
+          <a:xfrm>
+            <a:off x="6291072" y="5230368"/>
+            <a:ext cx="2331720" cy="274320"/>
+          </a:xfrm>
+          <a:prstGeom prst="rect">
+            <a:avLst/>
+          </a:prstGeom>
+          <a:noFill/>
+        </p:spPr>
+        <p:txBody>
+          <a:bodyPr wrap="square" anchor="t" lIns="0" rIns="0" tIns="0" bIns="0">
+            <a:spAutoFit/>
+          </a:bodyPr>
+          <a:lstStyle/>
+          <a:p>
+            <a:r>
+              <a:rPr sz="1100" b="0">
+                <a:solidFill>
+                  <a:srgbClr val="CFE3E6"/>
+                </a:solidFill>
+                <a:latin typeface="Calibri"/>
+              </a:rPr>
+              <a:t>Team Member</a:t>
+            </a:r>
+          </a:p>
+        </p:txBody>
+      </p:sp>
+      <p:sp>
+        <p:nvSpPr>
+          <p:cNvPr id="24" name="TextBox 23"/>
+          <p:cNvSpPr txBox="1"/>
+          <p:nvPr/>
+        </p:nvSpPr>
+        <p:spPr>
+          <a:xfrm>
+            <a:off x="6291072" y="5532120"/>
+            <a:ext cx="2331720" cy="274320"/>
+          </a:xfrm>
+          <a:prstGeom prst="rect">
+            <a:avLst/>
+          </a:prstGeom>
+          <a:noFill/>
+        </p:spPr>
+        <p:txBody>
+          <a:bodyPr wrap="square" anchor="t" lIns="0" rIns="0" tIns="0" bIns="0">
+            <a:spAutoFit/>
+          </a:bodyPr>
+          <a:lstStyle/>
+          <a:p>
+            <a:r>
+              <a:rPr sz="1100" b="0">
+                <a:solidFill>
+                  <a:srgbClr val="CFE3E6"/>
+                </a:solidFill>
+                <a:latin typeface="Calibri"/>
+              </a:rPr>
+              <a:t>shubham.veer24@pcu.edu.in</a:t>
+            </a:r>
+          </a:p>
+        </p:txBody>
+      </p:sp>
+      <p:sp>
+        <p:nvSpPr>
+          <p:cNvPr id="25" name="Rounded Rectangle 24"/>
+          <p:cNvSpPr/>
+          <p:nvPr/>
+        </p:nvSpPr>
+        <p:spPr>
+          <a:xfrm>
+            <a:off x="8942832" y="3840480"/>
+            <a:ext cx="2697480" cy="2103120"/>
+          </a:xfrm>
+          <a:prstGeom prst="roundRect">
+            <a:avLst>
+              <a:gd name="adj" fmla="val 5000"/>
+            </a:avLst>
+          </a:prstGeom>
+          <a:solidFill>
+            <a:srgbClr val="0B4F5C"/>
+          </a:solidFill>
+          <a:ln>
+            <a:noFill/>
+          </a:ln>
+          <a:effectLst/>
+        </p:spPr>
+        <p:style>
+          <a:lnRef idx="1">
+            <a:schemeClr val="accent1"/>
+          </a:lnRef>
+          <a:fillRef idx="3">
+            <a:schemeClr val="accent1"/>
+          </a:fillRef>
+          <a:effectRef idx="2">
+            <a:schemeClr val="accent1"/>
+          </a:effectRef>
+          <a:fontRef idx="minor">
+            <a:schemeClr val="lt1"/>
+          </a:fontRef>
+        </p:style>
+        <p:txBody>
+          <a:bodyPr rtlCol="0" anchor="ctr"/>
+          <a:lstStyle/>
+          <a:p>
+            <a:pPr algn="ctr"/>
+          </a:p>
+        </p:txBody>
+      </p:sp>
+      <p:sp>
+        <p:nvSpPr>
+          <p:cNvPr id="26" name="Oval 25"/>
+          <p:cNvSpPr/>
+          <p:nvPr/>
+        </p:nvSpPr>
+        <p:spPr>
+          <a:xfrm>
+            <a:off x="9171432" y="4069080"/>
+            <a:ext cx="640080" cy="640080"/>
+          </a:xfrm>
+          <a:prstGeom prst="ellipse">
+            <a:avLst/>
+          </a:prstGeom>
+          <a:solidFill>
+            <a:srgbClr val="072C34"/>
+          </a:solidFill>
+          <a:ln>
+            <a:noFill/>
+          </a:ln>
+          <a:effectLst/>
+        </p:spPr>
+        <p:style>
+          <a:lnRef idx="1">
+            <a:schemeClr val="accent1"/>
+          </a:lnRef>
+          <a:fillRef idx="3">
+            <a:schemeClr val="accent1"/>
+          </a:fillRef>
+          <a:effectRef idx="2">
+            <a:schemeClr val="accent1"/>
+          </a:effectRef>
+          <a:fontRef idx="minor">
+            <a:schemeClr val="lt1"/>
+          </a:fontRef>
+        </p:style>
+        <p:txBody>
+          <a:bodyPr rtlCol="0" anchor="ctr"/>
+          <a:lstStyle/>
+          <a:p>
+            <a:pPr algn="ctr"/>
+          </a:p>
+        </p:txBody>
+      </p:sp>
+      <p:sp>
+        <p:nvSpPr>
+          <p:cNvPr id="27" name="TextBox 26"/>
+          <p:cNvSpPr txBox="1"/>
+          <p:nvPr/>
+        </p:nvSpPr>
+        <p:spPr>
+          <a:xfrm>
+            <a:off x="9171432" y="4069080"/>
+            <a:ext cx="640080" cy="640080"/>
+          </a:xfrm>
+          <a:prstGeom prst="rect">
+            <a:avLst/>
+          </a:prstGeom>
+          <a:noFill/>
+        </p:spPr>
+        <p:txBody>
+          <a:bodyPr wrap="square" anchor="ctr" lIns="0" rIns="0" tIns="0" bIns="0">
+            <a:spAutoFit/>
+          </a:bodyPr>
+          <a:lstStyle/>
+          <a:p>
+            <a:pPr algn="ctr"/>
+            <a:r>
+              <a:rPr sz="1600" b="1">
+                <a:solidFill>
+                  <a:srgbClr val="FFFFFF"/>
+                </a:solidFill>
+                <a:latin typeface="Calibri"/>
+              </a:rPr>
+              <a:t>LS</a:t>
+            </a:r>
+          </a:p>
+        </p:txBody>
+      </p:sp>
+      <p:sp>
+        <p:nvSpPr>
+          <p:cNvPr id="28" name="TextBox 27"/>
+          <p:cNvSpPr txBox="1"/>
+          <p:nvPr/>
+        </p:nvSpPr>
+        <p:spPr>
+          <a:xfrm>
+            <a:off x="9171432" y="4892040"/>
+            <a:ext cx="2331720" cy="320040"/>
+          </a:xfrm>
+          <a:prstGeom prst="rect">
+            <a:avLst/>
+          </a:prstGeom>
+          <a:noFill/>
+        </p:spPr>
+        <p:txBody>
+          <a:bodyPr wrap="square" anchor="t" lIns="0" rIns="0" tIns="0" bIns="0">
+            <a:spAutoFit/>
+          </a:bodyPr>
+          <a:lstStyle/>
+          <a:p>
+            <a:r>
+              <a:rPr sz="1700" b="1">
+                <a:solidFill>
+                  <a:srgbClr val="FFFFFF"/>
+                </a:solidFill>
+                <a:latin typeface="Calibri"/>
+              </a:rPr>
+              <a:t>Laksh Sorathiya</a:t>
+            </a:r>
+          </a:p>
+        </p:txBody>
+      </p:sp>
+      <p:sp>
+        <p:nvSpPr>
+          <p:cNvPr id="29" name="TextBox 28"/>
+          <p:cNvSpPr txBox="1"/>
+          <p:nvPr/>
+        </p:nvSpPr>
+        <p:spPr>
+          <a:xfrm>
+            <a:off x="9171432" y="5230368"/>
+            <a:ext cx="2331720" cy="274320"/>
+          </a:xfrm>
+          <a:prstGeom prst="rect">
+            <a:avLst/>
+          </a:prstGeom>
+          <a:noFill/>
+        </p:spPr>
+        <p:txBody>
+          <a:bodyPr wrap="square" anchor="t" lIns="0" rIns="0" tIns="0" bIns="0">
+            <a:spAutoFit/>
+          </a:bodyPr>
+          <a:lstStyle/>
+          <a:p>
+            <a:r>
+              <a:rPr sz="1100" b="0">
+                <a:solidFill>
+                  <a:srgbClr val="CFE3E6"/>
+                </a:solidFill>
+                <a:latin typeface="Calibri"/>
+              </a:rPr>
+              <a:t>Team Member</a:t>
+            </a:r>
+          </a:p>
+        </p:txBody>
+      </p:sp>
+      <p:sp>
+        <p:nvSpPr>
+          <p:cNvPr id="30" name="TextBox 29"/>
+          <p:cNvSpPr txBox="1"/>
+          <p:nvPr/>
+        </p:nvSpPr>
+        <p:spPr>
+          <a:xfrm>
+            <a:off x="9171432" y="5532120"/>
+            <a:ext cx="2331720" cy="274320"/>
+          </a:xfrm>
+          <a:prstGeom prst="rect">
+            <a:avLst/>
+          </a:prstGeom>
+          <a:noFill/>
+        </p:spPr>
+        <p:txBody>
+          <a:bodyPr wrap="square" anchor="t" lIns="0" rIns="0" tIns="0" bIns="0">
+            <a:spAutoFit/>
+          </a:bodyPr>
+          <a:lstStyle/>
+          <a:p>
+            <a:r>
+              <a:rPr sz="1100" b="0">
+                <a:solidFill>
+                  <a:srgbClr val="CFE3E6"/>
+                </a:solidFill>
+                <a:latin typeface="Calibri"/>
+              </a:rPr>
+              <a:t>sorathiyalaksh37@gmail.com</a:t>
+            </a:r>
+          </a:p>
+        </p:txBody>
+      </p:sp>
+    </p:spTree>
+  </p:cSld>
+  <p:clrMapOvr>
+    <a:masterClrMapping/>
+  </p:clrMapOvr>
+</p:sld>
+</file>
+
+<file path=ppt/slides/slide2.xml><?xml version="1.0" encoding="utf-8"?>
 <p:sld xmlns:a="http://schemas.openxmlformats.org/drawingml/2006/main" xmlns:r="http://schemas.openxmlformats.org/officeDocument/2006/relationships" xmlns:p="http://schemas.openxmlformats.org/presentationml/2006/main">
   <p:cSld name="Slide 1">
     <p:bg>
@@ -1899,7 +3074,7 @@
 </p:sld>
 </file>
 
-<file path=ppt/slides/slide2.xml><?xml version="1.0" encoding="utf-8"?>
+<file path=ppt/slides/slide3.xml><?xml version="1.0" encoding="utf-8"?>
 <p:sld xmlns:a="http://schemas.openxmlformats.org/drawingml/2006/main" xmlns:p="http://schemas.openxmlformats.org/presentationml/2006/main" xmlns:r="http://schemas.openxmlformats.org/officeDocument/2006/relationships">
   <p:cSld>
     <p:bg>
@@ -2726,7 +3901,7 @@
 </p:sld>
 </file>
 
-<file path=ppt/slides/slide3.xml><?xml version="1.0" encoding="utf-8"?>
+<file path=ppt/slides/slide4.xml><?xml version="1.0" encoding="utf-8"?>
 <p:sld xmlns:a="http://schemas.openxmlformats.org/drawingml/2006/main" xmlns:r="http://schemas.openxmlformats.org/officeDocument/2006/relationships" xmlns:p="http://schemas.openxmlformats.org/presentationml/2006/main">
   <p:cSld name="Slide 2">
     <p:bg>
@@ -4112,7 +5287,7 @@
 </p:sld>
 </file>
 
-<file path=ppt/slides/slide4.xml><?xml version="1.0" encoding="utf-8"?>
+<file path=ppt/slides/slide5.xml><?xml version="1.0" encoding="utf-8"?>
 <p:sld xmlns:a="http://schemas.openxmlformats.org/drawingml/2006/main" xmlns:r="http://schemas.openxmlformats.org/officeDocument/2006/relationships" xmlns:p="http://schemas.openxmlformats.org/presentationml/2006/main">
   <p:cSld name="Slide 3">
     <p:bg>
@@ -5790,7 +6965,7 @@
 </p:sld>
 </file>
 
-<file path=ppt/slides/slide5.xml><?xml version="1.0" encoding="utf-8"?>
+<file path=ppt/slides/slide6.xml><?xml version="1.0" encoding="utf-8"?>
 <p:sld xmlns:a="http://schemas.openxmlformats.org/drawingml/2006/main" xmlns:r="http://schemas.openxmlformats.org/officeDocument/2006/relationships" xmlns:p="http://schemas.openxmlformats.org/presentationml/2006/main">
   <p:cSld name="Slide 4">
     <p:bg>
@@ -6449,7 +7624,7 @@
 </p:sld>
 </file>
 
-<file path=ppt/slides/slide6.xml><?xml version="1.0" encoding="utf-8"?>
+<file path=ppt/slides/slide7.xml><?xml version="1.0" encoding="utf-8"?>
 <p:sld xmlns:a="http://schemas.openxmlformats.org/drawingml/2006/main" xmlns:r="http://schemas.openxmlformats.org/officeDocument/2006/relationships" xmlns:p="http://schemas.openxmlformats.org/presentationml/2006/main">
   <p:cSld name="Slide 5">
     <p:bg>
@@ -7545,7 +8720,1036 @@
 </p:sld>
 </file>
 
-<file path=ppt/slides/slide7.xml><?xml version="1.0" encoding="utf-8"?>
+<file path=ppt/slides/slide8.xml><?xml version="1.0" encoding="utf-8"?>
+<p:sld xmlns:a="http://schemas.openxmlformats.org/drawingml/2006/main" xmlns:p="http://schemas.openxmlformats.org/presentationml/2006/main" xmlns:r="http://schemas.openxmlformats.org/officeDocument/2006/relationships">
+  <p:cSld>
+    <p:bg>
+      <p:bgPr>
+        <a:solidFill>
+          <a:srgbClr val="FFFFFF"/>
+        </a:solidFill>
+        <a:effectLst/>
+      </p:bgPr>
+    </p:bg>
+    <p:spTree>
+      <p:nvGrpSpPr>
+        <p:cNvPr id="1" name=""/>
+        <p:cNvGrpSpPr/>
+        <p:nvPr/>
+      </p:nvGrpSpPr>
+      <p:grpSpPr/>
+      <p:sp>
+        <p:nvSpPr>
+          <p:cNvPr id="2" name="TextBox 1"/>
+          <p:cNvSpPr txBox="1"/>
+          <p:nvPr/>
+        </p:nvSpPr>
+        <p:spPr>
+          <a:xfrm>
+            <a:off x="548640" y="365760"/>
+            <a:ext cx="8778240" cy="777240"/>
+          </a:xfrm>
+          <a:prstGeom prst="rect">
+            <a:avLst/>
+          </a:prstGeom>
+          <a:noFill/>
+        </p:spPr>
+        <p:txBody>
+          <a:bodyPr wrap="square" lIns="0" rIns="0" tIns="0" bIns="0" anchor="ctr">
+            <a:spAutoFit/>
+          </a:bodyPr>
+          <a:lstStyle/>
+          <a:p>
+            <a:pPr>
+              <a:spcAft>
+                <a:spcPts val="400"/>
+              </a:spcAft>
+            </a:pPr>
+            <a:r>
+              <a:rPr sz="3400" b="1">
+                <a:solidFill>
+                  <a:srgbClr val="14232B"/>
+                </a:solidFill>
+                <a:latin typeface="Cambria"/>
+              </a:rPr>
+              <a:t>BRICS: one infrastructure lens</a:t>
+            </a:r>
+          </a:p>
+        </p:txBody>
+      </p:sp>
+      <p:sp>
+        <p:nvSpPr>
+          <p:cNvPr id="3" name="Rounded Rectangle 2"/>
+          <p:cNvSpPr/>
+          <p:nvPr/>
+        </p:nvSpPr>
+        <p:spPr>
+          <a:xfrm>
+            <a:off x="9555480" y="566928"/>
+            <a:ext cx="2084831" cy="365760"/>
+          </a:xfrm>
+          <a:prstGeom prst="roundRect">
+            <a:avLst>
+              <a:gd name="adj" fmla="val 50000"/>
+            </a:avLst>
+          </a:prstGeom>
+          <a:solidFill>
+            <a:srgbClr val="E08A1E"/>
+          </a:solidFill>
+          <a:ln>
+            <a:noFill/>
+          </a:ln>
+          <a:effectLst/>
+        </p:spPr>
+        <p:style>
+          <a:lnRef idx="1">
+            <a:schemeClr val="accent1"/>
+          </a:lnRef>
+          <a:fillRef idx="3">
+            <a:schemeClr val="accent1"/>
+          </a:fillRef>
+          <a:effectRef idx="2">
+            <a:schemeClr val="accent1"/>
+          </a:effectRef>
+          <a:fontRef idx="minor">
+            <a:schemeClr val="lt1"/>
+          </a:fontRef>
+        </p:style>
+        <p:txBody>
+          <a:bodyPr rtlCol="0" anchor="ctr"/>
+          <a:lstStyle/>
+          <a:p>
+            <a:pPr algn="ctr"/>
+          </a:p>
+        </p:txBody>
+      </p:sp>
+      <p:sp>
+        <p:nvSpPr>
+          <p:cNvPr id="4" name="TextBox 3"/>
+          <p:cNvSpPr txBox="1"/>
+          <p:nvPr/>
+        </p:nvSpPr>
+        <p:spPr>
+          <a:xfrm>
+            <a:off x="9555480" y="566928"/>
+            <a:ext cx="2084831" cy="365760"/>
+          </a:xfrm>
+          <a:prstGeom prst="rect">
+            <a:avLst/>
+          </a:prstGeom>
+          <a:noFill/>
+        </p:spPr>
+        <p:txBody>
+          <a:bodyPr wrap="square" lIns="0" rIns="0" tIns="0" bIns="0" anchor="ctr">
+            <a:spAutoFit/>
+          </a:bodyPr>
+          <a:lstStyle/>
+          <a:p>
+            <a:pPr algn="ctr">
+              <a:spcAft>
+                <a:spcPts val="400"/>
+              </a:spcAft>
+            </a:pPr>
+            <a:r>
+              <a:rPr sz="1100" b="1">
+                <a:solidFill>
+                  <a:srgbClr val="FFFFFF"/>
+                </a:solidFill>
+                <a:latin typeface="Calibri"/>
+              </a:rPr>
+              <a:t>PROPOSED · NOT BUILT</a:t>
+            </a:r>
+          </a:p>
+        </p:txBody>
+      </p:sp>
+      <p:sp>
+        <p:nvSpPr>
+          <p:cNvPr id="5" name="TextBox 4"/>
+          <p:cNvSpPr txBox="1"/>
+          <p:nvPr/>
+        </p:nvSpPr>
+        <p:spPr>
+          <a:xfrm>
+            <a:off x="548640" y="1115568"/>
+            <a:ext cx="11064240" cy="365760"/>
+          </a:xfrm>
+          <a:prstGeom prst="rect">
+            <a:avLst/>
+          </a:prstGeom>
+          <a:noFill/>
+        </p:spPr>
+        <p:txBody>
+          <a:bodyPr wrap="square" lIns="0" rIns="0" tIns="0" bIns="0" anchor="t">
+            <a:spAutoFit/>
+          </a:bodyPr>
+          <a:lstStyle/>
+          <a:p>
+            <a:pPr>
+              <a:spcAft>
+                <a:spcPts val="400"/>
+              </a:spcAft>
+            </a:pPr>
+            <a:r>
+              <a:rPr sz="1500" b="0">
+                <a:solidFill>
+                  <a:srgbClr val="5B6B72"/>
+                </a:solidFill>
+                <a:latin typeface="Calibri"/>
+              </a:rPr>
+              <a:t>Today INFRA-AI covers India only. Here is what the same platform could do for BRICS, and what should come first.</a:t>
+            </a:r>
+          </a:p>
+        </p:txBody>
+      </p:sp>
+      <p:sp>
+        <p:nvSpPr>
+          <p:cNvPr id="6" name="Rounded Rectangle 5"/>
+          <p:cNvSpPr/>
+          <p:nvPr/>
+        </p:nvSpPr>
+        <p:spPr>
+          <a:xfrm>
+            <a:off x="548640" y="1783080"/>
+            <a:ext cx="3566160" cy="3977639"/>
+          </a:xfrm>
+          <a:prstGeom prst="roundRect">
+            <a:avLst>
+              <a:gd name="adj" fmla="val 2564"/>
+            </a:avLst>
+          </a:prstGeom>
+          <a:solidFill>
+            <a:srgbClr val="EAF2F3"/>
+          </a:solidFill>
+          <a:ln>
+            <a:noFill/>
+          </a:ln>
+          <a:effectLst/>
+        </p:spPr>
+        <p:style>
+          <a:lnRef idx="1">
+            <a:schemeClr val="accent1"/>
+          </a:lnRef>
+          <a:fillRef idx="3">
+            <a:schemeClr val="accent1"/>
+          </a:fillRef>
+          <a:effectRef idx="2">
+            <a:schemeClr val="accent1"/>
+          </a:effectRef>
+          <a:fontRef idx="minor">
+            <a:schemeClr val="lt1"/>
+          </a:fontRef>
+        </p:style>
+        <p:txBody>
+          <a:bodyPr rtlCol="0" anchor="ctr"/>
+          <a:lstStyle/>
+          <a:p>
+            <a:pPr algn="ctr"/>
+          </a:p>
+        </p:txBody>
+      </p:sp>
+      <p:sp>
+        <p:nvSpPr>
+          <p:cNvPr id="7" name="Oval 6"/>
+          <p:cNvSpPr/>
+          <p:nvPr/>
+        </p:nvSpPr>
+        <p:spPr>
+          <a:xfrm>
+            <a:off x="731520" y="1984248"/>
+            <a:ext cx="146304" cy="146304"/>
+          </a:xfrm>
+          <a:prstGeom prst="ellipse">
+            <a:avLst/>
+          </a:prstGeom>
+          <a:solidFill>
+            <a:srgbClr val="0B4F5C"/>
+          </a:solidFill>
+          <a:ln>
+            <a:noFill/>
+          </a:ln>
+          <a:effectLst/>
+        </p:spPr>
+        <p:style>
+          <a:lnRef idx="1">
+            <a:schemeClr val="accent1"/>
+          </a:lnRef>
+          <a:fillRef idx="3">
+            <a:schemeClr val="accent1"/>
+          </a:fillRef>
+          <a:effectRef idx="2">
+            <a:schemeClr val="accent1"/>
+          </a:effectRef>
+          <a:fontRef idx="minor">
+            <a:schemeClr val="lt1"/>
+          </a:fontRef>
+        </p:style>
+        <p:txBody>
+          <a:bodyPr rtlCol="0" anchor="ctr"/>
+          <a:lstStyle/>
+          <a:p>
+            <a:pPr algn="ctr"/>
+          </a:p>
+        </p:txBody>
+      </p:sp>
+      <p:sp>
+        <p:nvSpPr>
+          <p:cNvPr id="8" name="TextBox 7"/>
+          <p:cNvSpPr txBox="1"/>
+          <p:nvPr/>
+        </p:nvSpPr>
+        <p:spPr>
+          <a:xfrm>
+            <a:off x="1005840" y="1901952"/>
+            <a:ext cx="2926080" cy="329184"/>
+          </a:xfrm>
+          <a:prstGeom prst="rect">
+            <a:avLst/>
+          </a:prstGeom>
+          <a:noFill/>
+        </p:spPr>
+        <p:txBody>
+          <a:bodyPr wrap="square" lIns="0" rIns="0" tIns="0" bIns="0" anchor="ctr">
+            <a:spAutoFit/>
+          </a:bodyPr>
+          <a:lstStyle/>
+          <a:p>
+            <a:pPr>
+              <a:spcAft>
+                <a:spcPts val="400"/>
+              </a:spcAft>
+            </a:pPr>
+            <a:r>
+              <a:rPr sz="1700" b="1">
+                <a:solidFill>
+                  <a:srgbClr val="14232B"/>
+                </a:solidFill>
+                <a:latin typeface="Cambria"/>
+              </a:rPr>
+              <a:t>Why it can travel</a:t>
+            </a:r>
+          </a:p>
+        </p:txBody>
+      </p:sp>
+      <p:sp>
+        <p:nvSpPr>
+          <p:cNvPr id="9" name="TextBox 8"/>
+          <p:cNvSpPr txBox="1"/>
+          <p:nvPr/>
+        </p:nvSpPr>
+        <p:spPr>
+          <a:xfrm>
+            <a:off x="777240" y="2468880"/>
+            <a:ext cx="3108960" cy="3200400"/>
+          </a:xfrm>
+          <a:prstGeom prst="rect">
+            <a:avLst/>
+          </a:prstGeom>
+          <a:noFill/>
+        </p:spPr>
+        <p:txBody>
+          <a:bodyPr wrap="square" lIns="0" rIns="0" tIns="0" bIns="0" anchor="t">
+            <a:spAutoFit/>
+          </a:bodyPr>
+          <a:lstStyle/>
+          <a:p>
+            <a:pPr marL="171450" indent="-171450">
+              <a:spcAft>
+                <a:spcPts val="700"/>
+              </a:spcAft>
+              <a:buChar char="•"/>
+            </a:pPr>
+            <a:r>
+              <a:rPr sz="1400" b="0">
+                <a:solidFill>
+                  <a:srgbClr val="14232B"/>
+                </a:solidFill>
+                <a:latin typeface="Calibri"/>
+              </a:rPr>
+              <a:t>Core is city- and field-agnostic: a new place is one config file, not new code</a:t>
+            </a:r>
+          </a:p>
+          <a:p>
+            <a:pPr marL="171450" indent="-171450">
+              <a:spcAft>
+                <a:spcPts val="700"/>
+              </a:spcAft>
+              <a:buChar char="•"/>
+            </a:pPr>
+            <a:r>
+              <a:rPr sz="1400" b="0">
+                <a:solidFill>
+                  <a:srgbClr val="14232B"/>
+                </a:solidFill>
+                <a:latin typeface="Calibri"/>
+              </a:rPr>
+              <a:t>Built on global open data: OSM, WorldPop, GHSL, night lights</a:t>
+            </a:r>
+          </a:p>
+          <a:p>
+            <a:pPr marL="171450" indent="-171450">
+              <a:spcAft>
+                <a:spcPts val="700"/>
+              </a:spcAft>
+              <a:buChar char="•"/>
+            </a:pPr>
+            <a:r>
+              <a:rPr sz="1400" b="0">
+                <a:solidFill>
+                  <a:srgbClr val="14232B"/>
+                </a:solidFill>
+                <a:latin typeface="Calibri"/>
+              </a:rPr>
+              <a:t>Open source DPG, open standards, swappable AI providers</a:t>
+            </a:r>
+          </a:p>
+          <a:p>
+            <a:pPr marL="171450" indent="-171450">
+              <a:spcAft>
+                <a:spcPts val="700"/>
+              </a:spcAft>
+              <a:buChar char="•"/>
+            </a:pPr>
+            <a:r>
+              <a:rPr sz="1400" b="0">
+                <a:solidFill>
+                  <a:srgbClr val="14232B"/>
+                </a:solidFill>
+                <a:latin typeface="Calibri"/>
+              </a:rPr>
+              <a:t>Language picker already groups Portuguese, Russian and Chinese as BRICS / international</a:t>
+            </a:r>
+          </a:p>
+        </p:txBody>
+      </p:sp>
+      <p:sp>
+        <p:nvSpPr>
+          <p:cNvPr id="10" name="Rounded Rectangle 9"/>
+          <p:cNvSpPr/>
+          <p:nvPr/>
+        </p:nvSpPr>
+        <p:spPr>
+          <a:xfrm>
+            <a:off x="4311396" y="1783080"/>
+            <a:ext cx="3566160" cy="3977639"/>
+          </a:xfrm>
+          <a:prstGeom prst="roundRect">
+            <a:avLst>
+              <a:gd name="adj" fmla="val 2564"/>
+            </a:avLst>
+          </a:prstGeom>
+          <a:solidFill>
+            <a:srgbClr val="EAF2F3"/>
+          </a:solidFill>
+          <a:ln>
+            <a:noFill/>
+          </a:ln>
+          <a:effectLst/>
+        </p:spPr>
+        <p:style>
+          <a:lnRef idx="1">
+            <a:schemeClr val="accent1"/>
+          </a:lnRef>
+          <a:fillRef idx="3">
+            <a:schemeClr val="accent1"/>
+          </a:fillRef>
+          <a:effectRef idx="2">
+            <a:schemeClr val="accent1"/>
+          </a:effectRef>
+          <a:fontRef idx="minor">
+            <a:schemeClr val="lt1"/>
+          </a:fontRef>
+        </p:style>
+        <p:txBody>
+          <a:bodyPr rtlCol="0" anchor="ctr"/>
+          <a:lstStyle/>
+          <a:p>
+            <a:pPr algn="ctr"/>
+          </a:p>
+        </p:txBody>
+      </p:sp>
+      <p:sp>
+        <p:nvSpPr>
+          <p:cNvPr id="11" name="Oval 10"/>
+          <p:cNvSpPr/>
+          <p:nvPr/>
+        </p:nvSpPr>
+        <p:spPr>
+          <a:xfrm>
+            <a:off x="4494276" y="1984248"/>
+            <a:ext cx="146304" cy="146304"/>
+          </a:xfrm>
+          <a:prstGeom prst="ellipse">
+            <a:avLst/>
+          </a:prstGeom>
+          <a:solidFill>
+            <a:srgbClr val="0B4F5C"/>
+          </a:solidFill>
+          <a:ln>
+            <a:noFill/>
+          </a:ln>
+          <a:effectLst/>
+        </p:spPr>
+        <p:style>
+          <a:lnRef idx="1">
+            <a:schemeClr val="accent1"/>
+          </a:lnRef>
+          <a:fillRef idx="3">
+            <a:schemeClr val="accent1"/>
+          </a:fillRef>
+          <a:effectRef idx="2">
+            <a:schemeClr val="accent1"/>
+          </a:effectRef>
+          <a:fontRef idx="minor">
+            <a:schemeClr val="lt1"/>
+          </a:fontRef>
+        </p:style>
+        <p:txBody>
+          <a:bodyPr rtlCol="0" anchor="ctr"/>
+          <a:lstStyle/>
+          <a:p>
+            <a:pPr algn="ctr"/>
+          </a:p>
+        </p:txBody>
+      </p:sp>
+      <p:sp>
+        <p:nvSpPr>
+          <p:cNvPr id="12" name="TextBox 11"/>
+          <p:cNvSpPr txBox="1"/>
+          <p:nvPr/>
+        </p:nvSpPr>
+        <p:spPr>
+          <a:xfrm>
+            <a:off x="4768596" y="1901952"/>
+            <a:ext cx="2926080" cy="329184"/>
+          </a:xfrm>
+          <a:prstGeom prst="rect">
+            <a:avLst/>
+          </a:prstGeom>
+          <a:noFill/>
+        </p:spPr>
+        <p:txBody>
+          <a:bodyPr wrap="square" lIns="0" rIns="0" tIns="0" bIns="0" anchor="ctr">
+            <a:spAutoFit/>
+          </a:bodyPr>
+          <a:lstStyle/>
+          <a:p>
+            <a:pPr>
+              <a:spcAft>
+                <a:spcPts val="400"/>
+              </a:spcAft>
+            </a:pPr>
+            <a:r>
+              <a:rPr sz="1700" b="1">
+                <a:solidFill>
+                  <a:srgbClr val="14232B"/>
+                </a:solidFill>
+                <a:latin typeface="Cambria"/>
+              </a:rPr>
+              <a:t>What we can do</a:t>
+            </a:r>
+          </a:p>
+        </p:txBody>
+      </p:sp>
+      <p:sp>
+        <p:nvSpPr>
+          <p:cNvPr id="13" name="TextBox 12"/>
+          <p:cNvSpPr txBox="1"/>
+          <p:nvPr/>
+        </p:nvSpPr>
+        <p:spPr>
+          <a:xfrm>
+            <a:off x="4539996" y="2468880"/>
+            <a:ext cx="3108960" cy="3200400"/>
+          </a:xfrm>
+          <a:prstGeom prst="rect">
+            <a:avLst/>
+          </a:prstGeom>
+          <a:noFill/>
+        </p:spPr>
+        <p:txBody>
+          <a:bodyPr wrap="square" lIns="0" rIns="0" tIns="0" bIns="0" anchor="t">
+            <a:spAutoFit/>
+          </a:bodyPr>
+          <a:lstStyle/>
+          <a:p>
+            <a:pPr marL="171450" indent="-171450">
+              <a:spcAft>
+                <a:spcPts val="700"/>
+              </a:spcAft>
+              <a:buChar char="•"/>
+            </a:pPr>
+            <a:r>
+              <a:rPr sz="1400" b="0">
+                <a:solidFill>
+                  <a:srgbClr val="14232B"/>
+                </a:solidFill>
+                <a:latin typeface="Calibri"/>
+              </a:rPr>
+              <a:t>Pilot one city per member: for example Brazil, Russia, China, South Africa</a:t>
+            </a:r>
+          </a:p>
+          <a:p>
+            <a:pPr marL="171450" indent="-171450">
+              <a:spcAft>
+                <a:spcPts val="700"/>
+              </a:spcAft>
+              <a:buChar char="•"/>
+            </a:pPr>
+            <a:r>
+              <a:rPr sz="1400" b="0">
+                <a:solidFill>
+                  <a:srgbClr val="14232B"/>
+                </a:solidFill>
+                <a:latin typeface="Calibri"/>
+              </a:rPr>
+              <a:t>Same explainable scores everywhere, so access to highways, metro and rail is comparable</a:t>
+            </a:r>
+          </a:p>
+          <a:p>
+            <a:pPr marL="171450" indent="-171450">
+              <a:spcAft>
+                <a:spcPts val="700"/>
+              </a:spcAft>
+              <a:buChar char="•"/>
+            </a:pPr>
+            <a:r>
+              <a:rPr sz="1400" b="0">
+                <a:solidFill>
+                  <a:srgbClr val="14232B"/>
+                </a:solidFill>
+                <a:latin typeface="Calibri"/>
+              </a:rPr>
+              <a:t>Voice and text intake in each national language on the existing pipeline</a:t>
+            </a:r>
+          </a:p>
+          <a:p>
+            <a:pPr marL="171450" indent="-171450">
+              <a:spcAft>
+                <a:spcPts val="700"/>
+              </a:spcAft>
+              <a:buChar char="•"/>
+            </a:pPr>
+            <a:r>
+              <a:rPr sz="1400" b="0">
+                <a:solidFill>
+                  <a:srgbClr val="14232B"/>
+                </a:solidFill>
+                <a:latin typeface="Calibri"/>
+              </a:rPr>
+              <a:t>Share the toolkit as a DPG through BRICS forums, so each country runs its own copy</a:t>
+            </a:r>
+          </a:p>
+        </p:txBody>
+      </p:sp>
+      <p:sp>
+        <p:nvSpPr>
+          <p:cNvPr id="14" name="Rounded Rectangle 13"/>
+          <p:cNvSpPr/>
+          <p:nvPr/>
+        </p:nvSpPr>
+        <p:spPr>
+          <a:xfrm>
+            <a:off x="8074152" y="1783080"/>
+            <a:ext cx="3566160" cy="3977639"/>
+          </a:xfrm>
+          <a:prstGeom prst="roundRect">
+            <a:avLst>
+              <a:gd name="adj" fmla="val 2564"/>
+            </a:avLst>
+          </a:prstGeom>
+          <a:solidFill>
+            <a:srgbClr val="EAF2F3"/>
+          </a:solidFill>
+          <a:ln>
+            <a:noFill/>
+          </a:ln>
+          <a:effectLst/>
+        </p:spPr>
+        <p:style>
+          <a:lnRef idx="1">
+            <a:schemeClr val="accent1"/>
+          </a:lnRef>
+          <a:fillRef idx="3">
+            <a:schemeClr val="accent1"/>
+          </a:fillRef>
+          <a:effectRef idx="2">
+            <a:schemeClr val="accent1"/>
+          </a:effectRef>
+          <a:fontRef idx="minor">
+            <a:schemeClr val="lt1"/>
+          </a:fontRef>
+        </p:style>
+        <p:txBody>
+          <a:bodyPr rtlCol="0" anchor="ctr"/>
+          <a:lstStyle/>
+          <a:p>
+            <a:pPr algn="ctr"/>
+          </a:p>
+        </p:txBody>
+      </p:sp>
+      <p:sp>
+        <p:nvSpPr>
+          <p:cNvPr id="15" name="Oval 14"/>
+          <p:cNvSpPr/>
+          <p:nvPr/>
+        </p:nvSpPr>
+        <p:spPr>
+          <a:xfrm>
+            <a:off x="8257031" y="1984248"/>
+            <a:ext cx="146304" cy="146304"/>
+          </a:xfrm>
+          <a:prstGeom prst="ellipse">
+            <a:avLst/>
+          </a:prstGeom>
+          <a:solidFill>
+            <a:srgbClr val="E08A1E"/>
+          </a:solidFill>
+          <a:ln>
+            <a:noFill/>
+          </a:ln>
+          <a:effectLst/>
+        </p:spPr>
+        <p:style>
+          <a:lnRef idx="1">
+            <a:schemeClr val="accent1"/>
+          </a:lnRef>
+          <a:fillRef idx="3">
+            <a:schemeClr val="accent1"/>
+          </a:fillRef>
+          <a:effectRef idx="2">
+            <a:schemeClr val="accent1"/>
+          </a:effectRef>
+          <a:fontRef idx="minor">
+            <a:schemeClr val="lt1"/>
+          </a:fontRef>
+        </p:style>
+        <p:txBody>
+          <a:bodyPr rtlCol="0" anchor="ctr"/>
+          <a:lstStyle/>
+          <a:p>
+            <a:pPr algn="ctr"/>
+          </a:p>
+        </p:txBody>
+      </p:sp>
+      <p:sp>
+        <p:nvSpPr>
+          <p:cNvPr id="16" name="TextBox 15"/>
+          <p:cNvSpPr txBox="1"/>
+          <p:nvPr/>
+        </p:nvSpPr>
+        <p:spPr>
+          <a:xfrm>
+            <a:off x="8531352" y="1901952"/>
+            <a:ext cx="2926080" cy="329184"/>
+          </a:xfrm>
+          <a:prstGeom prst="rect">
+            <a:avLst/>
+          </a:prstGeom>
+          <a:noFill/>
+        </p:spPr>
+        <p:txBody>
+          <a:bodyPr wrap="square" lIns="0" rIns="0" tIns="0" bIns="0" anchor="ctr">
+            <a:spAutoFit/>
+          </a:bodyPr>
+          <a:lstStyle/>
+          <a:p>
+            <a:pPr>
+              <a:spcAft>
+                <a:spcPts val="400"/>
+              </a:spcAft>
+            </a:pPr>
+            <a:r>
+              <a:rPr sz="1700" b="1">
+                <a:solidFill>
+                  <a:srgbClr val="14232B"/>
+                </a:solidFill>
+                <a:latin typeface="Cambria"/>
+              </a:rPr>
+              <a:t>What we should do first</a:t>
+            </a:r>
+          </a:p>
+        </p:txBody>
+      </p:sp>
+      <p:sp>
+        <p:nvSpPr>
+          <p:cNvPr id="17" name="TextBox 16"/>
+          <p:cNvSpPr txBox="1"/>
+          <p:nvPr/>
+        </p:nvSpPr>
+        <p:spPr>
+          <a:xfrm>
+            <a:off x="8302752" y="2468880"/>
+            <a:ext cx="3108960" cy="3200400"/>
+          </a:xfrm>
+          <a:prstGeom prst="rect">
+            <a:avLst/>
+          </a:prstGeom>
+          <a:noFill/>
+        </p:spPr>
+        <p:txBody>
+          <a:bodyPr wrap="square" lIns="0" rIns="0" tIns="0" bIns="0" anchor="t">
+            <a:spAutoFit/>
+          </a:bodyPr>
+          <a:lstStyle/>
+          <a:p>
+            <a:pPr marL="171450" indent="-171450">
+              <a:spcAft>
+                <a:spcPts val="700"/>
+              </a:spcAft>
+              <a:buChar char="•"/>
+            </a:pPr>
+            <a:r>
+              <a:rPr sz="1400" b="0">
+                <a:solidFill>
+                  <a:srgbClr val="14232B"/>
+                </a:solidFill>
+                <a:latin typeface="Calibri"/>
+              </a:rPr>
+              <a:t>Write an ADR: scope today is India only (ADR-0013)</a:t>
+            </a:r>
+          </a:p>
+          <a:p>
+            <a:pPr marL="171450" indent="-171450">
+              <a:spcAft>
+                <a:spcPts val="700"/>
+              </a:spcAft>
+              <a:buChar char="•"/>
+            </a:pPr>
+            <a:r>
+              <a:rPr sz="1400" b="0">
+                <a:solidFill>
+                  <a:srgbClr val="14232B"/>
+                </a:solidFill>
+                <a:latin typeface="Calibri"/>
+              </a:rPr>
+              <a:t>Check licences per country before ingesting any data</a:t>
+            </a:r>
+          </a:p>
+          <a:p>
+            <a:pPr marL="171450" indent="-171450">
+              <a:spcAft>
+                <a:spcPts val="700"/>
+              </a:spcAft>
+              <a:buChar char="•"/>
+            </a:pPr>
+            <a:r>
+              <a:rPr sz="1400" b="0">
+                <a:solidFill>
+                  <a:srgbClr val="14232B"/>
+                </a:solidFill>
+                <a:latin typeface="Calibri"/>
+              </a:rPr>
+              <a:t>Swap in each country's official boundaries; India's come from Survey of India</a:t>
+            </a:r>
+          </a:p>
+          <a:p>
+            <a:pPr marL="171450" indent="-171450">
+              <a:spcAft>
+                <a:spcPts val="700"/>
+              </a:spcAft>
+              <a:buChar char="•"/>
+            </a:pPr>
+            <a:r>
+              <a:rPr sz="1400" b="0">
+                <a:solidFill>
+                  <a:srgbClr val="14232B"/>
+                </a:solidFill>
+                <a:latin typeface="Calibri"/>
+              </a:rPr>
+              <a:t>Map privacy law per country (LGPD, 152-FZ, PIPL, POPIA) before any citizen data</a:t>
+            </a:r>
+          </a:p>
+          <a:p>
+            <a:pPr marL="171450" indent="-171450">
+              <a:spcAft>
+                <a:spcPts val="700"/>
+              </a:spcAft>
+              <a:buChar char="•"/>
+            </a:pPr>
+            <a:r>
+              <a:rPr sz="1400" b="0">
+                <a:solidFill>
+                  <a:srgbClr val="14232B"/>
+                </a:solidFill>
+                <a:latin typeface="Calibri"/>
+              </a:rPr>
+              <a:t>Measure language quality with a gold set per language before launch</a:t>
+            </a:r>
+          </a:p>
+        </p:txBody>
+      </p:sp>
+      <p:sp>
+        <p:nvSpPr>
+          <p:cNvPr id="18" name="Rounded Rectangle 17"/>
+          <p:cNvSpPr/>
+          <p:nvPr/>
+        </p:nvSpPr>
+        <p:spPr>
+          <a:xfrm>
+            <a:off x="548640" y="5897880"/>
+            <a:ext cx="11091672" cy="411480"/>
+          </a:xfrm>
+          <a:prstGeom prst="roundRect">
+            <a:avLst>
+              <a:gd name="adj" fmla="val 22222"/>
+            </a:avLst>
+          </a:prstGeom>
+          <a:solidFill>
+            <a:srgbClr val="072C34"/>
+          </a:solidFill>
+          <a:ln>
+            <a:noFill/>
+          </a:ln>
+          <a:effectLst/>
+        </p:spPr>
+        <p:style>
+          <a:lnRef idx="1">
+            <a:schemeClr val="accent1"/>
+          </a:lnRef>
+          <a:fillRef idx="3">
+            <a:schemeClr val="accent1"/>
+          </a:fillRef>
+          <a:effectRef idx="2">
+            <a:schemeClr val="accent1"/>
+          </a:effectRef>
+          <a:fontRef idx="minor">
+            <a:schemeClr val="lt1"/>
+          </a:fontRef>
+        </p:style>
+        <p:txBody>
+          <a:bodyPr rtlCol="0" anchor="ctr"/>
+          <a:lstStyle/>
+          <a:p>
+            <a:pPr algn="ctr"/>
+          </a:p>
+        </p:txBody>
+      </p:sp>
+      <p:sp>
+        <p:nvSpPr>
+          <p:cNvPr id="19" name="TextBox 18"/>
+          <p:cNvSpPr txBox="1"/>
+          <p:nvPr/>
+        </p:nvSpPr>
+        <p:spPr>
+          <a:xfrm>
+            <a:off x="777240" y="5897880"/>
+            <a:ext cx="10698480" cy="411480"/>
+          </a:xfrm>
+          <a:prstGeom prst="rect">
+            <a:avLst/>
+          </a:prstGeom>
+          <a:noFill/>
+        </p:spPr>
+        <p:txBody>
+          <a:bodyPr wrap="square" lIns="0" rIns="0" tIns="0" bIns="0" anchor="ctr">
+            <a:spAutoFit/>
+          </a:bodyPr>
+          <a:lstStyle/>
+          <a:p>
+            <a:pPr>
+              <a:spcAft>
+                <a:spcPts val="400"/>
+              </a:spcAft>
+            </a:pPr>
+            <a:r>
+              <a:rPr sz="1200" b="0">
+                <a:solidFill>
+                  <a:srgbClr val="CFE3E6"/>
+                </a:solidFill>
+                <a:latin typeface="Calibri"/>
+              </a:rPr>
+              <a:t>Scores describe existing infrastructure, never rank countries. Nothing here is built or promised yet.</a:t>
+            </a:r>
+          </a:p>
+        </p:txBody>
+      </p:sp>
+      <p:sp>
+        <p:nvSpPr>
+          <p:cNvPr id="20" name="TextBox 19"/>
+          <p:cNvSpPr txBox="1"/>
+          <p:nvPr/>
+        </p:nvSpPr>
+        <p:spPr>
+          <a:xfrm>
+            <a:off x="548640" y="6446520"/>
+            <a:ext cx="5486400" cy="274320"/>
+          </a:xfrm>
+          <a:prstGeom prst="rect">
+            <a:avLst/>
+          </a:prstGeom>
+          <a:noFill/>
+        </p:spPr>
+        <p:txBody>
+          <a:bodyPr wrap="square" lIns="0" rIns="0" tIns="0" bIns="0" anchor="t">
+            <a:spAutoFit/>
+          </a:bodyPr>
+          <a:lstStyle/>
+          <a:p>
+            <a:pPr>
+              <a:spcAft>
+                <a:spcPts val="400"/>
+              </a:spcAft>
+            </a:pPr>
+            <a:r>
+              <a:rPr sz="1000" b="0">
+                <a:solidFill>
+                  <a:srgbClr val="5B6B72"/>
+                </a:solidFill>
+                <a:latin typeface="Calibri"/>
+              </a:rPr>
+              <a:t>INFRA-AI  ·  Digital Public Good</a:t>
+            </a:r>
+          </a:p>
+        </p:txBody>
+      </p:sp>
+      <p:sp>
+        <p:nvSpPr>
+          <p:cNvPr id="21" name="TextBox 20"/>
+          <p:cNvSpPr txBox="1"/>
+          <p:nvPr/>
+        </p:nvSpPr>
+        <p:spPr>
+          <a:xfrm>
+            <a:off x="11091672" y="6446520"/>
+            <a:ext cx="548640" cy="274320"/>
+          </a:xfrm>
+          <a:prstGeom prst="rect">
+            <a:avLst/>
+          </a:prstGeom>
+          <a:noFill/>
+        </p:spPr>
+        <p:txBody>
+          <a:bodyPr wrap="square" lIns="0" rIns="0" tIns="0" bIns="0" anchor="t">
+            <a:spAutoFit/>
+          </a:bodyPr>
+          <a:lstStyle/>
+          <a:p>
+            <a:pPr algn="r">
+              <a:spcAft>
+                <a:spcPts val="400"/>
+              </a:spcAft>
+            </a:pPr>
+            <a:r>
+              <a:rPr sz="1000" b="0">
+                <a:solidFill>
+                  <a:srgbClr val="5B6B72"/>
+                </a:solidFill>
+                <a:latin typeface="Calibri"/>
+              </a:rPr>
+              <a:t>8</a:t>
+            </a:r>
+          </a:p>
+        </p:txBody>
+      </p:sp>
+    </p:spTree>
+  </p:cSld>
+  <p:clrMapOvr>
+    <a:masterClrMapping/>
+  </p:clrMapOvr>
+</p:sld>
+</file>
+
+<file path=ppt/slides/slide9.xml><?xml version="1.0" encoding="utf-8"?>
 <p:sld xmlns:a="http://schemas.openxmlformats.org/drawingml/2006/main" xmlns:r="http://schemas.openxmlformats.org/officeDocument/2006/relationships" xmlns:p="http://schemas.openxmlformats.org/presentationml/2006/main">
   <p:cSld name="Slide 6">
     <p:bg>
@@ -7669,6 +9873,10 @@
             <a:prstDash val="solid"/>
           </a:ln>
         </p:spPr>
+        <p:txBody>
+          <a:bodyPr/>
+          <a:p/>
+        </p:txBody>
       </p:sp>
       <p:sp>
         <p:nvSpPr>
@@ -7694,6 +9902,10 @@
             <a:prstDash val="solid"/>
           </a:ln>
         </p:spPr>
+        <p:txBody>
+          <a:bodyPr/>
+          <a:p/>
+        </p:txBody>
       </p:sp>
       <p:pic>
         <p:nvPicPr>
@@ -7779,6 +9991,10 @@
           </a:solidFill>
           <a:ln/>
         </p:spPr>
+        <p:txBody>
+          <a:bodyPr/>
+          <a:p/>
+        </p:txBody>
       </p:sp>
       <p:sp>
         <p:nvSpPr>
@@ -7882,6 +10098,10 @@
             <a:prstDash val="solid"/>
           </a:ln>
         </p:spPr>
+        <p:txBody>
+          <a:bodyPr/>
+          <a:p/>
+        </p:txBody>
       </p:sp>
       <p:pic>
         <p:nvPicPr>
@@ -7967,6 +10187,10 @@
           </a:solidFill>
           <a:ln/>
         </p:spPr>
+        <p:txBody>
+          <a:bodyPr/>
+          <a:p/>
+        </p:txBody>
       </p:sp>
       <p:sp>
         <p:nvSpPr>
@@ -8070,6 +10294,10 @@
             <a:prstDash val="solid"/>
           </a:ln>
         </p:spPr>
+        <p:txBody>
+          <a:bodyPr/>
+          <a:p/>
+        </p:txBody>
       </p:sp>
       <p:sp>
         <p:nvSpPr>
@@ -8131,6 +10359,10 @@
           </a:solidFill>
           <a:ln/>
         </p:spPr>
+        <p:txBody>
+          <a:bodyPr/>
+          <a:p/>
+        </p:txBody>
       </p:sp>
       <p:sp>
         <p:nvSpPr>
@@ -8234,6 +10466,10 @@
             <a:prstDash val="solid"/>
           </a:ln>
         </p:spPr>
+        <p:txBody>
+          <a:bodyPr/>
+          <a:p/>
+        </p:txBody>
       </p:sp>
       <p:sp>
         <p:nvSpPr>
@@ -8295,6 +10531,10 @@
           </a:solidFill>
           <a:ln/>
         </p:spPr>
+        <p:txBody>
+          <a:bodyPr/>
+          <a:p/>
+        </p:txBody>
       </p:sp>
       <p:sp>
         <p:nvSpPr>
@@ -8519,6 +10759,10 @@
           </a:solidFill>
           <a:ln/>
         </p:spPr>
+        <p:txBody>
+          <a:bodyPr/>
+          <a:p/>
+        </p:txBody>
       </p:sp>
       <p:sp>
         <p:nvSpPr>
@@ -8716,1113 +10960,9 @@
                 <a:ea typeface="Calibri" pitchFamily="34" charset="-122"/>
                 <a:cs typeface="Calibri" pitchFamily="34" charset="-120"/>
               </a:rPr>
-              <a:t>8</a:t>
+              <a:t>9</a:t>
             </a:r>
             <a:endParaRPr lang="en-US" sz="1000" dirty="0"/>
-          </a:p>
-        </p:txBody>
-      </p:sp>
-    </p:spTree>
-  </p:cSld>
-  <p:clrMapOvr>
-    <a:masterClrMapping/>
-  </p:clrMapOvr>
-</p:sld>
-</file>
-
-<file path=ppt/slides/slide8.xml><?xml version="1.0" encoding="utf-8"?>
-<p:sld xmlns:a="http://schemas.openxmlformats.org/drawingml/2006/main" xmlns:p="http://schemas.openxmlformats.org/presentationml/2006/main" xmlns:r="http://schemas.openxmlformats.org/officeDocument/2006/relationships">
-  <p:cSld>
-    <p:bg>
-      <p:bgPr>
-        <a:solidFill>
-          <a:srgbClr val="072C34"/>
-        </a:solidFill>
-        <a:effectLst/>
-      </p:bgPr>
-    </p:bg>
-    <p:spTree>
-      <p:nvGrpSpPr>
-        <p:cNvPr id="1" name=""/>
-        <p:cNvGrpSpPr/>
-        <p:nvPr/>
-      </p:nvGrpSpPr>
-      <p:grpSpPr/>
-      <p:sp>
-        <p:nvSpPr>
-          <p:cNvPr id="2" name="TextBox 1"/>
-          <p:cNvSpPr txBox="1"/>
-          <p:nvPr/>
-        </p:nvSpPr>
-        <p:spPr>
-          <a:xfrm>
-            <a:off x="548640" y="640080"/>
-            <a:ext cx="5120640" cy="320040"/>
-          </a:xfrm>
-          <a:prstGeom prst="rect">
-            <a:avLst/>
-          </a:prstGeom>
-          <a:noFill/>
-        </p:spPr>
-        <p:txBody>
-          <a:bodyPr wrap="square" anchor="t" lIns="0" rIns="0" tIns="0" bIns="0">
-            <a:spAutoFit/>
-          </a:bodyPr>
-          <a:lstStyle/>
-          <a:p>
-            <a:r>
-              <a:rPr sz="1200" b="1" spc="100">
-                <a:solidFill>
-                  <a:srgbClr val="E08A1E"/>
-                </a:solidFill>
-                <a:latin typeface="Calibri"/>
-              </a:rPr>
-              <a:t>BUILD WITH AI: CODE FOR COMMUNITIES  ·  SECOND EDITION</a:t>
-            </a:r>
-          </a:p>
-        </p:txBody>
-      </p:sp>
-      <p:sp>
-        <p:nvSpPr>
-          <p:cNvPr id="3" name="TextBox 2"/>
-          <p:cNvSpPr txBox="1"/>
-          <p:nvPr/>
-        </p:nvSpPr>
-        <p:spPr>
-          <a:xfrm>
-            <a:off x="548640" y="1188720"/>
-            <a:ext cx="5120640" cy="1097280"/>
-          </a:xfrm>
-          <a:prstGeom prst="rect">
-            <a:avLst/>
-          </a:prstGeom>
-          <a:noFill/>
-        </p:spPr>
-        <p:txBody>
-          <a:bodyPr wrap="square" anchor="t" lIns="0" rIns="0" tIns="0" bIns="0">
-            <a:spAutoFit/>
-          </a:bodyPr>
-          <a:lstStyle/>
-          <a:p>
-            <a:r>
-              <a:rPr sz="4800" b="1">
-                <a:solidFill>
-                  <a:srgbClr val="FFFFFF"/>
-                </a:solidFill>
-                <a:latin typeface="Cambria"/>
-              </a:rPr>
-              <a:t>Team Predators</a:t>
-            </a:r>
-          </a:p>
-        </p:txBody>
-      </p:sp>
-      <p:sp>
-        <p:nvSpPr>
-          <p:cNvPr id="4" name="TextBox 3"/>
-          <p:cNvSpPr txBox="1"/>
-          <p:nvPr/>
-        </p:nvSpPr>
-        <p:spPr>
-          <a:xfrm>
-            <a:off x="548640" y="2514600"/>
-            <a:ext cx="5120640" cy="1280160"/>
-          </a:xfrm>
-          <a:prstGeom prst="rect">
-            <a:avLst/>
-          </a:prstGeom>
-          <a:noFill/>
-        </p:spPr>
-        <p:txBody>
-          <a:bodyPr wrap="square" anchor="t" lIns="0" rIns="0" tIns="0" bIns="0">
-            <a:spAutoFit/>
-          </a:bodyPr>
-          <a:lstStyle/>
-          <a:p>
-            <a:r>
-              <a:rPr sz="2000" b="0">
-                <a:solidFill>
-                  <a:srgbClr val="CFE3E6"/>
-                </a:solidFill>
-                <a:latin typeface="Calibri"/>
-              </a:rPr>
-              <a:t>Problem statement 01: AI for Digital Public Infrastructure &amp; Governance</a:t>
-            </a:r>
-          </a:p>
-        </p:txBody>
-      </p:sp>
-      <p:sp>
-        <p:nvSpPr>
-          <p:cNvPr id="5" name="TextBox 4"/>
-          <p:cNvSpPr txBox="1"/>
-          <p:nvPr/>
-        </p:nvSpPr>
-        <p:spPr>
-          <a:xfrm>
-            <a:off x="548640" y="4206240"/>
-            <a:ext cx="5120640" cy="457200"/>
-          </a:xfrm>
-          <a:prstGeom prst="rect">
-            <a:avLst/>
-          </a:prstGeom>
-          <a:noFill/>
-        </p:spPr>
-        <p:txBody>
-          <a:bodyPr wrap="square" anchor="t" lIns="0" rIns="0" tIns="0" bIns="0">
-            <a:spAutoFit/>
-          </a:bodyPr>
-          <a:lstStyle/>
-          <a:p>
-            <a:r>
-              <a:rPr sz="1800" b="1">
-                <a:solidFill>
-                  <a:srgbClr val="FFFFFF"/>
-                </a:solidFill>
-                <a:latin typeface="Cambria"/>
-              </a:rPr>
-              <a:t>Our solution: INFRA-AI</a:t>
-            </a:r>
-          </a:p>
-        </p:txBody>
-      </p:sp>
-      <p:sp>
-        <p:nvSpPr>
-          <p:cNvPr id="6" name="TextBox 5"/>
-          <p:cNvSpPr txBox="1"/>
-          <p:nvPr/>
-        </p:nvSpPr>
-        <p:spPr>
-          <a:xfrm>
-            <a:off x="548640" y="4617720"/>
-            <a:ext cx="5120640" cy="731520"/>
-          </a:xfrm>
-          <a:prstGeom prst="rect">
-            <a:avLst/>
-          </a:prstGeom>
-          <a:noFill/>
-        </p:spPr>
-        <p:txBody>
-          <a:bodyPr wrap="square" anchor="t" lIns="0" rIns="0" tIns="0" bIns="0">
-            <a:spAutoFit/>
-          </a:bodyPr>
-          <a:lstStyle/>
-          <a:p>
-            <a:r>
-              <a:rPr sz="1400" b="0">
-                <a:solidFill>
-                  <a:srgbClr val="CFE3E6"/>
-                </a:solidFill>
-                <a:latin typeface="Calibri"/>
-              </a:rPr>
-              <a:t>A multilingual, location-first infrastructure intelligence platform for India, built as a Digital Public Good.</a:t>
-            </a:r>
-          </a:p>
-        </p:txBody>
-      </p:sp>
-      <p:sp>
-        <p:nvSpPr>
-          <p:cNvPr id="7" name="Rounded Rectangle 6"/>
-          <p:cNvSpPr/>
-          <p:nvPr/>
-        </p:nvSpPr>
-        <p:spPr>
-          <a:xfrm>
-            <a:off x="6062472" y="1554480"/>
-            <a:ext cx="2697480" cy="2103120"/>
-          </a:xfrm>
-          <a:prstGeom prst="roundRect">
-            <a:avLst>
-              <a:gd name="adj" fmla="val 5000"/>
-            </a:avLst>
-          </a:prstGeom>
-          <a:solidFill>
-            <a:srgbClr val="0B4F5C"/>
-          </a:solidFill>
-          <a:ln>
-            <a:noFill/>
-          </a:ln>
-          <a:effectLst/>
-        </p:spPr>
-        <p:style>
-          <a:lnRef idx="1">
-            <a:schemeClr val="accent1"/>
-          </a:lnRef>
-          <a:fillRef idx="3">
-            <a:schemeClr val="accent1"/>
-          </a:fillRef>
-          <a:effectRef idx="2">
-            <a:schemeClr val="accent1"/>
-          </a:effectRef>
-          <a:fontRef idx="minor">
-            <a:schemeClr val="lt1"/>
-          </a:fontRef>
-        </p:style>
-        <p:txBody>
-          <a:bodyPr rtlCol="0" anchor="ctr"/>
-          <a:lstStyle/>
-          <a:p>
-            <a:pPr algn="ctr"/>
-          </a:p>
-        </p:txBody>
-      </p:sp>
-      <p:sp>
-        <p:nvSpPr>
-          <p:cNvPr id="8" name="Oval 7"/>
-          <p:cNvSpPr/>
-          <p:nvPr/>
-        </p:nvSpPr>
-        <p:spPr>
-          <a:xfrm>
-            <a:off x="6291072" y="1783080"/>
-            <a:ext cx="640080" cy="640080"/>
-          </a:xfrm>
-          <a:prstGeom prst="ellipse">
-            <a:avLst/>
-          </a:prstGeom>
-          <a:solidFill>
-            <a:srgbClr val="E08A1E"/>
-          </a:solidFill>
-          <a:ln>
-            <a:noFill/>
-          </a:ln>
-          <a:effectLst/>
-        </p:spPr>
-        <p:style>
-          <a:lnRef idx="1">
-            <a:schemeClr val="accent1"/>
-          </a:lnRef>
-          <a:fillRef idx="3">
-            <a:schemeClr val="accent1"/>
-          </a:fillRef>
-          <a:effectRef idx="2">
-            <a:schemeClr val="accent1"/>
-          </a:effectRef>
-          <a:fontRef idx="minor">
-            <a:schemeClr val="lt1"/>
-          </a:fontRef>
-        </p:style>
-        <p:txBody>
-          <a:bodyPr rtlCol="0" anchor="ctr"/>
-          <a:lstStyle/>
-          <a:p>
-            <a:pPr algn="ctr"/>
-          </a:p>
-        </p:txBody>
-      </p:sp>
-      <p:sp>
-        <p:nvSpPr>
-          <p:cNvPr id="9" name="TextBox 8"/>
-          <p:cNvSpPr txBox="1"/>
-          <p:nvPr/>
-        </p:nvSpPr>
-        <p:spPr>
-          <a:xfrm>
-            <a:off x="6291072" y="1783080"/>
-            <a:ext cx="640080" cy="640080"/>
-          </a:xfrm>
-          <a:prstGeom prst="rect">
-            <a:avLst/>
-          </a:prstGeom>
-          <a:noFill/>
-        </p:spPr>
-        <p:txBody>
-          <a:bodyPr wrap="square" anchor="ctr" lIns="0" rIns="0" tIns="0" bIns="0">
-            <a:spAutoFit/>
-          </a:bodyPr>
-          <a:lstStyle/>
-          <a:p>
-            <a:pPr algn="ctr"/>
-            <a:r>
-              <a:rPr sz="1600" b="1">
-                <a:solidFill>
-                  <a:srgbClr val="072C34"/>
-                </a:solidFill>
-                <a:latin typeface="Calibri"/>
-              </a:rPr>
-              <a:t>PS</a:t>
-            </a:r>
-          </a:p>
-        </p:txBody>
-      </p:sp>
-      <p:sp>
-        <p:nvSpPr>
-          <p:cNvPr id="10" name="TextBox 9"/>
-          <p:cNvSpPr txBox="1"/>
-          <p:nvPr/>
-        </p:nvSpPr>
-        <p:spPr>
-          <a:xfrm>
-            <a:off x="6291072" y="2606039"/>
-            <a:ext cx="2331720" cy="320040"/>
-          </a:xfrm>
-          <a:prstGeom prst="rect">
-            <a:avLst/>
-          </a:prstGeom>
-          <a:noFill/>
-        </p:spPr>
-        <p:txBody>
-          <a:bodyPr wrap="square" anchor="t" lIns="0" rIns="0" tIns="0" bIns="0">
-            <a:spAutoFit/>
-          </a:bodyPr>
-          <a:lstStyle/>
-          <a:p>
-            <a:r>
-              <a:rPr sz="1700" b="1">
-                <a:solidFill>
-                  <a:srgbClr val="FFFFFF"/>
-                </a:solidFill>
-                <a:latin typeface="Calibri"/>
-              </a:rPr>
-              <a:t>Punya Surana</a:t>
-            </a:r>
-          </a:p>
-        </p:txBody>
-      </p:sp>
-      <p:sp>
-        <p:nvSpPr>
-          <p:cNvPr id="11" name="TextBox 10"/>
-          <p:cNvSpPr txBox="1"/>
-          <p:nvPr/>
-        </p:nvSpPr>
-        <p:spPr>
-          <a:xfrm>
-            <a:off x="6291072" y="2944368"/>
-            <a:ext cx="2331720" cy="274320"/>
-          </a:xfrm>
-          <a:prstGeom prst="rect">
-            <a:avLst/>
-          </a:prstGeom>
-          <a:noFill/>
-        </p:spPr>
-        <p:txBody>
-          <a:bodyPr wrap="square" anchor="t" lIns="0" rIns="0" tIns="0" bIns="0">
-            <a:spAutoFit/>
-          </a:bodyPr>
-          <a:lstStyle/>
-          <a:p>
-            <a:r>
-              <a:rPr sz="1100" b="1">
-                <a:solidFill>
-                  <a:srgbClr val="E08A1E"/>
-                </a:solidFill>
-                <a:latin typeface="Calibri"/>
-              </a:rPr>
-              <a:t>Team Leader</a:t>
-            </a:r>
-          </a:p>
-        </p:txBody>
-      </p:sp>
-      <p:sp>
-        <p:nvSpPr>
-          <p:cNvPr id="12" name="TextBox 11"/>
-          <p:cNvSpPr txBox="1"/>
-          <p:nvPr/>
-        </p:nvSpPr>
-        <p:spPr>
-          <a:xfrm>
-            <a:off x="6291072" y="3246120"/>
-            <a:ext cx="2331720" cy="274320"/>
-          </a:xfrm>
-          <a:prstGeom prst="rect">
-            <a:avLst/>
-          </a:prstGeom>
-          <a:noFill/>
-        </p:spPr>
-        <p:txBody>
-          <a:bodyPr wrap="square" anchor="t" lIns="0" rIns="0" tIns="0" bIns="0">
-            <a:spAutoFit/>
-          </a:bodyPr>
-          <a:lstStyle/>
-          <a:p>
-            <a:r>
-              <a:rPr sz="1100" b="0">
-                <a:solidFill>
-                  <a:srgbClr val="CFE3E6"/>
-                </a:solidFill>
-                <a:latin typeface="Calibri"/>
-              </a:rPr>
-              <a:t>punyasurana23@gmail.com</a:t>
-            </a:r>
-          </a:p>
-        </p:txBody>
-      </p:sp>
-      <p:sp>
-        <p:nvSpPr>
-          <p:cNvPr id="13" name="Rounded Rectangle 12"/>
-          <p:cNvSpPr/>
-          <p:nvPr/>
-        </p:nvSpPr>
-        <p:spPr>
-          <a:xfrm>
-            <a:off x="8942832" y="1554480"/>
-            <a:ext cx="2697480" cy="2103120"/>
-          </a:xfrm>
-          <a:prstGeom prst="roundRect">
-            <a:avLst>
-              <a:gd name="adj" fmla="val 5000"/>
-            </a:avLst>
-          </a:prstGeom>
-          <a:solidFill>
-            <a:srgbClr val="0B4F5C"/>
-          </a:solidFill>
-          <a:ln>
-            <a:noFill/>
-          </a:ln>
-          <a:effectLst/>
-        </p:spPr>
-        <p:style>
-          <a:lnRef idx="1">
-            <a:schemeClr val="accent1"/>
-          </a:lnRef>
-          <a:fillRef idx="3">
-            <a:schemeClr val="accent1"/>
-          </a:fillRef>
-          <a:effectRef idx="2">
-            <a:schemeClr val="accent1"/>
-          </a:effectRef>
-          <a:fontRef idx="minor">
-            <a:schemeClr val="lt1"/>
-          </a:fontRef>
-        </p:style>
-        <p:txBody>
-          <a:bodyPr rtlCol="0" anchor="ctr"/>
-          <a:lstStyle/>
-          <a:p>
-            <a:pPr algn="ctr"/>
-          </a:p>
-        </p:txBody>
-      </p:sp>
-      <p:sp>
-        <p:nvSpPr>
-          <p:cNvPr id="14" name="Oval 13"/>
-          <p:cNvSpPr/>
-          <p:nvPr/>
-        </p:nvSpPr>
-        <p:spPr>
-          <a:xfrm>
-            <a:off x="9171432" y="1783080"/>
-            <a:ext cx="640080" cy="640080"/>
-          </a:xfrm>
-          <a:prstGeom prst="ellipse">
-            <a:avLst/>
-          </a:prstGeom>
-          <a:solidFill>
-            <a:srgbClr val="072C34"/>
-          </a:solidFill>
-          <a:ln>
-            <a:noFill/>
-          </a:ln>
-          <a:effectLst/>
-        </p:spPr>
-        <p:style>
-          <a:lnRef idx="1">
-            <a:schemeClr val="accent1"/>
-          </a:lnRef>
-          <a:fillRef idx="3">
-            <a:schemeClr val="accent1"/>
-          </a:fillRef>
-          <a:effectRef idx="2">
-            <a:schemeClr val="accent1"/>
-          </a:effectRef>
-          <a:fontRef idx="minor">
-            <a:schemeClr val="lt1"/>
-          </a:fontRef>
-        </p:style>
-        <p:txBody>
-          <a:bodyPr rtlCol="0" anchor="ctr"/>
-          <a:lstStyle/>
-          <a:p>
-            <a:pPr algn="ctr"/>
-          </a:p>
-        </p:txBody>
-      </p:sp>
-      <p:sp>
-        <p:nvSpPr>
-          <p:cNvPr id="15" name="TextBox 14"/>
-          <p:cNvSpPr txBox="1"/>
-          <p:nvPr/>
-        </p:nvSpPr>
-        <p:spPr>
-          <a:xfrm>
-            <a:off x="9171432" y="1783080"/>
-            <a:ext cx="640080" cy="640080"/>
-          </a:xfrm>
-          <a:prstGeom prst="rect">
-            <a:avLst/>
-          </a:prstGeom>
-          <a:noFill/>
-        </p:spPr>
-        <p:txBody>
-          <a:bodyPr wrap="square" anchor="ctr" lIns="0" rIns="0" tIns="0" bIns="0">
-            <a:spAutoFit/>
-          </a:bodyPr>
-          <a:lstStyle/>
-          <a:p>
-            <a:pPr algn="ctr"/>
-            <a:r>
-              <a:rPr sz="1600" b="1">
-                <a:solidFill>
-                  <a:srgbClr val="FFFFFF"/>
-                </a:solidFill>
-                <a:latin typeface="Calibri"/>
-              </a:rPr>
-              <a:t>SP</a:t>
-            </a:r>
-          </a:p>
-        </p:txBody>
-      </p:sp>
-      <p:sp>
-        <p:nvSpPr>
-          <p:cNvPr id="16" name="TextBox 15"/>
-          <p:cNvSpPr txBox="1"/>
-          <p:nvPr/>
-        </p:nvSpPr>
-        <p:spPr>
-          <a:xfrm>
-            <a:off x="9171432" y="2606039"/>
-            <a:ext cx="2331720" cy="320040"/>
-          </a:xfrm>
-          <a:prstGeom prst="rect">
-            <a:avLst/>
-          </a:prstGeom>
-          <a:noFill/>
-        </p:spPr>
-        <p:txBody>
-          <a:bodyPr wrap="square" anchor="t" lIns="0" rIns="0" tIns="0" bIns="0">
-            <a:spAutoFit/>
-          </a:bodyPr>
-          <a:lstStyle/>
-          <a:p>
-            <a:r>
-              <a:rPr sz="1700" b="1">
-                <a:solidFill>
-                  <a:srgbClr val="FFFFFF"/>
-                </a:solidFill>
-                <a:latin typeface="Calibri"/>
-              </a:rPr>
-              <a:t>Shreyam Pandey</a:t>
-            </a:r>
-          </a:p>
-        </p:txBody>
-      </p:sp>
-      <p:sp>
-        <p:nvSpPr>
-          <p:cNvPr id="17" name="TextBox 16"/>
-          <p:cNvSpPr txBox="1"/>
-          <p:nvPr/>
-        </p:nvSpPr>
-        <p:spPr>
-          <a:xfrm>
-            <a:off x="9171432" y="2944368"/>
-            <a:ext cx="2331720" cy="274320"/>
-          </a:xfrm>
-          <a:prstGeom prst="rect">
-            <a:avLst/>
-          </a:prstGeom>
-          <a:noFill/>
-        </p:spPr>
-        <p:txBody>
-          <a:bodyPr wrap="square" anchor="t" lIns="0" rIns="0" tIns="0" bIns="0">
-            <a:spAutoFit/>
-          </a:bodyPr>
-          <a:lstStyle/>
-          <a:p>
-            <a:r>
-              <a:rPr sz="1100" b="0">
-                <a:solidFill>
-                  <a:srgbClr val="CFE3E6"/>
-                </a:solidFill>
-                <a:latin typeface="Calibri"/>
-              </a:rPr>
-              <a:t>Team Member</a:t>
-            </a:r>
-          </a:p>
-        </p:txBody>
-      </p:sp>
-      <p:sp>
-        <p:nvSpPr>
-          <p:cNvPr id="18" name="TextBox 17"/>
-          <p:cNvSpPr txBox="1"/>
-          <p:nvPr/>
-        </p:nvSpPr>
-        <p:spPr>
-          <a:xfrm>
-            <a:off x="9171432" y="3246120"/>
-            <a:ext cx="2331720" cy="274320"/>
-          </a:xfrm>
-          <a:prstGeom prst="rect">
-            <a:avLst/>
-          </a:prstGeom>
-          <a:noFill/>
-        </p:spPr>
-        <p:txBody>
-          <a:bodyPr wrap="square" anchor="t" lIns="0" rIns="0" tIns="0" bIns="0">
-            <a:spAutoFit/>
-          </a:bodyPr>
-          <a:lstStyle/>
-          <a:p>
-            <a:r>
-              <a:rPr sz="1100" b="0">
-                <a:solidFill>
-                  <a:srgbClr val="CFE3E6"/>
-                </a:solidFill>
-                <a:latin typeface="Calibri"/>
-              </a:rPr>
-              <a:t>p.shreyambbk@gmail.com</a:t>
-            </a:r>
-          </a:p>
-        </p:txBody>
-      </p:sp>
-      <p:sp>
-        <p:nvSpPr>
-          <p:cNvPr id="19" name="Rounded Rectangle 18"/>
-          <p:cNvSpPr/>
-          <p:nvPr/>
-        </p:nvSpPr>
-        <p:spPr>
-          <a:xfrm>
-            <a:off x="6062472" y="3840480"/>
-            <a:ext cx="2697480" cy="2103120"/>
-          </a:xfrm>
-          <a:prstGeom prst="roundRect">
-            <a:avLst>
-              <a:gd name="adj" fmla="val 5000"/>
-            </a:avLst>
-          </a:prstGeom>
-          <a:solidFill>
-            <a:srgbClr val="0B4F5C"/>
-          </a:solidFill>
-          <a:ln>
-            <a:noFill/>
-          </a:ln>
-          <a:effectLst/>
-        </p:spPr>
-        <p:style>
-          <a:lnRef idx="1">
-            <a:schemeClr val="accent1"/>
-          </a:lnRef>
-          <a:fillRef idx="3">
-            <a:schemeClr val="accent1"/>
-          </a:fillRef>
-          <a:effectRef idx="2">
-            <a:schemeClr val="accent1"/>
-          </a:effectRef>
-          <a:fontRef idx="minor">
-            <a:schemeClr val="lt1"/>
-          </a:fontRef>
-        </p:style>
-        <p:txBody>
-          <a:bodyPr rtlCol="0" anchor="ctr"/>
-          <a:lstStyle/>
-          <a:p>
-            <a:pPr algn="ctr"/>
-          </a:p>
-        </p:txBody>
-      </p:sp>
-      <p:sp>
-        <p:nvSpPr>
-          <p:cNvPr id="20" name="Oval 19"/>
-          <p:cNvSpPr/>
-          <p:nvPr/>
-        </p:nvSpPr>
-        <p:spPr>
-          <a:xfrm>
-            <a:off x="6291072" y="4069080"/>
-            <a:ext cx="640080" cy="640080"/>
-          </a:xfrm>
-          <a:prstGeom prst="ellipse">
-            <a:avLst/>
-          </a:prstGeom>
-          <a:solidFill>
-            <a:srgbClr val="072C34"/>
-          </a:solidFill>
-          <a:ln>
-            <a:noFill/>
-          </a:ln>
-          <a:effectLst/>
-        </p:spPr>
-        <p:style>
-          <a:lnRef idx="1">
-            <a:schemeClr val="accent1"/>
-          </a:lnRef>
-          <a:fillRef idx="3">
-            <a:schemeClr val="accent1"/>
-          </a:fillRef>
-          <a:effectRef idx="2">
-            <a:schemeClr val="accent1"/>
-          </a:effectRef>
-          <a:fontRef idx="minor">
-            <a:schemeClr val="lt1"/>
-          </a:fontRef>
-        </p:style>
-        <p:txBody>
-          <a:bodyPr rtlCol="0" anchor="ctr"/>
-          <a:lstStyle/>
-          <a:p>
-            <a:pPr algn="ctr"/>
-          </a:p>
-        </p:txBody>
-      </p:sp>
-      <p:sp>
-        <p:nvSpPr>
-          <p:cNvPr id="21" name="TextBox 20"/>
-          <p:cNvSpPr txBox="1"/>
-          <p:nvPr/>
-        </p:nvSpPr>
-        <p:spPr>
-          <a:xfrm>
-            <a:off x="6291072" y="4069080"/>
-            <a:ext cx="640080" cy="640080"/>
-          </a:xfrm>
-          <a:prstGeom prst="rect">
-            <a:avLst/>
-          </a:prstGeom>
-          <a:noFill/>
-        </p:spPr>
-        <p:txBody>
-          <a:bodyPr wrap="square" anchor="ctr" lIns="0" rIns="0" tIns="0" bIns="0">
-            <a:spAutoFit/>
-          </a:bodyPr>
-          <a:lstStyle/>
-          <a:p>
-            <a:pPr algn="ctr"/>
-            <a:r>
-              <a:rPr sz="1600" b="1">
-                <a:solidFill>
-                  <a:srgbClr val="FFFFFF"/>
-                </a:solidFill>
-                <a:latin typeface="Calibri"/>
-              </a:rPr>
-              <a:t>SV</a:t>
-            </a:r>
-          </a:p>
-        </p:txBody>
-      </p:sp>
-      <p:sp>
-        <p:nvSpPr>
-          <p:cNvPr id="22" name="TextBox 21"/>
-          <p:cNvSpPr txBox="1"/>
-          <p:nvPr/>
-        </p:nvSpPr>
-        <p:spPr>
-          <a:xfrm>
-            <a:off x="6291072" y="4892040"/>
-            <a:ext cx="2331720" cy="320040"/>
-          </a:xfrm>
-          <a:prstGeom prst="rect">
-            <a:avLst/>
-          </a:prstGeom>
-          <a:noFill/>
-        </p:spPr>
-        <p:txBody>
-          <a:bodyPr wrap="square" anchor="t" lIns="0" rIns="0" tIns="0" bIns="0">
-            <a:spAutoFit/>
-          </a:bodyPr>
-          <a:lstStyle/>
-          <a:p>
-            <a:r>
-              <a:rPr sz="1700" b="1">
-                <a:solidFill>
-                  <a:srgbClr val="FFFFFF"/>
-                </a:solidFill>
-                <a:latin typeface="Calibri"/>
-              </a:rPr>
-              <a:t>Shubham Veer</a:t>
-            </a:r>
-          </a:p>
-        </p:txBody>
-      </p:sp>
-      <p:sp>
-        <p:nvSpPr>
-          <p:cNvPr id="23" name="TextBox 22"/>
-          <p:cNvSpPr txBox="1"/>
-          <p:nvPr/>
-        </p:nvSpPr>
-        <p:spPr>
-          <a:xfrm>
-            <a:off x="6291072" y="5230368"/>
-            <a:ext cx="2331720" cy="274320"/>
-          </a:xfrm>
-          <a:prstGeom prst="rect">
-            <a:avLst/>
-          </a:prstGeom>
-          <a:noFill/>
-        </p:spPr>
-        <p:txBody>
-          <a:bodyPr wrap="square" anchor="t" lIns="0" rIns="0" tIns="0" bIns="0">
-            <a:spAutoFit/>
-          </a:bodyPr>
-          <a:lstStyle/>
-          <a:p>
-            <a:r>
-              <a:rPr sz="1100" b="0">
-                <a:solidFill>
-                  <a:srgbClr val="CFE3E6"/>
-                </a:solidFill>
-                <a:latin typeface="Calibri"/>
-              </a:rPr>
-              <a:t>Team Member</a:t>
-            </a:r>
-          </a:p>
-        </p:txBody>
-      </p:sp>
-      <p:sp>
-        <p:nvSpPr>
-          <p:cNvPr id="24" name="TextBox 23"/>
-          <p:cNvSpPr txBox="1"/>
-          <p:nvPr/>
-        </p:nvSpPr>
-        <p:spPr>
-          <a:xfrm>
-            <a:off x="6291072" y="5532120"/>
-            <a:ext cx="2331720" cy="274320"/>
-          </a:xfrm>
-          <a:prstGeom prst="rect">
-            <a:avLst/>
-          </a:prstGeom>
-          <a:noFill/>
-        </p:spPr>
-        <p:txBody>
-          <a:bodyPr wrap="square" anchor="t" lIns="0" rIns="0" tIns="0" bIns="0">
-            <a:spAutoFit/>
-          </a:bodyPr>
-          <a:lstStyle/>
-          <a:p>
-            <a:r>
-              <a:rPr sz="1100" b="0">
-                <a:solidFill>
-                  <a:srgbClr val="CFE3E6"/>
-                </a:solidFill>
-                <a:latin typeface="Calibri"/>
-              </a:rPr>
-              <a:t>shubham.veer24@pcu.edu.in</a:t>
-            </a:r>
-          </a:p>
-        </p:txBody>
-      </p:sp>
-      <p:sp>
-        <p:nvSpPr>
-          <p:cNvPr id="25" name="Rounded Rectangle 24"/>
-          <p:cNvSpPr/>
-          <p:nvPr/>
-        </p:nvSpPr>
-        <p:spPr>
-          <a:xfrm>
-            <a:off x="8942832" y="3840480"/>
-            <a:ext cx="2697480" cy="2103120"/>
-          </a:xfrm>
-          <a:prstGeom prst="roundRect">
-            <a:avLst>
-              <a:gd name="adj" fmla="val 5000"/>
-            </a:avLst>
-          </a:prstGeom>
-          <a:solidFill>
-            <a:srgbClr val="0B4F5C"/>
-          </a:solidFill>
-          <a:ln>
-            <a:noFill/>
-          </a:ln>
-          <a:effectLst/>
-        </p:spPr>
-        <p:style>
-          <a:lnRef idx="1">
-            <a:schemeClr val="accent1"/>
-          </a:lnRef>
-          <a:fillRef idx="3">
-            <a:schemeClr val="accent1"/>
-          </a:fillRef>
-          <a:effectRef idx="2">
-            <a:schemeClr val="accent1"/>
-          </a:effectRef>
-          <a:fontRef idx="minor">
-            <a:schemeClr val="lt1"/>
-          </a:fontRef>
-        </p:style>
-        <p:txBody>
-          <a:bodyPr rtlCol="0" anchor="ctr"/>
-          <a:lstStyle/>
-          <a:p>
-            <a:pPr algn="ctr"/>
-          </a:p>
-        </p:txBody>
-      </p:sp>
-      <p:sp>
-        <p:nvSpPr>
-          <p:cNvPr id="26" name="Oval 25"/>
-          <p:cNvSpPr/>
-          <p:nvPr/>
-        </p:nvSpPr>
-        <p:spPr>
-          <a:xfrm>
-            <a:off x="9171432" y="4069080"/>
-            <a:ext cx="640080" cy="640080"/>
-          </a:xfrm>
-          <a:prstGeom prst="ellipse">
-            <a:avLst/>
-          </a:prstGeom>
-          <a:solidFill>
-            <a:srgbClr val="072C34"/>
-          </a:solidFill>
-          <a:ln>
-            <a:noFill/>
-          </a:ln>
-          <a:effectLst/>
-        </p:spPr>
-        <p:style>
-          <a:lnRef idx="1">
-            <a:schemeClr val="accent1"/>
-          </a:lnRef>
-          <a:fillRef idx="3">
-            <a:schemeClr val="accent1"/>
-          </a:fillRef>
-          <a:effectRef idx="2">
-            <a:schemeClr val="accent1"/>
-          </a:effectRef>
-          <a:fontRef idx="minor">
-            <a:schemeClr val="lt1"/>
-          </a:fontRef>
-        </p:style>
-        <p:txBody>
-          <a:bodyPr rtlCol="0" anchor="ctr"/>
-          <a:lstStyle/>
-          <a:p>
-            <a:pPr algn="ctr"/>
-          </a:p>
-        </p:txBody>
-      </p:sp>
-      <p:sp>
-        <p:nvSpPr>
-          <p:cNvPr id="27" name="TextBox 26"/>
-          <p:cNvSpPr txBox="1"/>
-          <p:nvPr/>
-        </p:nvSpPr>
-        <p:spPr>
-          <a:xfrm>
-            <a:off x="9171432" y="4069080"/>
-            <a:ext cx="640080" cy="640080"/>
-          </a:xfrm>
-          <a:prstGeom prst="rect">
-            <a:avLst/>
-          </a:prstGeom>
-          <a:noFill/>
-        </p:spPr>
-        <p:txBody>
-          <a:bodyPr wrap="square" anchor="ctr" lIns="0" rIns="0" tIns="0" bIns="0">
-            <a:spAutoFit/>
-          </a:bodyPr>
-          <a:lstStyle/>
-          <a:p>
-            <a:pPr algn="ctr"/>
-            <a:r>
-              <a:rPr sz="1600" b="1">
-                <a:solidFill>
-                  <a:srgbClr val="FFFFFF"/>
-                </a:solidFill>
-                <a:latin typeface="Calibri"/>
-              </a:rPr>
-              <a:t>LS</a:t>
-            </a:r>
-          </a:p>
-        </p:txBody>
-      </p:sp>
-      <p:sp>
-        <p:nvSpPr>
-          <p:cNvPr id="28" name="TextBox 27"/>
-          <p:cNvSpPr txBox="1"/>
-          <p:nvPr/>
-        </p:nvSpPr>
-        <p:spPr>
-          <a:xfrm>
-            <a:off x="9171432" y="4892040"/>
-            <a:ext cx="2331720" cy="320040"/>
-          </a:xfrm>
-          <a:prstGeom prst="rect">
-            <a:avLst/>
-          </a:prstGeom>
-          <a:noFill/>
-        </p:spPr>
-        <p:txBody>
-          <a:bodyPr wrap="square" anchor="t" lIns="0" rIns="0" tIns="0" bIns="0">
-            <a:spAutoFit/>
-          </a:bodyPr>
-          <a:lstStyle/>
-          <a:p>
-            <a:r>
-              <a:rPr sz="1700" b="1">
-                <a:solidFill>
-                  <a:srgbClr val="FFFFFF"/>
-                </a:solidFill>
-                <a:latin typeface="Calibri"/>
-              </a:rPr>
-              <a:t>Laksh Sorathiya</a:t>
-            </a:r>
-          </a:p>
-        </p:txBody>
-      </p:sp>
-      <p:sp>
-        <p:nvSpPr>
-          <p:cNvPr id="29" name="TextBox 28"/>
-          <p:cNvSpPr txBox="1"/>
-          <p:nvPr/>
-        </p:nvSpPr>
-        <p:spPr>
-          <a:xfrm>
-            <a:off x="9171432" y="5230368"/>
-            <a:ext cx="2331720" cy="274320"/>
-          </a:xfrm>
-          <a:prstGeom prst="rect">
-            <a:avLst/>
-          </a:prstGeom>
-          <a:noFill/>
-        </p:spPr>
-        <p:txBody>
-          <a:bodyPr wrap="square" anchor="t" lIns="0" rIns="0" tIns="0" bIns="0">
-            <a:spAutoFit/>
-          </a:bodyPr>
-          <a:lstStyle/>
-          <a:p>
-            <a:r>
-              <a:rPr sz="1100" b="0">
-                <a:solidFill>
-                  <a:srgbClr val="CFE3E6"/>
-                </a:solidFill>
-                <a:latin typeface="Calibri"/>
-              </a:rPr>
-              <a:t>Team Member</a:t>
-            </a:r>
-          </a:p>
-        </p:txBody>
-      </p:sp>
-      <p:sp>
-        <p:nvSpPr>
-          <p:cNvPr id="30" name="TextBox 29"/>
-          <p:cNvSpPr txBox="1"/>
-          <p:nvPr/>
-        </p:nvSpPr>
-        <p:spPr>
-          <a:xfrm>
-            <a:off x="9171432" y="5532120"/>
-            <a:ext cx="2331720" cy="274320"/>
-          </a:xfrm>
-          <a:prstGeom prst="rect">
-            <a:avLst/>
-          </a:prstGeom>
-          <a:noFill/>
-        </p:spPr>
-        <p:txBody>
-          <a:bodyPr wrap="square" anchor="t" lIns="0" rIns="0" tIns="0" bIns="0">
-            <a:spAutoFit/>
-          </a:bodyPr>
-          <a:lstStyle/>
-          <a:p>
-            <a:r>
-              <a:rPr sz="1100" b="0">
-                <a:solidFill>
-                  <a:srgbClr val="CFE3E6"/>
-                </a:solidFill>
-                <a:latin typeface="Calibri"/>
-              </a:rPr>
-              <a:t>sorathiyalaksh37@gmail.com</a:t>
-            </a:r>
           </a:p>
         </p:txBody>
       </p:sp>

</xml_diff>

<commit_message>
docs(pitch): add BRICS world map with member outlines to slide 8
Map shows the ten BRICS members (India live, others proposed) drawn from Natural
Earth's India-view borders, with member languages. Cards condensed to fit.
Borders are not the official Survey of India layer; noted on the slide.

Co-Authored-By: Claude Sonnet 5.5 <noreply@anthropic.com>
</commit_message>
<xml_diff>
--- a/docs/INFRA-AI-pitch.pptx
+++ b/docs/INFRA-AI-pitch.pptx
@@ -8762,7 +8762,7 @@
           <a:p>
             <a:pPr>
               <a:spcAft>
-                <a:spcPts val="400"/>
+                <a:spcPts val="300"/>
               </a:spcAft>
             </a:pPr>
             <a:r>
@@ -8847,7 +8847,7 @@
           <a:p>
             <a:pPr algn="ctr">
               <a:spcAft>
-                <a:spcPts val="400"/>
+                <a:spcPts val="300"/>
               </a:spcAft>
             </a:pPr>
             <a:r>
@@ -8886,7 +8886,7 @@
           <a:p>
             <a:pPr>
               <a:spcAft>
-                <a:spcPts val="400"/>
+                <a:spcPts val="300"/>
               </a:spcAft>
             </a:pPr>
             <a:r>
@@ -8896,29 +8896,51 @@
                 </a:solidFill>
                 <a:latin typeface="Calibri"/>
               </a:rPr>
-              <a:t>Today INFRA-AI covers India only. Here is what the same platform could do for BRICS, and what should come first.</a:t>
-            </a:r>
-          </a:p>
-        </p:txBody>
-      </p:sp>
-      <p:sp>
-        <p:nvSpPr>
-          <p:cNvPr id="6" name="Rounded Rectangle 5"/>
+              <a:t>Today INFRA-AI covers India only. Here is what the same platform could do for the ten BRICS members.</a:t>
+            </a:r>
+          </a:p>
+        </p:txBody>
+      </p:sp>
+      <p:pic>
+        <p:nvPicPr>
+          <p:cNvPr id="6" name="Picture 5" descr="image.png"/>
+          <p:cNvPicPr>
+            <a:picLocks noChangeAspect="1"/>
+          </p:cNvPicPr>
+          <p:nvPr/>
+        </p:nvPicPr>
+        <p:blipFill>
+          <a:blip r:embed="rId3"/>
+          <a:stretch>
+            <a:fillRect/>
+          </a:stretch>
+        </p:blipFill>
+        <p:spPr>
+          <a:xfrm>
+            <a:off x="548640" y="1645920"/>
+            <a:ext cx="6035040" cy="2311884"/>
+          </a:xfrm>
+          <a:prstGeom prst="rect">
+            <a:avLst/>
+          </a:prstGeom>
+        </p:spPr>
+      </p:pic>
+      <p:sp>
+        <p:nvSpPr>
+          <p:cNvPr id="7" name="Oval 6"/>
           <p:cNvSpPr/>
           <p:nvPr/>
         </p:nvSpPr>
         <p:spPr>
           <a:xfrm>
-            <a:off x="548640" y="1783080"/>
-            <a:ext cx="3566160" cy="3977639"/>
-          </a:xfrm>
-          <a:prstGeom prst="roundRect">
-            <a:avLst>
-              <a:gd name="adj" fmla="val 2564"/>
-            </a:avLst>
+            <a:off x="548640" y="4049244"/>
+            <a:ext cx="146304" cy="146304"/>
+          </a:xfrm>
+          <a:prstGeom prst="ellipse">
+            <a:avLst/>
           </a:prstGeom>
           <a:solidFill>
-            <a:srgbClr val="EAF2F3"/>
+            <a:srgbClr val="E08A1E"/>
           </a:solidFill>
           <a:ln>
             <a:noFill/>
@@ -8949,13 +8971,52 @@
       </p:sp>
       <p:sp>
         <p:nvSpPr>
-          <p:cNvPr id="7" name="Oval 6"/>
+          <p:cNvPr id="8" name="TextBox 7"/>
+          <p:cNvSpPr txBox="1"/>
+          <p:nvPr/>
+        </p:nvSpPr>
+        <p:spPr>
+          <a:xfrm>
+            <a:off x="768096" y="4003524"/>
+            <a:ext cx="2103120" cy="237744"/>
+          </a:xfrm>
+          <a:prstGeom prst="rect">
+            <a:avLst/>
+          </a:prstGeom>
+          <a:noFill/>
+        </p:spPr>
+        <p:txBody>
+          <a:bodyPr wrap="square" lIns="0" rIns="0" tIns="0" bIns="0" anchor="ctr">
+            <a:spAutoFit/>
+          </a:bodyPr>
+          <a:lstStyle/>
+          <a:p>
+            <a:pPr>
+              <a:spcAft>
+                <a:spcPts val="300"/>
+              </a:spcAft>
+            </a:pPr>
+            <a:r>
+              <a:rPr sz="1100" b="0">
+                <a:solidFill>
+                  <a:srgbClr val="5B6B72"/>
+                </a:solidFill>
+                <a:latin typeface="Calibri"/>
+              </a:rPr>
+              <a:t>India: live today</a:t>
+            </a:r>
+          </a:p>
+        </p:txBody>
+      </p:sp>
+      <p:sp>
+        <p:nvSpPr>
+          <p:cNvPr id="9" name="Oval 8"/>
           <p:cNvSpPr/>
           <p:nvPr/>
         </p:nvSpPr>
         <p:spPr>
           <a:xfrm>
-            <a:off x="731520" y="1984248"/>
+            <a:off x="2148840" y="4049244"/>
             <a:ext cx="146304" cy="146304"/>
           </a:xfrm>
           <a:prstGeom prst="ellipse">
@@ -8993,14 +9054,14 @@
       </p:sp>
       <p:sp>
         <p:nvSpPr>
-          <p:cNvPr id="8" name="TextBox 7"/>
-          <p:cNvSpPr txBox="1"/>
-          <p:nvPr/>
-        </p:nvSpPr>
-        <p:spPr>
-          <a:xfrm>
-            <a:off x="1005840" y="1901952"/>
-            <a:ext cx="2926080" cy="329184"/>
+          <p:cNvPr id="10" name="TextBox 9"/>
+          <p:cNvSpPr txBox="1"/>
+          <p:nvPr/>
+        </p:nvSpPr>
+        <p:spPr>
+          <a:xfrm>
+            <a:off x="2368296" y="4003524"/>
+            <a:ext cx="2103120" cy="237744"/>
           </a:xfrm>
           <a:prstGeom prst="rect">
             <a:avLst/>
@@ -9015,130 +9076,37 @@
           <a:p>
             <a:pPr>
               <a:spcAft>
-                <a:spcPts val="400"/>
+                <a:spcPts val="300"/>
               </a:spcAft>
             </a:pPr>
             <a:r>
-              <a:rPr sz="1700" b="1">
-                <a:solidFill>
-                  <a:srgbClr val="14232B"/>
-                </a:solidFill>
-                <a:latin typeface="Cambria"/>
-              </a:rPr>
-              <a:t>Why it can travel</a:t>
-            </a:r>
-          </a:p>
-        </p:txBody>
-      </p:sp>
-      <p:sp>
-        <p:nvSpPr>
-          <p:cNvPr id="9" name="TextBox 8"/>
-          <p:cNvSpPr txBox="1"/>
-          <p:nvPr/>
-        </p:nvSpPr>
-        <p:spPr>
-          <a:xfrm>
-            <a:off x="777240" y="2468880"/>
-            <a:ext cx="3108960" cy="3200400"/>
-          </a:xfrm>
-          <a:prstGeom prst="rect">
-            <a:avLst/>
-          </a:prstGeom>
-          <a:noFill/>
-        </p:spPr>
-        <p:txBody>
-          <a:bodyPr wrap="square" lIns="0" rIns="0" tIns="0" bIns="0" anchor="t">
-            <a:spAutoFit/>
-          </a:bodyPr>
-          <a:lstStyle/>
-          <a:p>
-            <a:pPr marL="171450" indent="-171450">
-              <a:spcAft>
-                <a:spcPts val="700"/>
-              </a:spcAft>
-              <a:buChar char="•"/>
-            </a:pPr>
-            <a:r>
-              <a:rPr sz="1400" b="0">
-                <a:solidFill>
-                  <a:srgbClr val="14232B"/>
+              <a:rPr sz="1100" b="0">
+                <a:solidFill>
+                  <a:srgbClr val="5B6B72"/>
                 </a:solidFill>
                 <a:latin typeface="Calibri"/>
               </a:rPr>
-              <a:t>Core is city- and field-agnostic: a new place is one config file, not new code</a:t>
-            </a:r>
-          </a:p>
-          <a:p>
-            <a:pPr marL="171450" indent="-171450">
-              <a:spcAft>
-                <a:spcPts val="700"/>
-              </a:spcAft>
-              <a:buChar char="•"/>
-            </a:pPr>
-            <a:r>
-              <a:rPr sz="1400" b="0">
-                <a:solidFill>
-                  <a:srgbClr val="14232B"/>
-                </a:solidFill>
-                <a:latin typeface="Calibri"/>
-              </a:rPr>
-              <a:t>Built on global open data: OSM, WorldPop, GHSL, night lights</a:t>
-            </a:r>
-          </a:p>
-          <a:p>
-            <a:pPr marL="171450" indent="-171450">
-              <a:spcAft>
-                <a:spcPts val="700"/>
-              </a:spcAft>
-              <a:buChar char="•"/>
-            </a:pPr>
-            <a:r>
-              <a:rPr sz="1400" b="0">
-                <a:solidFill>
-                  <a:srgbClr val="14232B"/>
-                </a:solidFill>
-                <a:latin typeface="Calibri"/>
-              </a:rPr>
-              <a:t>Open source DPG, open standards, swappable AI providers</a:t>
-            </a:r>
-          </a:p>
-          <a:p>
-            <a:pPr marL="171450" indent="-171450">
-              <a:spcAft>
-                <a:spcPts val="700"/>
-              </a:spcAft>
-              <a:buChar char="•"/>
-            </a:pPr>
-            <a:r>
-              <a:rPr sz="1400" b="0">
-                <a:solidFill>
-                  <a:srgbClr val="14232B"/>
-                </a:solidFill>
-                <a:latin typeface="Calibri"/>
-              </a:rPr>
-              <a:t>Language picker already groups Portuguese, Russian and Chinese as BRICS / international</a:t>
-            </a:r>
-          </a:p>
-        </p:txBody>
-      </p:sp>
-      <p:sp>
-        <p:nvSpPr>
-          <p:cNvPr id="10" name="Rounded Rectangle 9"/>
+              <a:t>Other members: proposed</a:t>
+            </a:r>
+          </a:p>
+        </p:txBody>
+      </p:sp>
+      <p:sp>
+        <p:nvSpPr>
+          <p:cNvPr id="11" name="Oval 10"/>
           <p:cNvSpPr/>
           <p:nvPr/>
         </p:nvSpPr>
         <p:spPr>
           <a:xfrm>
-            <a:off x="4311396" y="1783080"/>
-            <a:ext cx="3566160" cy="3977639"/>
-          </a:xfrm>
-          <a:prstGeom prst="roundRect">
-            <a:avLst>
-              <a:gd name="adj" fmla="val 2564"/>
-            </a:avLst>
+            <a:off x="4343400" y="4049244"/>
+            <a:ext cx="146304" cy="146304"/>
+          </a:xfrm>
+          <a:prstGeom prst="ellipse">
+            <a:avLst/>
           </a:prstGeom>
           <a:solidFill>
-            <a:srgbClr val="EAF2F3"/>
+            <a:srgbClr val="D5E1E3"/>
           </a:solidFill>
           <a:ln>
             <a:noFill/>
@@ -9169,20 +9137,100 @@
       </p:sp>
       <p:sp>
         <p:nvSpPr>
-          <p:cNvPr id="11" name="Oval 10"/>
+          <p:cNvPr id="12" name="TextBox 11"/>
+          <p:cNvSpPr txBox="1"/>
+          <p:nvPr/>
+        </p:nvSpPr>
+        <p:spPr>
+          <a:xfrm>
+            <a:off x="4562856" y="4003524"/>
+            <a:ext cx="2103120" cy="237744"/>
+          </a:xfrm>
+          <a:prstGeom prst="rect">
+            <a:avLst/>
+          </a:prstGeom>
+          <a:noFill/>
+        </p:spPr>
+        <p:txBody>
+          <a:bodyPr wrap="square" lIns="0" rIns="0" tIns="0" bIns="0" anchor="ctr">
+            <a:spAutoFit/>
+          </a:bodyPr>
+          <a:lstStyle/>
+          <a:p>
+            <a:pPr>
+              <a:spcAft>
+                <a:spcPts val="300"/>
+              </a:spcAft>
+            </a:pPr>
+            <a:r>
+              <a:rPr sz="1100" b="0">
+                <a:solidFill>
+                  <a:srgbClr val="5B6B72"/>
+                </a:solidFill>
+                <a:latin typeface="Calibri"/>
+              </a:rPr>
+              <a:t>Not in scope</a:t>
+            </a:r>
+          </a:p>
+        </p:txBody>
+      </p:sp>
+      <p:sp>
+        <p:nvSpPr>
+          <p:cNvPr id="13" name="TextBox 12"/>
+          <p:cNvSpPr txBox="1"/>
+          <p:nvPr/>
+        </p:nvSpPr>
+        <p:spPr>
+          <a:xfrm>
+            <a:off x="6858000" y="1645920"/>
+            <a:ext cx="4572000" cy="274320"/>
+          </a:xfrm>
+          <a:prstGeom prst="rect">
+            <a:avLst/>
+          </a:prstGeom>
+          <a:noFill/>
+        </p:spPr>
+        <p:txBody>
+          <a:bodyPr wrap="square" lIns="0" rIns="0" tIns="0" bIns="0" anchor="t">
+            <a:spAutoFit/>
+          </a:bodyPr>
+          <a:lstStyle/>
+          <a:p>
+            <a:pPr>
+              <a:spcAft>
+                <a:spcPts val="300"/>
+              </a:spcAft>
+            </a:pPr>
+            <a:r>
+              <a:rPr sz="1100" b="1">
+                <a:solidFill>
+                  <a:srgbClr val="0B4F5C"/>
+                </a:solidFill>
+                <a:latin typeface="Calibri"/>
+              </a:rPr>
+              <a:t>MEMBERS AND MAIN LANGUAGES</a:t>
+            </a:r>
+          </a:p>
+        </p:txBody>
+      </p:sp>
+      <p:sp>
+        <p:nvSpPr>
+          <p:cNvPr id="14" name="Rounded Rectangle 13"/>
           <p:cNvSpPr/>
           <p:nvPr/>
         </p:nvSpPr>
         <p:spPr>
           <a:xfrm>
-            <a:off x="4494276" y="1984248"/>
-            <a:ext cx="146304" cy="146304"/>
-          </a:xfrm>
-          <a:prstGeom prst="ellipse">
-            <a:avLst/>
+            <a:off x="6858000" y="1965960"/>
+            <a:ext cx="2286000" cy="365760"/>
+          </a:xfrm>
+          <a:prstGeom prst="roundRect">
+            <a:avLst>
+              <a:gd name="adj" fmla="val 25000"/>
+            </a:avLst>
           </a:prstGeom>
           <a:solidFill>
-            <a:srgbClr val="0B4F5C"/>
+            <a:srgbClr val="E08A1E"/>
           </a:solidFill>
           <a:ln>
             <a:noFill/>
@@ -9213,14 +9261,14 @@
       </p:sp>
       <p:sp>
         <p:nvSpPr>
-          <p:cNvPr id="12" name="TextBox 11"/>
-          <p:cNvSpPr txBox="1"/>
-          <p:nvPr/>
-        </p:nvSpPr>
-        <p:spPr>
-          <a:xfrm>
-            <a:off x="4768596" y="1901952"/>
-            <a:ext cx="2926080" cy="329184"/>
+          <p:cNvPr id="15" name="TextBox 14"/>
+          <p:cNvSpPr txBox="1"/>
+          <p:nvPr/>
+        </p:nvSpPr>
+        <p:spPr>
+          <a:xfrm>
+            <a:off x="6995160" y="1965960"/>
+            <a:ext cx="2011680" cy="365760"/>
           </a:xfrm>
           <a:prstGeom prst="rect">
             <a:avLst/>
@@ -9235,126 +9283,74 @@
           <a:p>
             <a:pPr>
               <a:spcAft>
-                <a:spcPts val="400"/>
+                <a:spcPts val="300"/>
               </a:spcAft>
             </a:pPr>
             <a:r>
-              <a:rPr sz="1700" b="1">
-                <a:solidFill>
-                  <a:srgbClr val="14232B"/>
-                </a:solidFill>
-                <a:latin typeface="Cambria"/>
-              </a:rPr>
-              <a:t>What we can do</a:t>
-            </a:r>
-          </a:p>
-        </p:txBody>
-      </p:sp>
-      <p:sp>
-        <p:nvSpPr>
-          <p:cNvPr id="13" name="TextBox 12"/>
-          <p:cNvSpPr txBox="1"/>
-          <p:nvPr/>
-        </p:nvSpPr>
-        <p:spPr>
-          <a:xfrm>
-            <a:off x="4539996" y="2468880"/>
-            <a:ext cx="3108960" cy="3200400"/>
-          </a:xfrm>
-          <a:prstGeom prst="rect">
-            <a:avLst/>
-          </a:prstGeom>
-          <a:noFill/>
-        </p:spPr>
-        <p:txBody>
-          <a:bodyPr wrap="square" lIns="0" rIns="0" tIns="0" bIns="0" anchor="t">
+              <a:rPr sz="1200" b="1">
+                <a:solidFill>
+                  <a:srgbClr val="FFFFFF"/>
+                </a:solidFill>
+                <a:latin typeface="Calibri"/>
+              </a:rPr>
+              <a:t>India</a:t>
+            </a:r>
+          </a:p>
+        </p:txBody>
+      </p:sp>
+      <p:sp>
+        <p:nvSpPr>
+          <p:cNvPr id="16" name="TextBox 15"/>
+          <p:cNvSpPr txBox="1"/>
+          <p:nvPr/>
+        </p:nvSpPr>
+        <p:spPr>
+          <a:xfrm>
+            <a:off x="6995160" y="1965960"/>
+            <a:ext cx="2011680" cy="365760"/>
+          </a:xfrm>
+          <a:prstGeom prst="rect">
+            <a:avLst/>
+          </a:prstGeom>
+          <a:noFill/>
+        </p:spPr>
+        <p:txBody>
+          <a:bodyPr wrap="square" lIns="0" rIns="0" tIns="0" bIns="0" anchor="ctr">
             <a:spAutoFit/>
           </a:bodyPr>
           <a:lstStyle/>
           <a:p>
-            <a:pPr marL="171450" indent="-171450">
+            <a:pPr algn="r">
               <a:spcAft>
-                <a:spcPts val="700"/>
+                <a:spcPts val="300"/>
               </a:spcAft>
-              <a:buChar char="•"/>
-            </a:pPr>
-            <a:r>
-              <a:rPr sz="1400" b="0">
-                <a:solidFill>
-                  <a:srgbClr val="14232B"/>
+            </a:pPr>
+            <a:r>
+              <a:rPr sz="1100" b="0">
+                <a:solidFill>
+                  <a:srgbClr val="FFFFFF"/>
                 </a:solidFill>
                 <a:latin typeface="Calibri"/>
               </a:rPr>
-              <a:t>Pilot one city per member: for example Brazil, Russia, China, South Africa</a:t>
-            </a:r>
-          </a:p>
-          <a:p>
-            <a:pPr marL="171450" indent="-171450">
-              <a:spcAft>
-                <a:spcPts val="700"/>
-              </a:spcAft>
-              <a:buChar char="•"/>
-            </a:pPr>
-            <a:r>
-              <a:rPr sz="1400" b="0">
-                <a:solidFill>
-                  <a:srgbClr val="14232B"/>
-                </a:solidFill>
-                <a:latin typeface="Calibri"/>
-              </a:rPr>
-              <a:t>Same explainable scores everywhere, so access to highways, metro and rail is comparable</a:t>
-            </a:r>
-          </a:p>
-          <a:p>
-            <a:pPr marL="171450" indent="-171450">
-              <a:spcAft>
-                <a:spcPts val="700"/>
-              </a:spcAft>
-              <a:buChar char="•"/>
-            </a:pPr>
-            <a:r>
-              <a:rPr sz="1400" b="0">
-                <a:solidFill>
-                  <a:srgbClr val="14232B"/>
-                </a:solidFill>
-                <a:latin typeface="Calibri"/>
-              </a:rPr>
-              <a:t>Voice and text intake in each national language on the existing pipeline</a:t>
-            </a:r>
-          </a:p>
-          <a:p>
-            <a:pPr marL="171450" indent="-171450">
-              <a:spcAft>
-                <a:spcPts val="700"/>
-              </a:spcAft>
-              <a:buChar char="•"/>
-            </a:pPr>
-            <a:r>
-              <a:rPr sz="1400" b="0">
-                <a:solidFill>
-                  <a:srgbClr val="14232B"/>
-                </a:solidFill>
-                <a:latin typeface="Calibri"/>
-              </a:rPr>
-              <a:t>Share the toolkit as a DPG through BRICS forums, so each country runs its own copy</a:t>
-            </a:r>
-          </a:p>
-        </p:txBody>
-      </p:sp>
-      <p:sp>
-        <p:nvSpPr>
-          <p:cNvPr id="14" name="Rounded Rectangle 13"/>
+              <a:t>Hindi, English +20</a:t>
+            </a:r>
+          </a:p>
+        </p:txBody>
+      </p:sp>
+      <p:sp>
+        <p:nvSpPr>
+          <p:cNvPr id="17" name="Rounded Rectangle 16"/>
           <p:cNvSpPr/>
           <p:nvPr/>
         </p:nvSpPr>
         <p:spPr>
           <a:xfrm>
-            <a:off x="8074152" y="1783080"/>
-            <a:ext cx="3566160" cy="3977639"/>
+            <a:off x="9354312" y="1965960"/>
+            <a:ext cx="2286000" cy="365760"/>
           </a:xfrm>
           <a:prstGeom prst="roundRect">
             <a:avLst>
-              <a:gd name="adj" fmla="val 2564"/>
+              <a:gd name="adj" fmla="val 25000"/>
             </a:avLst>
           </a:prstGeom>
           <a:solidFill>
@@ -9389,20 +9385,100 @@
       </p:sp>
       <p:sp>
         <p:nvSpPr>
-          <p:cNvPr id="15" name="Oval 14"/>
+          <p:cNvPr id="18" name="TextBox 17"/>
+          <p:cNvSpPr txBox="1"/>
+          <p:nvPr/>
+        </p:nvSpPr>
+        <p:spPr>
+          <a:xfrm>
+            <a:off x="9491472" y="1965960"/>
+            <a:ext cx="2011680" cy="365760"/>
+          </a:xfrm>
+          <a:prstGeom prst="rect">
+            <a:avLst/>
+          </a:prstGeom>
+          <a:noFill/>
+        </p:spPr>
+        <p:txBody>
+          <a:bodyPr wrap="square" lIns="0" rIns="0" tIns="0" bIns="0" anchor="ctr">
+            <a:spAutoFit/>
+          </a:bodyPr>
+          <a:lstStyle/>
+          <a:p>
+            <a:pPr>
+              <a:spcAft>
+                <a:spcPts val="300"/>
+              </a:spcAft>
+            </a:pPr>
+            <a:r>
+              <a:rPr sz="1200" b="1">
+                <a:solidFill>
+                  <a:srgbClr val="14232B"/>
+                </a:solidFill>
+                <a:latin typeface="Calibri"/>
+              </a:rPr>
+              <a:t>Brazil</a:t>
+            </a:r>
+          </a:p>
+        </p:txBody>
+      </p:sp>
+      <p:sp>
+        <p:nvSpPr>
+          <p:cNvPr id="19" name="TextBox 18"/>
+          <p:cNvSpPr txBox="1"/>
+          <p:nvPr/>
+        </p:nvSpPr>
+        <p:spPr>
+          <a:xfrm>
+            <a:off x="9491472" y="1965960"/>
+            <a:ext cx="2011680" cy="365760"/>
+          </a:xfrm>
+          <a:prstGeom prst="rect">
+            <a:avLst/>
+          </a:prstGeom>
+          <a:noFill/>
+        </p:spPr>
+        <p:txBody>
+          <a:bodyPr wrap="square" lIns="0" rIns="0" tIns="0" bIns="0" anchor="ctr">
+            <a:spAutoFit/>
+          </a:bodyPr>
+          <a:lstStyle/>
+          <a:p>
+            <a:pPr algn="r">
+              <a:spcAft>
+                <a:spcPts val="300"/>
+              </a:spcAft>
+            </a:pPr>
+            <a:r>
+              <a:rPr sz="1100" b="0">
+                <a:solidFill>
+                  <a:srgbClr val="5B6B72"/>
+                </a:solidFill>
+                <a:latin typeface="Calibri"/>
+              </a:rPr>
+              <a:t>Portuguese</a:t>
+            </a:r>
+          </a:p>
+        </p:txBody>
+      </p:sp>
+      <p:sp>
+        <p:nvSpPr>
+          <p:cNvPr id="20" name="Rounded Rectangle 19"/>
           <p:cNvSpPr/>
           <p:nvPr/>
         </p:nvSpPr>
         <p:spPr>
           <a:xfrm>
-            <a:off x="8257031" y="1984248"/>
-            <a:ext cx="146304" cy="146304"/>
-          </a:xfrm>
-          <a:prstGeom prst="ellipse">
-            <a:avLst/>
+            <a:off x="6858000" y="2414015"/>
+            <a:ext cx="2286000" cy="365760"/>
+          </a:xfrm>
+          <a:prstGeom prst="roundRect">
+            <a:avLst>
+              <a:gd name="adj" fmla="val 25000"/>
+            </a:avLst>
           </a:prstGeom>
           <a:solidFill>
-            <a:srgbClr val="E08A1E"/>
+            <a:srgbClr val="EAF2F3"/>
           </a:solidFill>
           <a:ln>
             <a:noFill/>
@@ -9433,14 +9509,14 @@
       </p:sp>
       <p:sp>
         <p:nvSpPr>
-          <p:cNvPr id="16" name="TextBox 15"/>
-          <p:cNvSpPr txBox="1"/>
-          <p:nvPr/>
-        </p:nvSpPr>
-        <p:spPr>
-          <a:xfrm>
-            <a:off x="8531352" y="1901952"/>
-            <a:ext cx="2926080" cy="329184"/>
+          <p:cNvPr id="21" name="TextBox 20"/>
+          <p:cNvSpPr txBox="1"/>
+          <p:nvPr/>
+        </p:nvSpPr>
+        <p:spPr>
+          <a:xfrm>
+            <a:off x="6995160" y="2414015"/>
+            <a:ext cx="2011680" cy="365760"/>
           </a:xfrm>
           <a:prstGeom prst="rect">
             <a:avLst/>
@@ -9455,147 +9531,78 @@
           <a:p>
             <a:pPr>
               <a:spcAft>
-                <a:spcPts val="400"/>
+                <a:spcPts val="300"/>
               </a:spcAft>
             </a:pPr>
             <a:r>
-              <a:rPr sz="1700" b="1">
+              <a:rPr sz="1200" b="1">
                 <a:solidFill>
                   <a:srgbClr val="14232B"/>
                 </a:solidFill>
-                <a:latin typeface="Cambria"/>
-              </a:rPr>
-              <a:t>What we should do first</a:t>
-            </a:r>
-          </a:p>
-        </p:txBody>
-      </p:sp>
-      <p:sp>
-        <p:nvSpPr>
-          <p:cNvPr id="17" name="TextBox 16"/>
-          <p:cNvSpPr txBox="1"/>
-          <p:nvPr/>
-        </p:nvSpPr>
-        <p:spPr>
-          <a:xfrm>
-            <a:off x="8302752" y="2468880"/>
-            <a:ext cx="3108960" cy="3200400"/>
-          </a:xfrm>
-          <a:prstGeom prst="rect">
-            <a:avLst/>
-          </a:prstGeom>
-          <a:noFill/>
-        </p:spPr>
-        <p:txBody>
-          <a:bodyPr wrap="square" lIns="0" rIns="0" tIns="0" bIns="0" anchor="t">
+                <a:latin typeface="Calibri"/>
+              </a:rPr>
+              <a:t>Russia</a:t>
+            </a:r>
+          </a:p>
+        </p:txBody>
+      </p:sp>
+      <p:sp>
+        <p:nvSpPr>
+          <p:cNvPr id="22" name="TextBox 21"/>
+          <p:cNvSpPr txBox="1"/>
+          <p:nvPr/>
+        </p:nvSpPr>
+        <p:spPr>
+          <a:xfrm>
+            <a:off x="6995160" y="2414015"/>
+            <a:ext cx="2011680" cy="365760"/>
+          </a:xfrm>
+          <a:prstGeom prst="rect">
+            <a:avLst/>
+          </a:prstGeom>
+          <a:noFill/>
+        </p:spPr>
+        <p:txBody>
+          <a:bodyPr wrap="square" lIns="0" rIns="0" tIns="0" bIns="0" anchor="ctr">
             <a:spAutoFit/>
           </a:bodyPr>
           <a:lstStyle/>
           <a:p>
-            <a:pPr marL="171450" indent="-171450">
+            <a:pPr algn="r">
               <a:spcAft>
-                <a:spcPts val="700"/>
+                <a:spcPts val="300"/>
               </a:spcAft>
-              <a:buChar char="•"/>
-            </a:pPr>
-            <a:r>
-              <a:rPr sz="1400" b="0">
-                <a:solidFill>
-                  <a:srgbClr val="14232B"/>
+            </a:pPr>
+            <a:r>
+              <a:rPr sz="1100" b="0">
+                <a:solidFill>
+                  <a:srgbClr val="5B6B72"/>
                 </a:solidFill>
                 <a:latin typeface="Calibri"/>
               </a:rPr>
-              <a:t>Write an ADR: scope today is India only (ADR-0013)</a:t>
-            </a:r>
-          </a:p>
-          <a:p>
-            <a:pPr marL="171450" indent="-171450">
-              <a:spcAft>
-                <a:spcPts val="700"/>
-              </a:spcAft>
-              <a:buChar char="•"/>
-            </a:pPr>
-            <a:r>
-              <a:rPr sz="1400" b="0">
-                <a:solidFill>
-                  <a:srgbClr val="14232B"/>
-                </a:solidFill>
-                <a:latin typeface="Calibri"/>
-              </a:rPr>
-              <a:t>Check licences per country before ingesting any data</a:t>
-            </a:r>
-          </a:p>
-          <a:p>
-            <a:pPr marL="171450" indent="-171450">
-              <a:spcAft>
-                <a:spcPts val="700"/>
-              </a:spcAft>
-              <a:buChar char="•"/>
-            </a:pPr>
-            <a:r>
-              <a:rPr sz="1400" b="0">
-                <a:solidFill>
-                  <a:srgbClr val="14232B"/>
-                </a:solidFill>
-                <a:latin typeface="Calibri"/>
-              </a:rPr>
-              <a:t>Swap in each country's official boundaries; India's come from Survey of India</a:t>
-            </a:r>
-          </a:p>
-          <a:p>
-            <a:pPr marL="171450" indent="-171450">
-              <a:spcAft>
-                <a:spcPts val="700"/>
-              </a:spcAft>
-              <a:buChar char="•"/>
-            </a:pPr>
-            <a:r>
-              <a:rPr sz="1400" b="0">
-                <a:solidFill>
-                  <a:srgbClr val="14232B"/>
-                </a:solidFill>
-                <a:latin typeface="Calibri"/>
-              </a:rPr>
-              <a:t>Map privacy law per country (LGPD, 152-FZ, PIPL, POPIA) before any citizen data</a:t>
-            </a:r>
-          </a:p>
-          <a:p>
-            <a:pPr marL="171450" indent="-171450">
-              <a:spcAft>
-                <a:spcPts val="700"/>
-              </a:spcAft>
-              <a:buChar char="•"/>
-            </a:pPr>
-            <a:r>
-              <a:rPr sz="1400" b="0">
-                <a:solidFill>
-                  <a:srgbClr val="14232B"/>
-                </a:solidFill>
-                <a:latin typeface="Calibri"/>
-              </a:rPr>
-              <a:t>Measure language quality with a gold set per language before launch</a:t>
-            </a:r>
-          </a:p>
-        </p:txBody>
-      </p:sp>
-      <p:sp>
-        <p:nvSpPr>
-          <p:cNvPr id="18" name="Rounded Rectangle 17"/>
+              <a:t>Russian</a:t>
+            </a:r>
+          </a:p>
+        </p:txBody>
+      </p:sp>
+      <p:sp>
+        <p:nvSpPr>
+          <p:cNvPr id="23" name="Rounded Rectangle 22"/>
           <p:cNvSpPr/>
           <p:nvPr/>
         </p:nvSpPr>
         <p:spPr>
           <a:xfrm>
-            <a:off x="548640" y="5897880"/>
-            <a:ext cx="11091672" cy="411480"/>
+            <a:off x="9354312" y="2414015"/>
+            <a:ext cx="2286000" cy="365760"/>
           </a:xfrm>
           <a:prstGeom prst="roundRect">
             <a:avLst>
-              <a:gd name="adj" fmla="val 22222"/>
+              <a:gd name="adj" fmla="val 25000"/>
             </a:avLst>
           </a:prstGeom>
           <a:solidFill>
-            <a:srgbClr val="072C34"/>
+            <a:srgbClr val="EAF2F3"/>
           </a:solidFill>
           <a:ln>
             <a:noFill/>
@@ -9626,14 +9633,14 @@
       </p:sp>
       <p:sp>
         <p:nvSpPr>
-          <p:cNvPr id="19" name="TextBox 18"/>
-          <p:cNvSpPr txBox="1"/>
-          <p:nvPr/>
-        </p:nvSpPr>
-        <p:spPr>
-          <a:xfrm>
-            <a:off x="777240" y="5897880"/>
-            <a:ext cx="10698480" cy="411480"/>
+          <p:cNvPr id="24" name="TextBox 23"/>
+          <p:cNvSpPr txBox="1"/>
+          <p:nvPr/>
+        </p:nvSpPr>
+        <p:spPr>
+          <a:xfrm>
+            <a:off x="9491472" y="2414015"/>
+            <a:ext cx="2011680" cy="365760"/>
           </a:xfrm>
           <a:prstGeom prst="rect">
             <a:avLst/>
@@ -9648,31 +9655,943 @@
           <a:p>
             <a:pPr>
               <a:spcAft>
-                <a:spcPts val="400"/>
+                <a:spcPts val="300"/>
               </a:spcAft>
             </a:pPr>
             <a:r>
-              <a:rPr sz="1200" b="0">
-                <a:solidFill>
-                  <a:srgbClr val="CFE3E6"/>
+              <a:rPr sz="1200" b="1">
+                <a:solidFill>
+                  <a:srgbClr val="14232B"/>
                 </a:solidFill>
                 <a:latin typeface="Calibri"/>
               </a:rPr>
-              <a:t>Scores describe existing infrastructure, never rank countries. Nothing here is built or promised yet.</a:t>
-            </a:r>
-          </a:p>
-        </p:txBody>
-      </p:sp>
-      <p:sp>
-        <p:nvSpPr>
-          <p:cNvPr id="20" name="TextBox 19"/>
-          <p:cNvSpPr txBox="1"/>
-          <p:nvPr/>
-        </p:nvSpPr>
-        <p:spPr>
-          <a:xfrm>
-            <a:off x="548640" y="6446520"/>
-            <a:ext cx="5486400" cy="274320"/>
+              <a:t>China</a:t>
+            </a:r>
+          </a:p>
+        </p:txBody>
+      </p:sp>
+      <p:sp>
+        <p:nvSpPr>
+          <p:cNvPr id="25" name="TextBox 24"/>
+          <p:cNvSpPr txBox="1"/>
+          <p:nvPr/>
+        </p:nvSpPr>
+        <p:spPr>
+          <a:xfrm>
+            <a:off x="9491472" y="2414015"/>
+            <a:ext cx="2011680" cy="365760"/>
+          </a:xfrm>
+          <a:prstGeom prst="rect">
+            <a:avLst/>
+          </a:prstGeom>
+          <a:noFill/>
+        </p:spPr>
+        <p:txBody>
+          <a:bodyPr wrap="square" lIns="0" rIns="0" tIns="0" bIns="0" anchor="ctr">
+            <a:spAutoFit/>
+          </a:bodyPr>
+          <a:lstStyle/>
+          <a:p>
+            <a:pPr algn="r">
+              <a:spcAft>
+                <a:spcPts val="300"/>
+              </a:spcAft>
+            </a:pPr>
+            <a:r>
+              <a:rPr sz="1100" b="0">
+                <a:solidFill>
+                  <a:srgbClr val="5B6B72"/>
+                </a:solidFill>
+                <a:latin typeface="Calibri"/>
+              </a:rPr>
+              <a:t>Mandarin</a:t>
+            </a:r>
+          </a:p>
+        </p:txBody>
+      </p:sp>
+      <p:sp>
+        <p:nvSpPr>
+          <p:cNvPr id="26" name="Rounded Rectangle 25"/>
+          <p:cNvSpPr/>
+          <p:nvPr/>
+        </p:nvSpPr>
+        <p:spPr>
+          <a:xfrm>
+            <a:off x="6858000" y="2862072"/>
+            <a:ext cx="2286000" cy="365760"/>
+          </a:xfrm>
+          <a:prstGeom prst="roundRect">
+            <a:avLst>
+              <a:gd name="adj" fmla="val 25000"/>
+            </a:avLst>
+          </a:prstGeom>
+          <a:solidFill>
+            <a:srgbClr val="EAF2F3"/>
+          </a:solidFill>
+          <a:ln>
+            <a:noFill/>
+          </a:ln>
+          <a:effectLst/>
+        </p:spPr>
+        <p:style>
+          <a:lnRef idx="1">
+            <a:schemeClr val="accent1"/>
+          </a:lnRef>
+          <a:fillRef idx="3">
+            <a:schemeClr val="accent1"/>
+          </a:fillRef>
+          <a:effectRef idx="2">
+            <a:schemeClr val="accent1"/>
+          </a:effectRef>
+          <a:fontRef idx="minor">
+            <a:schemeClr val="lt1"/>
+          </a:fontRef>
+        </p:style>
+        <p:txBody>
+          <a:bodyPr rtlCol="0" anchor="ctr"/>
+          <a:lstStyle/>
+          <a:p>
+            <a:pPr algn="ctr"/>
+          </a:p>
+        </p:txBody>
+      </p:sp>
+      <p:sp>
+        <p:nvSpPr>
+          <p:cNvPr id="27" name="TextBox 26"/>
+          <p:cNvSpPr txBox="1"/>
+          <p:nvPr/>
+        </p:nvSpPr>
+        <p:spPr>
+          <a:xfrm>
+            <a:off x="6995160" y="2862072"/>
+            <a:ext cx="2011680" cy="365760"/>
+          </a:xfrm>
+          <a:prstGeom prst="rect">
+            <a:avLst/>
+          </a:prstGeom>
+          <a:noFill/>
+        </p:spPr>
+        <p:txBody>
+          <a:bodyPr wrap="square" lIns="0" rIns="0" tIns="0" bIns="0" anchor="ctr">
+            <a:spAutoFit/>
+          </a:bodyPr>
+          <a:lstStyle/>
+          <a:p>
+            <a:pPr>
+              <a:spcAft>
+                <a:spcPts val="300"/>
+              </a:spcAft>
+            </a:pPr>
+            <a:r>
+              <a:rPr sz="1200" b="1">
+                <a:solidFill>
+                  <a:srgbClr val="14232B"/>
+                </a:solidFill>
+                <a:latin typeface="Calibri"/>
+              </a:rPr>
+              <a:t>South Africa</a:t>
+            </a:r>
+          </a:p>
+        </p:txBody>
+      </p:sp>
+      <p:sp>
+        <p:nvSpPr>
+          <p:cNvPr id="28" name="TextBox 27"/>
+          <p:cNvSpPr txBox="1"/>
+          <p:nvPr/>
+        </p:nvSpPr>
+        <p:spPr>
+          <a:xfrm>
+            <a:off x="6995160" y="2862072"/>
+            <a:ext cx="2011680" cy="365760"/>
+          </a:xfrm>
+          <a:prstGeom prst="rect">
+            <a:avLst/>
+          </a:prstGeom>
+          <a:noFill/>
+        </p:spPr>
+        <p:txBody>
+          <a:bodyPr wrap="square" lIns="0" rIns="0" tIns="0" bIns="0" anchor="ctr">
+            <a:spAutoFit/>
+          </a:bodyPr>
+          <a:lstStyle/>
+          <a:p>
+            <a:pPr algn="r">
+              <a:spcAft>
+                <a:spcPts val="300"/>
+              </a:spcAft>
+            </a:pPr>
+            <a:r>
+              <a:rPr sz="1100" b="0">
+                <a:solidFill>
+                  <a:srgbClr val="5B6B72"/>
+                </a:solidFill>
+                <a:latin typeface="Calibri"/>
+              </a:rPr>
+              <a:t>English +10</a:t>
+            </a:r>
+          </a:p>
+        </p:txBody>
+      </p:sp>
+      <p:sp>
+        <p:nvSpPr>
+          <p:cNvPr id="29" name="Rounded Rectangle 28"/>
+          <p:cNvSpPr/>
+          <p:nvPr/>
+        </p:nvSpPr>
+        <p:spPr>
+          <a:xfrm>
+            <a:off x="9354312" y="2862072"/>
+            <a:ext cx="2286000" cy="365760"/>
+          </a:xfrm>
+          <a:prstGeom prst="roundRect">
+            <a:avLst>
+              <a:gd name="adj" fmla="val 25000"/>
+            </a:avLst>
+          </a:prstGeom>
+          <a:solidFill>
+            <a:srgbClr val="EAF2F3"/>
+          </a:solidFill>
+          <a:ln>
+            <a:noFill/>
+          </a:ln>
+          <a:effectLst/>
+        </p:spPr>
+        <p:style>
+          <a:lnRef idx="1">
+            <a:schemeClr val="accent1"/>
+          </a:lnRef>
+          <a:fillRef idx="3">
+            <a:schemeClr val="accent1"/>
+          </a:fillRef>
+          <a:effectRef idx="2">
+            <a:schemeClr val="accent1"/>
+          </a:effectRef>
+          <a:fontRef idx="minor">
+            <a:schemeClr val="lt1"/>
+          </a:fontRef>
+        </p:style>
+        <p:txBody>
+          <a:bodyPr rtlCol="0" anchor="ctr"/>
+          <a:lstStyle/>
+          <a:p>
+            <a:pPr algn="ctr"/>
+          </a:p>
+        </p:txBody>
+      </p:sp>
+      <p:sp>
+        <p:nvSpPr>
+          <p:cNvPr id="30" name="TextBox 29"/>
+          <p:cNvSpPr txBox="1"/>
+          <p:nvPr/>
+        </p:nvSpPr>
+        <p:spPr>
+          <a:xfrm>
+            <a:off x="9491472" y="2862072"/>
+            <a:ext cx="2011680" cy="365760"/>
+          </a:xfrm>
+          <a:prstGeom prst="rect">
+            <a:avLst/>
+          </a:prstGeom>
+          <a:noFill/>
+        </p:spPr>
+        <p:txBody>
+          <a:bodyPr wrap="square" lIns="0" rIns="0" tIns="0" bIns="0" anchor="ctr">
+            <a:spAutoFit/>
+          </a:bodyPr>
+          <a:lstStyle/>
+          <a:p>
+            <a:pPr>
+              <a:spcAft>
+                <a:spcPts val="300"/>
+              </a:spcAft>
+            </a:pPr>
+            <a:r>
+              <a:rPr sz="1200" b="1">
+                <a:solidFill>
+                  <a:srgbClr val="14232B"/>
+                </a:solidFill>
+                <a:latin typeface="Calibri"/>
+              </a:rPr>
+              <a:t>Indonesia</a:t>
+            </a:r>
+          </a:p>
+        </p:txBody>
+      </p:sp>
+      <p:sp>
+        <p:nvSpPr>
+          <p:cNvPr id="31" name="TextBox 30"/>
+          <p:cNvSpPr txBox="1"/>
+          <p:nvPr/>
+        </p:nvSpPr>
+        <p:spPr>
+          <a:xfrm>
+            <a:off x="9491472" y="2862072"/>
+            <a:ext cx="2011680" cy="365760"/>
+          </a:xfrm>
+          <a:prstGeom prst="rect">
+            <a:avLst/>
+          </a:prstGeom>
+          <a:noFill/>
+        </p:spPr>
+        <p:txBody>
+          <a:bodyPr wrap="square" lIns="0" rIns="0" tIns="0" bIns="0" anchor="ctr">
+            <a:spAutoFit/>
+          </a:bodyPr>
+          <a:lstStyle/>
+          <a:p>
+            <a:pPr algn="r">
+              <a:spcAft>
+                <a:spcPts val="300"/>
+              </a:spcAft>
+            </a:pPr>
+            <a:r>
+              <a:rPr sz="1100" b="0">
+                <a:solidFill>
+                  <a:srgbClr val="5B6B72"/>
+                </a:solidFill>
+                <a:latin typeface="Calibri"/>
+              </a:rPr>
+              <a:t>Bahasa</a:t>
+            </a:r>
+          </a:p>
+        </p:txBody>
+      </p:sp>
+      <p:sp>
+        <p:nvSpPr>
+          <p:cNvPr id="32" name="Rounded Rectangle 31"/>
+          <p:cNvSpPr/>
+          <p:nvPr/>
+        </p:nvSpPr>
+        <p:spPr>
+          <a:xfrm>
+            <a:off x="6858000" y="3310128"/>
+            <a:ext cx="2286000" cy="365760"/>
+          </a:xfrm>
+          <a:prstGeom prst="roundRect">
+            <a:avLst>
+              <a:gd name="adj" fmla="val 25000"/>
+            </a:avLst>
+          </a:prstGeom>
+          <a:solidFill>
+            <a:srgbClr val="EAF2F3"/>
+          </a:solidFill>
+          <a:ln>
+            <a:noFill/>
+          </a:ln>
+          <a:effectLst/>
+        </p:spPr>
+        <p:style>
+          <a:lnRef idx="1">
+            <a:schemeClr val="accent1"/>
+          </a:lnRef>
+          <a:fillRef idx="3">
+            <a:schemeClr val="accent1"/>
+          </a:fillRef>
+          <a:effectRef idx="2">
+            <a:schemeClr val="accent1"/>
+          </a:effectRef>
+          <a:fontRef idx="minor">
+            <a:schemeClr val="lt1"/>
+          </a:fontRef>
+        </p:style>
+        <p:txBody>
+          <a:bodyPr rtlCol="0" anchor="ctr"/>
+          <a:lstStyle/>
+          <a:p>
+            <a:pPr algn="ctr"/>
+          </a:p>
+        </p:txBody>
+      </p:sp>
+      <p:sp>
+        <p:nvSpPr>
+          <p:cNvPr id="33" name="TextBox 32"/>
+          <p:cNvSpPr txBox="1"/>
+          <p:nvPr/>
+        </p:nvSpPr>
+        <p:spPr>
+          <a:xfrm>
+            <a:off x="6995160" y="3310128"/>
+            <a:ext cx="2011680" cy="365760"/>
+          </a:xfrm>
+          <a:prstGeom prst="rect">
+            <a:avLst/>
+          </a:prstGeom>
+          <a:noFill/>
+        </p:spPr>
+        <p:txBody>
+          <a:bodyPr wrap="square" lIns="0" rIns="0" tIns="0" bIns="0" anchor="ctr">
+            <a:spAutoFit/>
+          </a:bodyPr>
+          <a:lstStyle/>
+          <a:p>
+            <a:pPr>
+              <a:spcAft>
+                <a:spcPts val="300"/>
+              </a:spcAft>
+            </a:pPr>
+            <a:r>
+              <a:rPr sz="1200" b="1">
+                <a:solidFill>
+                  <a:srgbClr val="14232B"/>
+                </a:solidFill>
+                <a:latin typeface="Calibri"/>
+              </a:rPr>
+              <a:t>Egypt</a:t>
+            </a:r>
+          </a:p>
+        </p:txBody>
+      </p:sp>
+      <p:sp>
+        <p:nvSpPr>
+          <p:cNvPr id="34" name="TextBox 33"/>
+          <p:cNvSpPr txBox="1"/>
+          <p:nvPr/>
+        </p:nvSpPr>
+        <p:spPr>
+          <a:xfrm>
+            <a:off x="6995160" y="3310128"/>
+            <a:ext cx="2011680" cy="365760"/>
+          </a:xfrm>
+          <a:prstGeom prst="rect">
+            <a:avLst/>
+          </a:prstGeom>
+          <a:noFill/>
+        </p:spPr>
+        <p:txBody>
+          <a:bodyPr wrap="square" lIns="0" rIns="0" tIns="0" bIns="0" anchor="ctr">
+            <a:spAutoFit/>
+          </a:bodyPr>
+          <a:lstStyle/>
+          <a:p>
+            <a:pPr algn="r">
+              <a:spcAft>
+                <a:spcPts val="300"/>
+              </a:spcAft>
+            </a:pPr>
+            <a:r>
+              <a:rPr sz="1100" b="0">
+                <a:solidFill>
+                  <a:srgbClr val="5B6B72"/>
+                </a:solidFill>
+                <a:latin typeface="Calibri"/>
+              </a:rPr>
+              <a:t>Arabic</a:t>
+            </a:r>
+          </a:p>
+        </p:txBody>
+      </p:sp>
+      <p:sp>
+        <p:nvSpPr>
+          <p:cNvPr id="35" name="Rounded Rectangle 34"/>
+          <p:cNvSpPr/>
+          <p:nvPr/>
+        </p:nvSpPr>
+        <p:spPr>
+          <a:xfrm>
+            <a:off x="9354312" y="3310128"/>
+            <a:ext cx="2286000" cy="365760"/>
+          </a:xfrm>
+          <a:prstGeom prst="roundRect">
+            <a:avLst>
+              <a:gd name="adj" fmla="val 25000"/>
+            </a:avLst>
+          </a:prstGeom>
+          <a:solidFill>
+            <a:srgbClr val="EAF2F3"/>
+          </a:solidFill>
+          <a:ln>
+            <a:noFill/>
+          </a:ln>
+          <a:effectLst/>
+        </p:spPr>
+        <p:style>
+          <a:lnRef idx="1">
+            <a:schemeClr val="accent1"/>
+          </a:lnRef>
+          <a:fillRef idx="3">
+            <a:schemeClr val="accent1"/>
+          </a:fillRef>
+          <a:effectRef idx="2">
+            <a:schemeClr val="accent1"/>
+          </a:effectRef>
+          <a:fontRef idx="minor">
+            <a:schemeClr val="lt1"/>
+          </a:fontRef>
+        </p:style>
+        <p:txBody>
+          <a:bodyPr rtlCol="0" anchor="ctr"/>
+          <a:lstStyle/>
+          <a:p>
+            <a:pPr algn="ctr"/>
+          </a:p>
+        </p:txBody>
+      </p:sp>
+      <p:sp>
+        <p:nvSpPr>
+          <p:cNvPr id="36" name="TextBox 35"/>
+          <p:cNvSpPr txBox="1"/>
+          <p:nvPr/>
+        </p:nvSpPr>
+        <p:spPr>
+          <a:xfrm>
+            <a:off x="9491472" y="3310128"/>
+            <a:ext cx="2011680" cy="365760"/>
+          </a:xfrm>
+          <a:prstGeom prst="rect">
+            <a:avLst/>
+          </a:prstGeom>
+          <a:noFill/>
+        </p:spPr>
+        <p:txBody>
+          <a:bodyPr wrap="square" lIns="0" rIns="0" tIns="0" bIns="0" anchor="ctr">
+            <a:spAutoFit/>
+          </a:bodyPr>
+          <a:lstStyle/>
+          <a:p>
+            <a:pPr>
+              <a:spcAft>
+                <a:spcPts val="300"/>
+              </a:spcAft>
+            </a:pPr>
+            <a:r>
+              <a:rPr sz="1200" b="1">
+                <a:solidFill>
+                  <a:srgbClr val="14232B"/>
+                </a:solidFill>
+                <a:latin typeface="Calibri"/>
+              </a:rPr>
+              <a:t>Ethiopia</a:t>
+            </a:r>
+          </a:p>
+        </p:txBody>
+      </p:sp>
+      <p:sp>
+        <p:nvSpPr>
+          <p:cNvPr id="37" name="TextBox 36"/>
+          <p:cNvSpPr txBox="1"/>
+          <p:nvPr/>
+        </p:nvSpPr>
+        <p:spPr>
+          <a:xfrm>
+            <a:off x="9491472" y="3310128"/>
+            <a:ext cx="2011680" cy="365760"/>
+          </a:xfrm>
+          <a:prstGeom prst="rect">
+            <a:avLst/>
+          </a:prstGeom>
+          <a:noFill/>
+        </p:spPr>
+        <p:txBody>
+          <a:bodyPr wrap="square" lIns="0" rIns="0" tIns="0" bIns="0" anchor="ctr">
+            <a:spAutoFit/>
+          </a:bodyPr>
+          <a:lstStyle/>
+          <a:p>
+            <a:pPr algn="r">
+              <a:spcAft>
+                <a:spcPts val="300"/>
+              </a:spcAft>
+            </a:pPr>
+            <a:r>
+              <a:rPr sz="1100" b="0">
+                <a:solidFill>
+                  <a:srgbClr val="5B6B72"/>
+                </a:solidFill>
+                <a:latin typeface="Calibri"/>
+              </a:rPr>
+              <a:t>Amharic</a:t>
+            </a:r>
+          </a:p>
+        </p:txBody>
+      </p:sp>
+      <p:sp>
+        <p:nvSpPr>
+          <p:cNvPr id="38" name="Rounded Rectangle 37"/>
+          <p:cNvSpPr/>
+          <p:nvPr/>
+        </p:nvSpPr>
+        <p:spPr>
+          <a:xfrm>
+            <a:off x="6858000" y="3758183"/>
+            <a:ext cx="2286000" cy="365760"/>
+          </a:xfrm>
+          <a:prstGeom prst="roundRect">
+            <a:avLst>
+              <a:gd name="adj" fmla="val 25000"/>
+            </a:avLst>
+          </a:prstGeom>
+          <a:solidFill>
+            <a:srgbClr val="EAF2F3"/>
+          </a:solidFill>
+          <a:ln>
+            <a:noFill/>
+          </a:ln>
+          <a:effectLst/>
+        </p:spPr>
+        <p:style>
+          <a:lnRef idx="1">
+            <a:schemeClr val="accent1"/>
+          </a:lnRef>
+          <a:fillRef idx="3">
+            <a:schemeClr val="accent1"/>
+          </a:fillRef>
+          <a:effectRef idx="2">
+            <a:schemeClr val="accent1"/>
+          </a:effectRef>
+          <a:fontRef idx="minor">
+            <a:schemeClr val="lt1"/>
+          </a:fontRef>
+        </p:style>
+        <p:txBody>
+          <a:bodyPr rtlCol="0" anchor="ctr"/>
+          <a:lstStyle/>
+          <a:p>
+            <a:pPr algn="ctr"/>
+          </a:p>
+        </p:txBody>
+      </p:sp>
+      <p:sp>
+        <p:nvSpPr>
+          <p:cNvPr id="39" name="TextBox 38"/>
+          <p:cNvSpPr txBox="1"/>
+          <p:nvPr/>
+        </p:nvSpPr>
+        <p:spPr>
+          <a:xfrm>
+            <a:off x="6995160" y="3758183"/>
+            <a:ext cx="2011680" cy="365760"/>
+          </a:xfrm>
+          <a:prstGeom prst="rect">
+            <a:avLst/>
+          </a:prstGeom>
+          <a:noFill/>
+        </p:spPr>
+        <p:txBody>
+          <a:bodyPr wrap="square" lIns="0" rIns="0" tIns="0" bIns="0" anchor="ctr">
+            <a:spAutoFit/>
+          </a:bodyPr>
+          <a:lstStyle/>
+          <a:p>
+            <a:pPr>
+              <a:spcAft>
+                <a:spcPts val="300"/>
+              </a:spcAft>
+            </a:pPr>
+            <a:r>
+              <a:rPr sz="1200" b="1">
+                <a:solidFill>
+                  <a:srgbClr val="14232B"/>
+                </a:solidFill>
+                <a:latin typeface="Calibri"/>
+              </a:rPr>
+              <a:t>Iran</a:t>
+            </a:r>
+          </a:p>
+        </p:txBody>
+      </p:sp>
+      <p:sp>
+        <p:nvSpPr>
+          <p:cNvPr id="40" name="TextBox 39"/>
+          <p:cNvSpPr txBox="1"/>
+          <p:nvPr/>
+        </p:nvSpPr>
+        <p:spPr>
+          <a:xfrm>
+            <a:off x="6995160" y="3758183"/>
+            <a:ext cx="2011680" cy="365760"/>
+          </a:xfrm>
+          <a:prstGeom prst="rect">
+            <a:avLst/>
+          </a:prstGeom>
+          <a:noFill/>
+        </p:spPr>
+        <p:txBody>
+          <a:bodyPr wrap="square" lIns="0" rIns="0" tIns="0" bIns="0" anchor="ctr">
+            <a:spAutoFit/>
+          </a:bodyPr>
+          <a:lstStyle/>
+          <a:p>
+            <a:pPr algn="r">
+              <a:spcAft>
+                <a:spcPts val="300"/>
+              </a:spcAft>
+            </a:pPr>
+            <a:r>
+              <a:rPr sz="1100" b="0">
+                <a:solidFill>
+                  <a:srgbClr val="5B6B72"/>
+                </a:solidFill>
+                <a:latin typeface="Calibri"/>
+              </a:rPr>
+              <a:t>Persian</a:t>
+            </a:r>
+          </a:p>
+        </p:txBody>
+      </p:sp>
+      <p:sp>
+        <p:nvSpPr>
+          <p:cNvPr id="41" name="Rounded Rectangle 40"/>
+          <p:cNvSpPr/>
+          <p:nvPr/>
+        </p:nvSpPr>
+        <p:spPr>
+          <a:xfrm>
+            <a:off x="9354312" y="3758183"/>
+            <a:ext cx="2286000" cy="365760"/>
+          </a:xfrm>
+          <a:prstGeom prst="roundRect">
+            <a:avLst>
+              <a:gd name="adj" fmla="val 25000"/>
+            </a:avLst>
+          </a:prstGeom>
+          <a:solidFill>
+            <a:srgbClr val="EAF2F3"/>
+          </a:solidFill>
+          <a:ln>
+            <a:noFill/>
+          </a:ln>
+          <a:effectLst/>
+        </p:spPr>
+        <p:style>
+          <a:lnRef idx="1">
+            <a:schemeClr val="accent1"/>
+          </a:lnRef>
+          <a:fillRef idx="3">
+            <a:schemeClr val="accent1"/>
+          </a:fillRef>
+          <a:effectRef idx="2">
+            <a:schemeClr val="accent1"/>
+          </a:effectRef>
+          <a:fontRef idx="minor">
+            <a:schemeClr val="lt1"/>
+          </a:fontRef>
+        </p:style>
+        <p:txBody>
+          <a:bodyPr rtlCol="0" anchor="ctr"/>
+          <a:lstStyle/>
+          <a:p>
+            <a:pPr algn="ctr"/>
+          </a:p>
+        </p:txBody>
+      </p:sp>
+      <p:sp>
+        <p:nvSpPr>
+          <p:cNvPr id="42" name="TextBox 41"/>
+          <p:cNvSpPr txBox="1"/>
+          <p:nvPr/>
+        </p:nvSpPr>
+        <p:spPr>
+          <a:xfrm>
+            <a:off x="9491472" y="3758183"/>
+            <a:ext cx="2011680" cy="365760"/>
+          </a:xfrm>
+          <a:prstGeom prst="rect">
+            <a:avLst/>
+          </a:prstGeom>
+          <a:noFill/>
+        </p:spPr>
+        <p:txBody>
+          <a:bodyPr wrap="square" lIns="0" rIns="0" tIns="0" bIns="0" anchor="ctr">
+            <a:spAutoFit/>
+          </a:bodyPr>
+          <a:lstStyle/>
+          <a:p>
+            <a:pPr>
+              <a:spcAft>
+                <a:spcPts val="300"/>
+              </a:spcAft>
+            </a:pPr>
+            <a:r>
+              <a:rPr sz="1200" b="1">
+                <a:solidFill>
+                  <a:srgbClr val="14232B"/>
+                </a:solidFill>
+                <a:latin typeface="Calibri"/>
+              </a:rPr>
+              <a:t>UAE</a:t>
+            </a:r>
+          </a:p>
+        </p:txBody>
+      </p:sp>
+      <p:sp>
+        <p:nvSpPr>
+          <p:cNvPr id="43" name="TextBox 42"/>
+          <p:cNvSpPr txBox="1"/>
+          <p:nvPr/>
+        </p:nvSpPr>
+        <p:spPr>
+          <a:xfrm>
+            <a:off x="9491472" y="3758183"/>
+            <a:ext cx="2011680" cy="365760"/>
+          </a:xfrm>
+          <a:prstGeom prst="rect">
+            <a:avLst/>
+          </a:prstGeom>
+          <a:noFill/>
+        </p:spPr>
+        <p:txBody>
+          <a:bodyPr wrap="square" lIns="0" rIns="0" tIns="0" bIns="0" anchor="ctr">
+            <a:spAutoFit/>
+          </a:bodyPr>
+          <a:lstStyle/>
+          <a:p>
+            <a:pPr algn="r">
+              <a:spcAft>
+                <a:spcPts val="300"/>
+              </a:spcAft>
+            </a:pPr>
+            <a:r>
+              <a:rPr sz="1100" b="0">
+                <a:solidFill>
+                  <a:srgbClr val="5B6B72"/>
+                </a:solidFill>
+                <a:latin typeface="Calibri"/>
+              </a:rPr>
+              <a:t>Arabic</a:t>
+            </a:r>
+          </a:p>
+        </p:txBody>
+      </p:sp>
+      <p:sp>
+        <p:nvSpPr>
+          <p:cNvPr id="44" name="Rounded Rectangle 43"/>
+          <p:cNvSpPr/>
+          <p:nvPr/>
+        </p:nvSpPr>
+        <p:spPr>
+          <a:xfrm>
+            <a:off x="548640" y="4343400"/>
+            <a:ext cx="3566160" cy="1463040"/>
+          </a:xfrm>
+          <a:prstGeom prst="roundRect">
+            <a:avLst>
+              <a:gd name="adj" fmla="val 6250"/>
+            </a:avLst>
+          </a:prstGeom>
+          <a:solidFill>
+            <a:srgbClr val="EAF2F3"/>
+          </a:solidFill>
+          <a:ln>
+            <a:noFill/>
+          </a:ln>
+          <a:effectLst/>
+        </p:spPr>
+        <p:style>
+          <a:lnRef idx="1">
+            <a:schemeClr val="accent1"/>
+          </a:lnRef>
+          <a:fillRef idx="3">
+            <a:schemeClr val="accent1"/>
+          </a:fillRef>
+          <a:effectRef idx="2">
+            <a:schemeClr val="accent1"/>
+          </a:effectRef>
+          <a:fontRef idx="minor">
+            <a:schemeClr val="lt1"/>
+          </a:fontRef>
+        </p:style>
+        <p:txBody>
+          <a:bodyPr rtlCol="0" anchor="ctr"/>
+          <a:lstStyle/>
+          <a:p>
+            <a:pPr algn="ctr"/>
+          </a:p>
+        </p:txBody>
+      </p:sp>
+      <p:sp>
+        <p:nvSpPr>
+          <p:cNvPr id="45" name="Oval 44"/>
+          <p:cNvSpPr/>
+          <p:nvPr/>
+        </p:nvSpPr>
+        <p:spPr>
+          <a:xfrm>
+            <a:off x="731520" y="4526280"/>
+            <a:ext cx="128016" cy="128016"/>
+          </a:xfrm>
+          <a:prstGeom prst="ellipse">
+            <a:avLst/>
+          </a:prstGeom>
+          <a:solidFill>
+            <a:srgbClr val="0B4F5C"/>
+          </a:solidFill>
+          <a:ln>
+            <a:noFill/>
+          </a:ln>
+          <a:effectLst/>
+        </p:spPr>
+        <p:style>
+          <a:lnRef idx="1">
+            <a:schemeClr val="accent1"/>
+          </a:lnRef>
+          <a:fillRef idx="3">
+            <a:schemeClr val="accent1"/>
+          </a:fillRef>
+          <a:effectRef idx="2">
+            <a:schemeClr val="accent1"/>
+          </a:effectRef>
+          <a:fontRef idx="minor">
+            <a:schemeClr val="lt1"/>
+          </a:fontRef>
+        </p:style>
+        <p:txBody>
+          <a:bodyPr rtlCol="0" anchor="ctr"/>
+          <a:lstStyle/>
+          <a:p>
+            <a:pPr algn="ctr"/>
+          </a:p>
+        </p:txBody>
+      </p:sp>
+      <p:sp>
+        <p:nvSpPr>
+          <p:cNvPr id="46" name="TextBox 45"/>
+          <p:cNvSpPr txBox="1"/>
+          <p:nvPr/>
+        </p:nvSpPr>
+        <p:spPr>
+          <a:xfrm>
+            <a:off x="960120" y="4434840"/>
+            <a:ext cx="3017520" cy="310896"/>
+          </a:xfrm>
+          <a:prstGeom prst="rect">
+            <a:avLst/>
+          </a:prstGeom>
+          <a:noFill/>
+        </p:spPr>
+        <p:txBody>
+          <a:bodyPr wrap="square" lIns="0" rIns="0" tIns="0" bIns="0" anchor="ctr">
+            <a:spAutoFit/>
+          </a:bodyPr>
+          <a:lstStyle/>
+          <a:p>
+            <a:pPr>
+              <a:spcAft>
+                <a:spcPts val="300"/>
+              </a:spcAft>
+            </a:pPr>
+            <a:r>
+              <a:rPr sz="1500" b="1">
+                <a:solidFill>
+                  <a:srgbClr val="14232B"/>
+                </a:solidFill>
+                <a:latin typeface="Cambria"/>
+              </a:rPr>
+              <a:t>Why it can travel</a:t>
+            </a:r>
+          </a:p>
+        </p:txBody>
+      </p:sp>
+      <p:sp>
+        <p:nvSpPr>
+          <p:cNvPr id="47" name="TextBox 46"/>
+          <p:cNvSpPr txBox="1"/>
+          <p:nvPr/>
+        </p:nvSpPr>
+        <p:spPr>
+          <a:xfrm>
+            <a:off x="749808" y="4846320"/>
+            <a:ext cx="3163824" cy="914400"/>
           </a:xfrm>
           <a:prstGeom prst="rect">
             <a:avLst/>
@@ -9685,33 +10604,197 @@
           </a:bodyPr>
           <a:lstStyle/>
           <a:p>
+            <a:pPr marL="171450" indent="-171450">
+              <a:spcAft>
+                <a:spcPts val="300"/>
+              </a:spcAft>
+              <a:buChar char="•"/>
+            </a:pPr>
+            <a:r>
+              <a:rPr sz="1200" b="0">
+                <a:solidFill>
+                  <a:srgbClr val="14232B"/>
+                </a:solidFill>
+                <a:latin typeface="Calibri"/>
+              </a:rPr>
+              <a:t>A new place is one config file</a:t>
+            </a:r>
+          </a:p>
+          <a:p>
+            <a:pPr marL="171450" indent="-171450">
+              <a:spcAft>
+                <a:spcPts val="300"/>
+              </a:spcAft>
+              <a:buChar char="•"/>
+            </a:pPr>
+            <a:r>
+              <a:rPr sz="1200" b="0">
+                <a:solidFill>
+                  <a:srgbClr val="14232B"/>
+                </a:solidFill>
+                <a:latin typeface="Calibri"/>
+              </a:rPr>
+              <a:t>Global open data: OSM, WorldPop, GHSL</a:t>
+            </a:r>
+          </a:p>
+          <a:p>
+            <a:pPr marL="171450" indent="-171450">
+              <a:spcAft>
+                <a:spcPts val="300"/>
+              </a:spcAft>
+              <a:buChar char="•"/>
+            </a:pPr>
+            <a:r>
+              <a:rPr sz="1200" b="0">
+                <a:solidFill>
+                  <a:srgbClr val="14232B"/>
+                </a:solidFill>
+                <a:latin typeface="Calibri"/>
+              </a:rPr>
+              <a:t>Open-source DPG; UI already has pt, ru, zh</a:t>
+            </a:r>
+          </a:p>
+        </p:txBody>
+      </p:sp>
+      <p:sp>
+        <p:nvSpPr>
+          <p:cNvPr id="48" name="Rounded Rectangle 47"/>
+          <p:cNvSpPr/>
+          <p:nvPr/>
+        </p:nvSpPr>
+        <p:spPr>
+          <a:xfrm>
+            <a:off x="4311396" y="4343400"/>
+            <a:ext cx="3566160" cy="1463040"/>
+          </a:xfrm>
+          <a:prstGeom prst="roundRect">
+            <a:avLst>
+              <a:gd name="adj" fmla="val 6250"/>
+            </a:avLst>
+          </a:prstGeom>
+          <a:solidFill>
+            <a:srgbClr val="EAF2F3"/>
+          </a:solidFill>
+          <a:ln>
+            <a:noFill/>
+          </a:ln>
+          <a:effectLst/>
+        </p:spPr>
+        <p:style>
+          <a:lnRef idx="1">
+            <a:schemeClr val="accent1"/>
+          </a:lnRef>
+          <a:fillRef idx="3">
+            <a:schemeClr val="accent1"/>
+          </a:fillRef>
+          <a:effectRef idx="2">
+            <a:schemeClr val="accent1"/>
+          </a:effectRef>
+          <a:fontRef idx="minor">
+            <a:schemeClr val="lt1"/>
+          </a:fontRef>
+        </p:style>
+        <p:txBody>
+          <a:bodyPr rtlCol="0" anchor="ctr"/>
+          <a:lstStyle/>
+          <a:p>
+            <a:pPr algn="ctr"/>
+          </a:p>
+        </p:txBody>
+      </p:sp>
+      <p:sp>
+        <p:nvSpPr>
+          <p:cNvPr id="49" name="Oval 48"/>
+          <p:cNvSpPr/>
+          <p:nvPr/>
+        </p:nvSpPr>
+        <p:spPr>
+          <a:xfrm>
+            <a:off x="4494276" y="4526280"/>
+            <a:ext cx="128016" cy="128016"/>
+          </a:xfrm>
+          <a:prstGeom prst="ellipse">
+            <a:avLst/>
+          </a:prstGeom>
+          <a:solidFill>
+            <a:srgbClr val="0B4F5C"/>
+          </a:solidFill>
+          <a:ln>
+            <a:noFill/>
+          </a:ln>
+          <a:effectLst/>
+        </p:spPr>
+        <p:style>
+          <a:lnRef idx="1">
+            <a:schemeClr val="accent1"/>
+          </a:lnRef>
+          <a:fillRef idx="3">
+            <a:schemeClr val="accent1"/>
+          </a:fillRef>
+          <a:effectRef idx="2">
+            <a:schemeClr val="accent1"/>
+          </a:effectRef>
+          <a:fontRef idx="minor">
+            <a:schemeClr val="lt1"/>
+          </a:fontRef>
+        </p:style>
+        <p:txBody>
+          <a:bodyPr rtlCol="0" anchor="ctr"/>
+          <a:lstStyle/>
+          <a:p>
+            <a:pPr algn="ctr"/>
+          </a:p>
+        </p:txBody>
+      </p:sp>
+      <p:sp>
+        <p:nvSpPr>
+          <p:cNvPr id="50" name="TextBox 49"/>
+          <p:cNvSpPr txBox="1"/>
+          <p:nvPr/>
+        </p:nvSpPr>
+        <p:spPr>
+          <a:xfrm>
+            <a:off x="4722876" y="4434840"/>
+            <a:ext cx="3017520" cy="310896"/>
+          </a:xfrm>
+          <a:prstGeom prst="rect">
+            <a:avLst/>
+          </a:prstGeom>
+          <a:noFill/>
+        </p:spPr>
+        <p:txBody>
+          <a:bodyPr wrap="square" lIns="0" rIns="0" tIns="0" bIns="0" anchor="ctr">
+            <a:spAutoFit/>
+          </a:bodyPr>
+          <a:lstStyle/>
+          <a:p>
             <a:pPr>
               <a:spcAft>
-                <a:spcPts val="400"/>
+                <a:spcPts val="300"/>
               </a:spcAft>
             </a:pPr>
             <a:r>
-              <a:rPr sz="1000" b="0">
-                <a:solidFill>
-                  <a:srgbClr val="5B6B72"/>
-                </a:solidFill>
-                <a:latin typeface="Calibri"/>
-              </a:rPr>
-              <a:t>INFRA-AI  ·  Digital Public Good</a:t>
-            </a:r>
-          </a:p>
-        </p:txBody>
-      </p:sp>
-      <p:sp>
-        <p:nvSpPr>
-          <p:cNvPr id="21" name="TextBox 20"/>
-          <p:cNvSpPr txBox="1"/>
-          <p:nvPr/>
-        </p:nvSpPr>
-        <p:spPr>
-          <a:xfrm>
-            <a:off x="11091672" y="6446520"/>
-            <a:ext cx="548640" cy="274320"/>
+              <a:rPr sz="1500" b="1">
+                <a:solidFill>
+                  <a:srgbClr val="14232B"/>
+                </a:solidFill>
+                <a:latin typeface="Cambria"/>
+              </a:rPr>
+              <a:t>What we can do</a:t>
+            </a:r>
+          </a:p>
+        </p:txBody>
+      </p:sp>
+      <p:sp>
+        <p:nvSpPr>
+          <p:cNvPr id="51" name="TextBox 50"/>
+          <p:cNvSpPr txBox="1"/>
+          <p:nvPr/>
+        </p:nvSpPr>
+        <p:spPr>
+          <a:xfrm>
+            <a:off x="4512564" y="4846320"/>
+            <a:ext cx="3163824" cy="914400"/>
           </a:xfrm>
           <a:prstGeom prst="rect">
             <a:avLst/>
@@ -9724,9 +10807,364 @@
           </a:bodyPr>
           <a:lstStyle/>
           <a:p>
+            <a:pPr marL="171450" indent="-171450">
+              <a:spcAft>
+                <a:spcPts val="300"/>
+              </a:spcAft>
+              <a:buChar char="•"/>
+            </a:pPr>
+            <a:r>
+              <a:rPr sz="1200" b="0">
+                <a:solidFill>
+                  <a:srgbClr val="14232B"/>
+                </a:solidFill>
+                <a:latin typeface="Calibri"/>
+              </a:rPr>
+              <a:t>Pilot one city per member</a:t>
+            </a:r>
+          </a:p>
+          <a:p>
+            <a:pPr marL="171450" indent="-171450">
+              <a:spcAft>
+                <a:spcPts val="300"/>
+              </a:spcAft>
+              <a:buChar char="•"/>
+            </a:pPr>
+            <a:r>
+              <a:rPr sz="1200" b="0">
+                <a:solidFill>
+                  <a:srgbClr val="14232B"/>
+                </a:solidFill>
+                <a:latin typeface="Calibri"/>
+              </a:rPr>
+              <a:t>Comparable access scores across countries</a:t>
+            </a:r>
+          </a:p>
+          <a:p>
+            <a:pPr marL="171450" indent="-171450">
+              <a:spcAft>
+                <a:spcPts val="300"/>
+              </a:spcAft>
+              <a:buChar char="•"/>
+            </a:pPr>
+            <a:r>
+              <a:rPr sz="1200" b="0">
+                <a:solidFill>
+                  <a:srgbClr val="14232B"/>
+                </a:solidFill>
+                <a:latin typeface="Calibri"/>
+              </a:rPr>
+              <a:t>Voice and text intake in national languages</a:t>
+            </a:r>
+          </a:p>
+        </p:txBody>
+      </p:sp>
+      <p:sp>
+        <p:nvSpPr>
+          <p:cNvPr id="52" name="Rounded Rectangle 51"/>
+          <p:cNvSpPr/>
+          <p:nvPr/>
+        </p:nvSpPr>
+        <p:spPr>
+          <a:xfrm>
+            <a:off x="8074152" y="4343400"/>
+            <a:ext cx="3566160" cy="1463040"/>
+          </a:xfrm>
+          <a:prstGeom prst="roundRect">
+            <a:avLst>
+              <a:gd name="adj" fmla="val 6250"/>
+            </a:avLst>
+          </a:prstGeom>
+          <a:solidFill>
+            <a:srgbClr val="EAF2F3"/>
+          </a:solidFill>
+          <a:ln>
+            <a:noFill/>
+          </a:ln>
+          <a:effectLst/>
+        </p:spPr>
+        <p:style>
+          <a:lnRef idx="1">
+            <a:schemeClr val="accent1"/>
+          </a:lnRef>
+          <a:fillRef idx="3">
+            <a:schemeClr val="accent1"/>
+          </a:fillRef>
+          <a:effectRef idx="2">
+            <a:schemeClr val="accent1"/>
+          </a:effectRef>
+          <a:fontRef idx="minor">
+            <a:schemeClr val="lt1"/>
+          </a:fontRef>
+        </p:style>
+        <p:txBody>
+          <a:bodyPr rtlCol="0" anchor="ctr"/>
+          <a:lstStyle/>
+          <a:p>
+            <a:pPr algn="ctr"/>
+          </a:p>
+        </p:txBody>
+      </p:sp>
+      <p:sp>
+        <p:nvSpPr>
+          <p:cNvPr id="53" name="Oval 52"/>
+          <p:cNvSpPr/>
+          <p:nvPr/>
+        </p:nvSpPr>
+        <p:spPr>
+          <a:xfrm>
+            <a:off x="8257031" y="4526280"/>
+            <a:ext cx="128016" cy="128016"/>
+          </a:xfrm>
+          <a:prstGeom prst="ellipse">
+            <a:avLst/>
+          </a:prstGeom>
+          <a:solidFill>
+            <a:srgbClr val="E08A1E"/>
+          </a:solidFill>
+          <a:ln>
+            <a:noFill/>
+          </a:ln>
+          <a:effectLst/>
+        </p:spPr>
+        <p:style>
+          <a:lnRef idx="1">
+            <a:schemeClr val="accent1"/>
+          </a:lnRef>
+          <a:fillRef idx="3">
+            <a:schemeClr val="accent1"/>
+          </a:fillRef>
+          <a:effectRef idx="2">
+            <a:schemeClr val="accent1"/>
+          </a:effectRef>
+          <a:fontRef idx="minor">
+            <a:schemeClr val="lt1"/>
+          </a:fontRef>
+        </p:style>
+        <p:txBody>
+          <a:bodyPr rtlCol="0" anchor="ctr"/>
+          <a:lstStyle/>
+          <a:p>
+            <a:pPr algn="ctr"/>
+          </a:p>
+        </p:txBody>
+      </p:sp>
+      <p:sp>
+        <p:nvSpPr>
+          <p:cNvPr id="54" name="TextBox 53"/>
+          <p:cNvSpPr txBox="1"/>
+          <p:nvPr/>
+        </p:nvSpPr>
+        <p:spPr>
+          <a:xfrm>
+            <a:off x="8485632" y="4434840"/>
+            <a:ext cx="3017520" cy="310896"/>
+          </a:xfrm>
+          <a:prstGeom prst="rect">
+            <a:avLst/>
+          </a:prstGeom>
+          <a:noFill/>
+        </p:spPr>
+        <p:txBody>
+          <a:bodyPr wrap="square" lIns="0" rIns="0" tIns="0" bIns="0" anchor="ctr">
+            <a:spAutoFit/>
+          </a:bodyPr>
+          <a:lstStyle/>
+          <a:p>
+            <a:pPr>
+              <a:spcAft>
+                <a:spcPts val="300"/>
+              </a:spcAft>
+            </a:pPr>
+            <a:r>
+              <a:rPr sz="1500" b="1">
+                <a:solidFill>
+                  <a:srgbClr val="14232B"/>
+                </a:solidFill>
+                <a:latin typeface="Cambria"/>
+              </a:rPr>
+              <a:t>What we should do first</a:t>
+            </a:r>
+          </a:p>
+        </p:txBody>
+      </p:sp>
+      <p:sp>
+        <p:nvSpPr>
+          <p:cNvPr id="55" name="TextBox 54"/>
+          <p:cNvSpPr txBox="1"/>
+          <p:nvPr/>
+        </p:nvSpPr>
+        <p:spPr>
+          <a:xfrm>
+            <a:off x="8275320" y="4846320"/>
+            <a:ext cx="3163824" cy="914400"/>
+          </a:xfrm>
+          <a:prstGeom prst="rect">
+            <a:avLst/>
+          </a:prstGeom>
+          <a:noFill/>
+        </p:spPr>
+        <p:txBody>
+          <a:bodyPr wrap="square" lIns="0" rIns="0" tIns="0" bIns="0" anchor="t">
+            <a:spAutoFit/>
+          </a:bodyPr>
+          <a:lstStyle/>
+          <a:p>
+            <a:pPr marL="171450" indent="-171450">
+              <a:spcAft>
+                <a:spcPts val="300"/>
+              </a:spcAft>
+              <a:buChar char="•"/>
+            </a:pPr>
+            <a:r>
+              <a:rPr sz="1200" b="0">
+                <a:solidFill>
+                  <a:srgbClr val="14232B"/>
+                </a:solidFill>
+                <a:latin typeface="Calibri"/>
+              </a:rPr>
+              <a:t>Write an ADR: scope is India only today</a:t>
+            </a:r>
+          </a:p>
+          <a:p>
+            <a:pPr marL="171450" indent="-171450">
+              <a:spcAft>
+                <a:spcPts val="300"/>
+              </a:spcAft>
+              <a:buChar char="•"/>
+            </a:pPr>
+            <a:r>
+              <a:rPr sz="1200" b="0">
+                <a:solidFill>
+                  <a:srgbClr val="14232B"/>
+                </a:solidFill>
+                <a:latin typeface="Calibri"/>
+              </a:rPr>
+              <a:t>Licences, boundaries, privacy law per country</a:t>
+            </a:r>
+          </a:p>
+          <a:p>
+            <a:pPr marL="171450" indent="-171450">
+              <a:spcAft>
+                <a:spcPts val="300"/>
+              </a:spcAft>
+              <a:buChar char="•"/>
+            </a:pPr>
+            <a:r>
+              <a:rPr sz="1200" b="0">
+                <a:solidFill>
+                  <a:srgbClr val="14232B"/>
+                </a:solidFill>
+                <a:latin typeface="Calibri"/>
+              </a:rPr>
+              <a:t>Gold-set quality check per language</a:t>
+            </a:r>
+          </a:p>
+        </p:txBody>
+      </p:sp>
+      <p:sp>
+        <p:nvSpPr>
+          <p:cNvPr id="56" name="TextBox 55"/>
+          <p:cNvSpPr txBox="1"/>
+          <p:nvPr/>
+        </p:nvSpPr>
+        <p:spPr>
+          <a:xfrm>
+            <a:off x="548640" y="5943600"/>
+            <a:ext cx="11064240" cy="411480"/>
+          </a:xfrm>
+          <a:prstGeom prst="rect">
+            <a:avLst/>
+          </a:prstGeom>
+          <a:noFill/>
+        </p:spPr>
+        <p:txBody>
+          <a:bodyPr wrap="square" lIns="0" rIns="0" tIns="0" bIns="0" anchor="t">
+            <a:spAutoFit/>
+          </a:bodyPr>
+          <a:lstStyle/>
+          <a:p>
+            <a:pPr>
+              <a:spcAft>
+                <a:spcPts val="300"/>
+              </a:spcAft>
+            </a:pPr>
+            <a:r>
+              <a:rPr sz="1000" b="0">
+                <a:solidFill>
+                  <a:srgbClr val="5B6B72"/>
+                </a:solidFill>
+                <a:latin typeface="Calibri"/>
+              </a:rPr>
+              <a:t>Borders: Natural Earth, India view; not the official Survey of India layer. Members as of 2025. Scores describe infrastructure, never rank countries. Nothing here is built yet.</a:t>
+            </a:r>
+          </a:p>
+        </p:txBody>
+      </p:sp>
+      <p:sp>
+        <p:nvSpPr>
+          <p:cNvPr id="57" name="TextBox 56"/>
+          <p:cNvSpPr txBox="1"/>
+          <p:nvPr/>
+        </p:nvSpPr>
+        <p:spPr>
+          <a:xfrm>
+            <a:off x="548640" y="6446520"/>
+            <a:ext cx="5486400" cy="274320"/>
+          </a:xfrm>
+          <a:prstGeom prst="rect">
+            <a:avLst/>
+          </a:prstGeom>
+          <a:noFill/>
+        </p:spPr>
+        <p:txBody>
+          <a:bodyPr wrap="square" lIns="0" rIns="0" tIns="0" bIns="0" anchor="t">
+            <a:spAutoFit/>
+          </a:bodyPr>
+          <a:lstStyle/>
+          <a:p>
+            <a:pPr>
+              <a:spcAft>
+                <a:spcPts val="300"/>
+              </a:spcAft>
+            </a:pPr>
+            <a:r>
+              <a:rPr sz="1000" b="0">
+                <a:solidFill>
+                  <a:srgbClr val="5B6B72"/>
+                </a:solidFill>
+                <a:latin typeface="Calibri"/>
+              </a:rPr>
+              <a:t>INFRA-AI  ·  Digital Public Good</a:t>
+            </a:r>
+          </a:p>
+        </p:txBody>
+      </p:sp>
+      <p:sp>
+        <p:nvSpPr>
+          <p:cNvPr id="58" name="TextBox 57"/>
+          <p:cNvSpPr txBox="1"/>
+          <p:nvPr/>
+        </p:nvSpPr>
+        <p:spPr>
+          <a:xfrm>
+            <a:off x="11091672" y="6446520"/>
+            <a:ext cx="548640" cy="274320"/>
+          </a:xfrm>
+          <a:prstGeom prst="rect">
+            <a:avLst/>
+          </a:prstGeom>
+          <a:noFill/>
+        </p:spPr>
+        <p:txBody>
+          <a:bodyPr wrap="square" lIns="0" rIns="0" tIns="0" bIns="0" anchor="t">
+            <a:spAutoFit/>
+          </a:bodyPr>
+          <a:lstStyle/>
+          <a:p>
             <a:pPr algn="r">
               <a:spcAft>
-                <a:spcPts val="400"/>
+                <a:spcPts val="300"/>
               </a:spcAft>
             </a:pPr>
             <a:r>

</xml_diff>

<commit_message>
docs(pitch): drop the closing roadmap slide
Requested: deck ends on the BRICS slide.

Co-Authored-By: Claude Sonnet 5.5 <noreply@anthropic.com>
</commit_message>
<xml_diff>
--- a/docs/INFRA-AI-pitch.pptx
+++ b/docs/INFRA-AI-pitch.pptx
@@ -13,7 +13,6 @@
     <p:sldId id="259" r:id="rId5"/>
     <p:sldId id="260" r:id="rId6"/>
     <p:sldId id="264" r:id="rId15"/>
-    <p:sldId id="261" r:id="rId7"/>
   </p:sldIdLst>
   <p:notesMasterIdLst>
     <p:notesMasterId r:id="rId8"/>
@@ -886,94 +885,6 @@
             <a:fld id="{F7021451-1387-4CA6-816F-3879F97B5CBC}" type="slidenum">
               <a:rPr lang="en-US"/>
               <a:t>5</a:t>
-            </a:fld>
-            <a:endParaRPr lang="en-US"/>
-          </a:p>
-        </p:txBody>
-      </p:sp>
-    </p:spTree>
-    <p:extLst>
-      <p:ext uri="{BB962C8B-B14F-4D97-AF65-F5344CB8AC3E}">
-        <p14:creationId xmlns:p14="http://schemas.microsoft.com/office/powerpoint/2010/main" val="1024086991"/>
-      </p:ext>
-    </p:extLst>
-  </p:cSld>
-  <p:clrMapOvr>
-    <a:masterClrMapping/>
-  </p:clrMapOvr>
-</p:notes>
-</file>
-
-<file path=ppt/notesSlides/notesSlide6.xml><?xml version="1.0" encoding="utf-8"?>
-<p:notes xmlns:a="http://schemas.openxmlformats.org/drawingml/2006/main" xmlns:r="http://schemas.openxmlformats.org/officeDocument/2006/relationships" xmlns:p="http://schemas.openxmlformats.org/presentationml/2006/main">
-  <p:cSld>
-    <p:spTree>
-      <p:nvGrpSpPr>
-        <p:cNvPr id="1" name=""/>
-        <p:cNvGrpSpPr/>
-        <p:nvPr/>
-      </p:nvGrpSpPr>
-      <p:grpSpPr>
-        <a:xfrm>
-          <a:off x="0" y="0"/>
-          <a:ext cx="0" cy="0"/>
-          <a:chOff x="0" y="0"/>
-          <a:chExt cx="0" cy="0"/>
-        </a:xfrm>
-      </p:grpSpPr>
-      <p:sp>
-        <p:nvSpPr>
-          <p:cNvPr id="2" name="Slide Image Placeholder 1"/>
-          <p:cNvSpPr>
-            <a:spLocks noGrp="1" noRot="1" noChangeAspect="1"/>
-          </p:cNvSpPr>
-          <p:nvPr>
-            <p:ph type="sldImg"/>
-          </p:nvPr>
-        </p:nvSpPr>
-        <p:spPr/>
-      </p:sp>
-      <p:sp>
-        <p:nvSpPr>
-          <p:cNvPr id="3" name="Notes Placeholder 2"/>
-          <p:cNvSpPr>
-            <a:spLocks noGrp="1"/>
-          </p:cNvSpPr>
-          <p:nvPr>
-            <p:ph type="body" idx="1"/>
-          </p:nvPr>
-        </p:nvSpPr>
-        <p:spPr/>
-        <p:txBody>
-          <a:bodyPr/>
-          <a:lstStyle/>
-          <a:p>
-            <a:r>
-              <a:rPr lang="en-US" dirty="0"/>
-              <a:t>Milestones follow README section 13 and AGENTS.md status: NH M1/M2 done, M3 half done; investor flow landed ahead of M0; M0 is next. Asks are taken from the plan: GatiShakti access is listed as restricted and needs organizer help; Bhashini for the language stack; a pilot partner for real citizen intake.</a:t>
-            </a:r>
-            <a:endParaRPr lang="en-US" dirty="0"/>
-          </a:p>
-        </p:txBody>
-      </p:sp>
-      <p:sp>
-        <p:nvSpPr>
-          <p:cNvPr id="4" name="Slide Number Placeholder 3"/>
-          <p:cNvSpPr>
-            <a:spLocks noGrp="1"/>
-          </p:cNvSpPr>
-          <p:nvPr>
-            <p:ph type="sldNum" sz="quarter" idx="10"/>
-          </p:nvPr>
-        </p:nvSpPr>
-        <p:spPr/>
-        <p:txBody>
-          <a:bodyPr/>
-          <a:lstStyle/>
-          <a:p>
-            <a:fld id="{F7021451-1387-4CA6-816F-3879F97B5CBC}" type="slidenum">
-              <a:rPr lang="en-US"/>
-              <a:t>6</a:t>
             </a:fld>
             <a:endParaRPr lang="en-US"/>
           </a:p>
@@ -11187,1231 +11098,6 @@
 </p:sld>
 </file>
 
-<file path=ppt/slides/slide9.xml><?xml version="1.0" encoding="utf-8"?>
-<p:sld xmlns:a="http://schemas.openxmlformats.org/drawingml/2006/main" xmlns:r="http://schemas.openxmlformats.org/officeDocument/2006/relationships" xmlns:p="http://schemas.openxmlformats.org/presentationml/2006/main">
-  <p:cSld name="Slide 6">
-    <p:bg>
-      <p:bgPr>
-        <a:solidFill>
-          <a:srgbClr val="072C34"/>
-        </a:solidFill>
-      </p:bgPr>
-    </p:bg>
-    <p:spTree>
-      <p:nvGrpSpPr>
-        <p:cNvPr id="1" name=""/>
-        <p:cNvGrpSpPr/>
-        <p:nvPr/>
-      </p:nvGrpSpPr>
-      <p:grpSpPr>
-        <a:xfrm>
-          <a:off x="0" y="0"/>
-          <a:ext cx="0" cy="0"/>
-          <a:chOff x="0" y="0"/>
-          <a:chExt cx="0" cy="0"/>
-        </a:xfrm>
-      </p:grpSpPr>
-      <p:sp>
-        <p:nvSpPr>
-          <p:cNvPr id="2" name="Text 0"/>
-          <p:cNvSpPr txBox="1"/>
-          <p:nvPr/>
-        </p:nvSpPr>
-        <p:spPr>
-          <a:xfrm>
-            <a:off x="548640" y="365760"/>
-            <a:ext cx="11064240" cy="777240"/>
-          </a:xfrm>
-          <a:prstGeom prst="rect">
-            <a:avLst/>
-          </a:prstGeom>
-          <a:noFill/>
-          <a:ln/>
-        </p:spPr>
-        <p:txBody>
-          <a:bodyPr wrap="square" lIns="0" tIns="0" rIns="0" bIns="0" rtlCol="0" anchor="ctr"/>
-          <a:lstStyle/>
-          <a:p>
-            <a:pPr indent="0" marL="0">
-              <a:buNone/>
-            </a:pPr>
-            <a:r>
-              <a:rPr lang="en-US" sz="3400" b="1" dirty="0">
-                <a:solidFill>
-                  <a:srgbClr val="FFFFFF"/>
-                </a:solidFill>
-                <a:latin typeface="Cambria" pitchFamily="34" charset="0"/>
-                <a:ea typeface="Cambria" pitchFamily="34" charset="-122"/>
-                <a:cs typeface="Cambria" pitchFamily="34" charset="-120"/>
-              </a:rPr>
-              <a:t>From two fields to all of India</a:t>
-            </a:r>
-            <a:endParaRPr lang="en-US" sz="3400" dirty="0"/>
-          </a:p>
-        </p:txBody>
-      </p:sp>
-      <p:sp>
-        <p:nvSpPr>
-          <p:cNvPr id="3" name="Text 1"/>
-          <p:cNvSpPr txBox="1"/>
-          <p:nvPr/>
-        </p:nvSpPr>
-        <p:spPr>
-          <a:xfrm>
-            <a:off x="548640" y="1115568"/>
-            <a:ext cx="11064240" cy="365760"/>
-          </a:xfrm>
-          <a:prstGeom prst="rect">
-            <a:avLst/>
-          </a:prstGeom>
-          <a:noFill/>
-          <a:ln/>
-        </p:spPr>
-        <p:txBody>
-          <a:bodyPr wrap="square" lIns="0" tIns="0" rIns="0" bIns="0" rtlCol="0" anchor="ctr"/>
-          <a:lstStyle/>
-          <a:p>
-            <a:pPr indent="0" marL="0">
-              <a:buNone/>
-            </a:pPr>
-            <a:r>
-              <a:rPr lang="en-US" sz="1500" dirty="0">
-                <a:solidFill>
-                  <a:srgbClr val="9FC3C9"/>
-                </a:solidFill>
-                <a:latin typeface="Calibri" pitchFamily="34" charset="0"/>
-                <a:ea typeface="Calibri" pitchFamily="34" charset="-122"/>
-                <a:cs typeface="Calibri" pitchFamily="34" charset="-120"/>
-              </a:rPr>
-              <a:t>Each field follows one template. Each new city is one config file.</a:t>
-            </a:r>
-            <a:endParaRPr lang="en-US" sz="1500" dirty="0"/>
-          </a:p>
-        </p:txBody>
-      </p:sp>
-      <p:sp>
-        <p:nvSpPr>
-          <p:cNvPr id="4" name="Shape 2"/>
-          <p:cNvSpPr/>
-          <p:nvPr/>
-        </p:nvSpPr>
-        <p:spPr>
-          <a:xfrm>
-            <a:off x="822960" y="2240280"/>
-            <a:ext cx="10543032" cy="0"/>
-          </a:xfrm>
-          <a:prstGeom prst="line">
-            <a:avLst/>
-          </a:prstGeom>
-          <a:noFill/>
-          <a:ln w="25400">
-            <a:solidFill>
-              <a:srgbClr val="3C7A86"/>
-            </a:solidFill>
-            <a:prstDash val="solid"/>
-          </a:ln>
-        </p:spPr>
-        <p:txBody>
-          <a:bodyPr/>
-          <a:p/>
-        </p:txBody>
-      </p:sp>
-      <p:sp>
-        <p:nvSpPr>
-          <p:cNvPr id="5" name="Shape 3"/>
-          <p:cNvSpPr/>
-          <p:nvPr/>
-        </p:nvSpPr>
-        <p:spPr>
-          <a:xfrm>
-            <a:off x="548640" y="1965960"/>
-            <a:ext cx="548640" cy="548640"/>
-          </a:xfrm>
-          <a:prstGeom prst="ellipse">
-            <a:avLst/>
-          </a:prstGeom>
-          <a:solidFill>
-            <a:srgbClr val="E08A1E"/>
-          </a:solidFill>
-          <a:ln w="25400">
-            <a:solidFill>
-              <a:srgbClr val="3C7A86"/>
-            </a:solidFill>
-            <a:prstDash val="solid"/>
-          </a:ln>
-        </p:spPr>
-        <p:txBody>
-          <a:bodyPr/>
-          <a:p/>
-        </p:txBody>
-      </p:sp>
-      <p:pic>
-        <p:nvPicPr>
-          <p:cNvPr id="6" name="Image 0" descr="preencoded.png">    </p:cNvPr>
-          <p:cNvPicPr>
-            <a:picLocks noChangeAspect="1"/>
-          </p:cNvPicPr>
-          <p:nvPr/>
-        </p:nvPicPr>
-        <p:blipFill>
-          <a:blip r:embed="rId1"/>
-          <a:stretch>
-            <a:fillRect/>
-          </a:stretch>
-        </p:blipFill>
-        <p:spPr>
-          <a:xfrm>
-            <a:off x="704088" y="2121408"/>
-            <a:ext cx="237744" cy="237744"/>
-          </a:xfrm>
-          <a:prstGeom prst="rect">
-            <a:avLst/>
-          </a:prstGeom>
-        </p:spPr>
-      </p:pic>
-      <p:sp>
-        <p:nvSpPr>
-          <p:cNvPr id="7" name="Text 4"/>
-          <p:cNvSpPr txBox="1"/>
-          <p:nvPr/>
-        </p:nvSpPr>
-        <p:spPr>
-          <a:xfrm>
-            <a:off x="1234440" y="2011680"/>
-            <a:ext cx="1463040" cy="457200"/>
-          </a:xfrm>
-          <a:prstGeom prst="rect">
-            <a:avLst/>
-          </a:prstGeom>
-          <a:noFill/>
-          <a:ln/>
-        </p:spPr>
-        <p:txBody>
-          <a:bodyPr wrap="square" lIns="0" tIns="0" rIns="0" bIns="0" rtlCol="0" anchor="ctr"/>
-          <a:lstStyle/>
-          <a:p>
-            <a:pPr indent="0" marL="0">
-              <a:buNone/>
-            </a:pPr>
-            <a:r>
-              <a:rPr lang="en-US" sz="1200" b="1" spc="300" kern="0" dirty="0">
-                <a:solidFill>
-                  <a:srgbClr val="E08A1E"/>
-                </a:solidFill>
-                <a:latin typeface="Calibri" pitchFamily="34" charset="0"/>
-                <a:ea typeface="Calibri" pitchFamily="34" charset="-122"/>
-                <a:cs typeface="Calibri" pitchFamily="34" charset="-120"/>
-              </a:rPr>
-              <a:t>DONE</a:t>
-            </a:r>
-            <a:endParaRPr lang="en-US" sz="1200" dirty="0"/>
-          </a:p>
-        </p:txBody>
-      </p:sp>
-      <p:sp>
-        <p:nvSpPr>
-          <p:cNvPr id="8" name="Shape 5"/>
-          <p:cNvSpPr/>
-          <p:nvPr/>
-        </p:nvSpPr>
-        <p:spPr>
-          <a:xfrm>
-            <a:off x="548640" y="2743200"/>
-            <a:ext cx="2567178" cy="1600200"/>
-          </a:xfrm>
-          <a:prstGeom prst="roundRect">
-            <a:avLst>
-              <a:gd name="adj" fmla="val 5714"/>
-            </a:avLst>
-          </a:prstGeom>
-          <a:solidFill>
-            <a:srgbClr val="0E3F49"/>
-          </a:solidFill>
-          <a:ln/>
-        </p:spPr>
-        <p:txBody>
-          <a:bodyPr/>
-          <a:p/>
-        </p:txBody>
-      </p:sp>
-      <p:sp>
-        <p:nvSpPr>
-          <p:cNvPr id="9" name="Text 6"/>
-          <p:cNvSpPr txBox="1"/>
-          <p:nvPr/>
-        </p:nvSpPr>
-        <p:spPr>
-          <a:xfrm>
-            <a:off x="731520" y="2852928"/>
-            <a:ext cx="2201418" cy="365760"/>
-          </a:xfrm>
-          <a:prstGeom prst="rect">
-            <a:avLst/>
-          </a:prstGeom>
-          <a:noFill/>
-          <a:ln/>
-        </p:spPr>
-        <p:txBody>
-          <a:bodyPr wrap="square" lIns="0" tIns="0" rIns="0" bIns="0" rtlCol="0" anchor="ctr"/>
-          <a:lstStyle/>
-          <a:p>
-            <a:pPr indent="0" marL="0">
-              <a:buNone/>
-            </a:pPr>
-            <a:r>
-              <a:rPr lang="en-US" sz="1500" b="1" dirty="0">
-                <a:solidFill>
-                  <a:srgbClr val="FFFFFF"/>
-                </a:solidFill>
-                <a:latin typeface="Cambria" pitchFamily="34" charset="0"/>
-                <a:ea typeface="Cambria" pitchFamily="34" charset="-122"/>
-                <a:cs typeface="Cambria" pitchFamily="34" charset="-120"/>
-              </a:rPr>
-              <a:t>NH data + analysis</a:t>
-            </a:r>
-            <a:endParaRPr lang="en-US" sz="1500" dirty="0"/>
-          </a:p>
-        </p:txBody>
-      </p:sp>
-      <p:sp>
-        <p:nvSpPr>
-          <p:cNvPr id="10" name="Text 7"/>
-          <p:cNvSpPr txBox="1"/>
-          <p:nvPr/>
-        </p:nvSpPr>
-        <p:spPr>
-          <a:xfrm>
-            <a:off x="731520" y="3255264"/>
-            <a:ext cx="2201418" cy="1005840"/>
-          </a:xfrm>
-          <a:prstGeom prst="rect">
-            <a:avLst/>
-          </a:prstGeom>
-          <a:noFill/>
-          <a:ln/>
-        </p:spPr>
-        <p:txBody>
-          <a:bodyPr wrap="square" lIns="0" tIns="0" rIns="0" bIns="0" rtlCol="0" anchor="t"/>
-          <a:lstStyle/>
-          <a:p>
-            <a:pPr indent="0" marL="0">
-              <a:buNone/>
-            </a:pPr>
-            <a:r>
-              <a:rPr lang="en-US" sz="1200" dirty="0">
-                <a:solidFill>
-                  <a:srgbClr val="CFE3E6"/>
-                </a:solidFill>
-                <a:latin typeface="Calibri" pitchFamily="34" charset="0"/>
-                <a:ea typeface="Calibri" pitchFamily="34" charset="-122"/>
-                <a:cs typeface="Calibri" pitchFamily="34" charset="-120"/>
-              </a:rPr>
-              <a:t>97.8% OSM coverage, first findings, delay flags, cited PIB events</a:t>
-            </a:r>
-            <a:endParaRPr lang="en-US" sz="1200" dirty="0"/>
-          </a:p>
-        </p:txBody>
-      </p:sp>
-      <p:sp>
-        <p:nvSpPr>
-          <p:cNvPr id="11" name="Shape 8"/>
-          <p:cNvSpPr/>
-          <p:nvPr/>
-        </p:nvSpPr>
-        <p:spPr>
-          <a:xfrm>
-            <a:off x="3390138" y="1965960"/>
-            <a:ext cx="548640" cy="548640"/>
-          </a:xfrm>
-          <a:prstGeom prst="ellipse">
-            <a:avLst/>
-          </a:prstGeom>
-          <a:solidFill>
-            <a:srgbClr val="E08A1E"/>
-          </a:solidFill>
-          <a:ln w="25400">
-            <a:solidFill>
-              <a:srgbClr val="3C7A86"/>
-            </a:solidFill>
-            <a:prstDash val="solid"/>
-          </a:ln>
-        </p:spPr>
-        <p:txBody>
-          <a:bodyPr/>
-          <a:p/>
-        </p:txBody>
-      </p:sp>
-      <p:pic>
-        <p:nvPicPr>
-          <p:cNvPr id="12" name="Image 1" descr="preencoded.png">    </p:cNvPr>
-          <p:cNvPicPr>
-            <a:picLocks noChangeAspect="1"/>
-          </p:cNvPicPr>
-          <p:nvPr/>
-        </p:nvPicPr>
-        <p:blipFill>
-          <a:blip r:embed="rId2"/>
-          <a:stretch>
-            <a:fillRect/>
-          </a:stretch>
-        </p:blipFill>
-        <p:spPr>
-          <a:xfrm>
-            <a:off x="3545586" y="2121408"/>
-            <a:ext cx="237744" cy="237744"/>
-          </a:xfrm>
-          <a:prstGeom prst="rect">
-            <a:avLst/>
-          </a:prstGeom>
-        </p:spPr>
-      </p:pic>
-      <p:sp>
-        <p:nvSpPr>
-          <p:cNvPr id="13" name="Text 9"/>
-          <p:cNvSpPr txBox="1"/>
-          <p:nvPr/>
-        </p:nvSpPr>
-        <p:spPr>
-          <a:xfrm>
-            <a:off x="4075938" y="2011680"/>
-            <a:ext cx="1463040" cy="457200"/>
-          </a:xfrm>
-          <a:prstGeom prst="rect">
-            <a:avLst/>
-          </a:prstGeom>
-          <a:noFill/>
-          <a:ln/>
-        </p:spPr>
-        <p:txBody>
-          <a:bodyPr wrap="square" lIns="0" tIns="0" rIns="0" bIns="0" rtlCol="0" anchor="ctr"/>
-          <a:lstStyle/>
-          <a:p>
-            <a:pPr indent="0" marL="0">
-              <a:buNone/>
-            </a:pPr>
-            <a:r>
-              <a:rPr lang="en-US" sz="1200" b="1" spc="300" kern="0" dirty="0">
-                <a:solidFill>
-                  <a:srgbClr val="E08A1E"/>
-                </a:solidFill>
-                <a:latin typeface="Calibri" pitchFamily="34" charset="0"/>
-                <a:ea typeface="Calibri" pitchFamily="34" charset="-122"/>
-                <a:cs typeface="Calibri" pitchFamily="34" charset="-120"/>
-              </a:rPr>
-              <a:t>LIVE</a:t>
-            </a:r>
-            <a:endParaRPr lang="en-US" sz="1200" dirty="0"/>
-          </a:p>
-        </p:txBody>
-      </p:sp>
-      <p:sp>
-        <p:nvSpPr>
-          <p:cNvPr id="14" name="Shape 10"/>
-          <p:cNvSpPr/>
-          <p:nvPr/>
-        </p:nvSpPr>
-        <p:spPr>
-          <a:xfrm>
-            <a:off x="3390138" y="2743200"/>
-            <a:ext cx="2567178" cy="1600200"/>
-          </a:xfrm>
-          <a:prstGeom prst="roundRect">
-            <a:avLst>
-              <a:gd name="adj" fmla="val 5714"/>
-            </a:avLst>
-          </a:prstGeom>
-          <a:solidFill>
-            <a:srgbClr val="0E3F49"/>
-          </a:solidFill>
-          <a:ln/>
-        </p:spPr>
-        <p:txBody>
-          <a:bodyPr/>
-          <a:p/>
-        </p:txBody>
-      </p:sp>
-      <p:sp>
-        <p:nvSpPr>
-          <p:cNvPr id="15" name="Text 11"/>
-          <p:cNvSpPr txBox="1"/>
-          <p:nvPr/>
-        </p:nvSpPr>
-        <p:spPr>
-          <a:xfrm>
-            <a:off x="3573018" y="2852928"/>
-            <a:ext cx="2201418" cy="365760"/>
-          </a:xfrm>
-          <a:prstGeom prst="rect">
-            <a:avLst/>
-          </a:prstGeom>
-          <a:noFill/>
-          <a:ln/>
-        </p:spPr>
-        <p:txBody>
-          <a:bodyPr wrap="square" lIns="0" tIns="0" rIns="0" bIns="0" rtlCol="0" anchor="ctr"/>
-          <a:lstStyle/>
-          <a:p>
-            <a:pPr indent="0" marL="0">
-              <a:buNone/>
-            </a:pPr>
-            <a:r>
-              <a:rPr lang="en-US" sz="1500" b="1" dirty="0">
-                <a:solidFill>
-                  <a:srgbClr val="FFFFFF"/>
-                </a:solidFill>
-                <a:latin typeface="Cambria" pitchFamily="34" charset="0"/>
-                <a:ea typeface="Cambria" pitchFamily="34" charset="-122"/>
-                <a:cs typeface="Cambria" pitchFamily="34" charset="-120"/>
-              </a:rPr>
-              <a:t>Investor flow</a:t>
-            </a:r>
-            <a:endParaRPr lang="en-US" sz="1500" dirty="0"/>
-          </a:p>
-        </p:txBody>
-      </p:sp>
-      <p:sp>
-        <p:nvSpPr>
-          <p:cNvPr id="16" name="Text 12"/>
-          <p:cNvSpPr txBox="1"/>
-          <p:nvPr/>
-        </p:nvSpPr>
-        <p:spPr>
-          <a:xfrm>
-            <a:off x="3573018" y="3255264"/>
-            <a:ext cx="2201418" cy="1005840"/>
-          </a:xfrm>
-          <a:prstGeom prst="rect">
-            <a:avLst/>
-          </a:prstGeom>
-          <a:noFill/>
-          <a:ln/>
-        </p:spPr>
-        <p:txBody>
-          <a:bodyPr wrap="square" lIns="0" tIns="0" rIns="0" bIns="0" rtlCol="0" anchor="t"/>
-          <a:lstStyle/>
-          <a:p>
-            <a:pPr indent="0" marL="0">
-              <a:buNone/>
-            </a:pPr>
-            <a:r>
-              <a:rPr lang="en-US" sz="1200" dirty="0">
-                <a:solidFill>
-                  <a:srgbClr val="CFE3E6"/>
-                </a:solidFill>
-                <a:latin typeface="Calibri" pitchFamily="34" charset="0"/>
-                <a:ea typeface="Calibri" pitchFamily="34" charset="-122"/>
-                <a:cs typeface="Calibri" pitchFamily="34" charset="-120"/>
-              </a:rPr>
-              <a:t>381 cities, Go API, onboarding and city pages</a:t>
-            </a:r>
-            <a:endParaRPr lang="en-US" sz="1200" dirty="0"/>
-          </a:p>
-        </p:txBody>
-      </p:sp>
-      <p:sp>
-        <p:nvSpPr>
-          <p:cNvPr id="17" name="Shape 13"/>
-          <p:cNvSpPr/>
-          <p:nvPr/>
-        </p:nvSpPr>
-        <p:spPr>
-          <a:xfrm>
-            <a:off x="6231636" y="1965960"/>
-            <a:ext cx="548640" cy="548640"/>
-          </a:xfrm>
-          <a:prstGeom prst="ellipse">
-            <a:avLst/>
-          </a:prstGeom>
-          <a:solidFill>
-            <a:srgbClr val="0B4F5C"/>
-          </a:solidFill>
-          <a:ln w="25400">
-            <a:solidFill>
-              <a:srgbClr val="3C7A86"/>
-            </a:solidFill>
-            <a:prstDash val="solid"/>
-          </a:ln>
-        </p:spPr>
-        <p:txBody>
-          <a:bodyPr/>
-          <a:p/>
-        </p:txBody>
-      </p:sp>
-      <p:sp>
-        <p:nvSpPr>
-          <p:cNvPr id="18" name="Text 14"/>
-          <p:cNvSpPr txBox="1"/>
-          <p:nvPr/>
-        </p:nvSpPr>
-        <p:spPr>
-          <a:xfrm>
-            <a:off x="6917436" y="2011680"/>
-            <a:ext cx="1463040" cy="457200"/>
-          </a:xfrm>
-          <a:prstGeom prst="rect">
-            <a:avLst/>
-          </a:prstGeom>
-          <a:noFill/>
-          <a:ln/>
-        </p:spPr>
-        <p:txBody>
-          <a:bodyPr wrap="square" lIns="0" tIns="0" rIns="0" bIns="0" rtlCol="0" anchor="ctr"/>
-          <a:lstStyle/>
-          <a:p>
-            <a:pPr indent="0" marL="0">
-              <a:buNone/>
-            </a:pPr>
-            <a:r>
-              <a:rPr lang="en-US" sz="1200" b="1" spc="300" kern="0" dirty="0">
-                <a:solidFill>
-                  <a:srgbClr val="9FC3C9"/>
-                </a:solidFill>
-                <a:latin typeface="Calibri" pitchFamily="34" charset="0"/>
-                <a:ea typeface="Calibri" pitchFamily="34" charset="-122"/>
-                <a:cs typeface="Calibri" pitchFamily="34" charset="-120"/>
-              </a:rPr>
-              <a:t>NEXT</a:t>
-            </a:r>
-            <a:endParaRPr lang="en-US" sz="1200" dirty="0"/>
-          </a:p>
-        </p:txBody>
-      </p:sp>
-      <p:sp>
-        <p:nvSpPr>
-          <p:cNvPr id="19" name="Shape 15"/>
-          <p:cNvSpPr/>
-          <p:nvPr/>
-        </p:nvSpPr>
-        <p:spPr>
-          <a:xfrm>
-            <a:off x="6231636" y="2743200"/>
-            <a:ext cx="2567178" cy="1600200"/>
-          </a:xfrm>
-          <a:prstGeom prst="roundRect">
-            <a:avLst>
-              <a:gd name="adj" fmla="val 5714"/>
-            </a:avLst>
-          </a:prstGeom>
-          <a:solidFill>
-            <a:srgbClr val="0E3F49"/>
-          </a:solidFill>
-          <a:ln/>
-        </p:spPr>
-        <p:txBody>
-          <a:bodyPr/>
-          <a:p/>
-        </p:txBody>
-      </p:sp>
-      <p:sp>
-        <p:nvSpPr>
-          <p:cNvPr id="20" name="Text 16"/>
-          <p:cNvSpPr txBox="1"/>
-          <p:nvPr/>
-        </p:nvSpPr>
-        <p:spPr>
-          <a:xfrm>
-            <a:off x="6414516" y="2852928"/>
-            <a:ext cx="2201418" cy="365760"/>
-          </a:xfrm>
-          <a:prstGeom prst="rect">
-            <a:avLst/>
-          </a:prstGeom>
-          <a:noFill/>
-          <a:ln/>
-        </p:spPr>
-        <p:txBody>
-          <a:bodyPr wrap="square" lIns="0" tIns="0" rIns="0" bIns="0" rtlCol="0" anchor="ctr"/>
-          <a:lstStyle/>
-          <a:p>
-            <a:pPr indent="0" marL="0">
-              <a:buNone/>
-            </a:pPr>
-            <a:r>
-              <a:rPr lang="en-US" sz="1500" b="1" dirty="0">
-                <a:solidFill>
-                  <a:srgbClr val="FFFFFF"/>
-                </a:solidFill>
-                <a:latin typeface="Cambria" pitchFamily="34" charset="0"/>
-                <a:ea typeface="Cambria" pitchFamily="34" charset="-122"/>
-                <a:cs typeface="Cambria" pitchFamily="34" charset="-120"/>
-              </a:rPr>
-              <a:t>M0 Foundation</a:t>
-            </a:r>
-            <a:endParaRPr lang="en-US" sz="1500" dirty="0"/>
-          </a:p>
-        </p:txBody>
-      </p:sp>
-      <p:sp>
-        <p:nvSpPr>
-          <p:cNvPr id="21" name="Text 17"/>
-          <p:cNvSpPr txBox="1"/>
-          <p:nvPr/>
-        </p:nvSpPr>
-        <p:spPr>
-          <a:xfrm>
-            <a:off x="6414516" y="3255264"/>
-            <a:ext cx="2201418" cy="1005840"/>
-          </a:xfrm>
-          <a:prstGeom prst="rect">
-            <a:avLst/>
-          </a:prstGeom>
-          <a:noFill/>
-          <a:ln/>
-        </p:spPr>
-        <p:txBody>
-          <a:bodyPr wrap="square" lIns="0" tIns="0" rIns="0" bIns="0" rtlCol="0" anchor="t"/>
-          <a:lstStyle/>
-          <a:p>
-            <a:pPr indent="0" marL="0">
-              <a:buNone/>
-            </a:pPr>
-            <a:r>
-              <a:rPr lang="en-US" sz="1200" dirty="0">
-                <a:solidFill>
-                  <a:srgbClr val="CFE3E6"/>
-                </a:solidFill>
-                <a:latin typeface="Calibri" pitchFamily="34" charset="0"/>
-                <a:ea typeface="Calibri" pitchFamily="34" charset="-122"/>
-                <a:cs typeface="Calibri" pitchFamily="34" charset="-120"/>
-              </a:rPr>
-              <a:t>Postgres DB, API, UI shell, citizen intake</a:t>
-            </a:r>
-            <a:endParaRPr lang="en-US" sz="1200" dirty="0"/>
-          </a:p>
-        </p:txBody>
-      </p:sp>
-      <p:sp>
-        <p:nvSpPr>
-          <p:cNvPr id="22" name="Shape 18"/>
-          <p:cNvSpPr/>
-          <p:nvPr/>
-        </p:nvSpPr>
-        <p:spPr>
-          <a:xfrm>
-            <a:off x="9073134" y="1965960"/>
-            <a:ext cx="548640" cy="548640"/>
-          </a:xfrm>
-          <a:prstGeom prst="ellipse">
-            <a:avLst/>
-          </a:prstGeom>
-          <a:solidFill>
-            <a:srgbClr val="0B4F5C"/>
-          </a:solidFill>
-          <a:ln w="25400">
-            <a:solidFill>
-              <a:srgbClr val="3C7A86"/>
-            </a:solidFill>
-            <a:prstDash val="solid"/>
-          </a:ln>
-        </p:spPr>
-        <p:txBody>
-          <a:bodyPr/>
-          <a:p/>
-        </p:txBody>
-      </p:sp>
-      <p:sp>
-        <p:nvSpPr>
-          <p:cNvPr id="23" name="Text 19"/>
-          <p:cNvSpPr txBox="1"/>
-          <p:nvPr/>
-        </p:nvSpPr>
-        <p:spPr>
-          <a:xfrm>
-            <a:off x="9758934" y="2011680"/>
-            <a:ext cx="1463040" cy="457200"/>
-          </a:xfrm>
-          <a:prstGeom prst="rect">
-            <a:avLst/>
-          </a:prstGeom>
-          <a:noFill/>
-          <a:ln/>
-        </p:spPr>
-        <p:txBody>
-          <a:bodyPr wrap="square" lIns="0" tIns="0" rIns="0" bIns="0" rtlCol="0" anchor="ctr"/>
-          <a:lstStyle/>
-          <a:p>
-            <a:pPr indent="0" marL="0">
-              <a:buNone/>
-            </a:pPr>
-            <a:r>
-              <a:rPr lang="en-US" sz="1200" b="1" spc="300" kern="0" dirty="0">
-                <a:solidFill>
-                  <a:srgbClr val="9FC3C9"/>
-                </a:solidFill>
-                <a:latin typeface="Calibri" pitchFamily="34" charset="0"/>
-                <a:ea typeface="Calibri" pitchFamily="34" charset="-122"/>
-                <a:cs typeface="Calibri" pitchFamily="34" charset="-120"/>
-              </a:rPr>
-              <a:t>THEN</a:t>
-            </a:r>
-            <a:endParaRPr lang="en-US" sz="1200" dirty="0"/>
-          </a:p>
-        </p:txBody>
-      </p:sp>
-      <p:sp>
-        <p:nvSpPr>
-          <p:cNvPr id="24" name="Shape 20"/>
-          <p:cNvSpPr/>
-          <p:nvPr/>
-        </p:nvSpPr>
-        <p:spPr>
-          <a:xfrm>
-            <a:off x="9073134" y="2743200"/>
-            <a:ext cx="2567178" cy="1600200"/>
-          </a:xfrm>
-          <a:prstGeom prst="roundRect">
-            <a:avLst>
-              <a:gd name="adj" fmla="val 5714"/>
-            </a:avLst>
-          </a:prstGeom>
-          <a:solidFill>
-            <a:srgbClr val="0E3F49"/>
-          </a:solidFill>
-          <a:ln/>
-        </p:spPr>
-        <p:txBody>
-          <a:bodyPr/>
-          <a:p/>
-        </p:txBody>
-      </p:sp>
-      <p:sp>
-        <p:nvSpPr>
-          <p:cNvPr id="25" name="Text 21"/>
-          <p:cNvSpPr txBox="1"/>
-          <p:nvPr/>
-        </p:nvSpPr>
-        <p:spPr>
-          <a:xfrm>
-            <a:off x="9256014" y="2852928"/>
-            <a:ext cx="2201418" cy="365760"/>
-          </a:xfrm>
-          <a:prstGeom prst="rect">
-            <a:avLst/>
-          </a:prstGeom>
-          <a:noFill/>
-          <a:ln/>
-        </p:spPr>
-        <p:txBody>
-          <a:bodyPr wrap="square" lIns="0" tIns="0" rIns="0" bIns="0" rtlCol="0" anchor="ctr"/>
-          <a:lstStyle/>
-          <a:p>
-            <a:pPr indent="0" marL="0">
-              <a:buNone/>
-            </a:pPr>
-            <a:r>
-              <a:rPr lang="en-US" sz="1500" b="1" dirty="0">
-                <a:solidFill>
-                  <a:srgbClr val="FFFFFF"/>
-                </a:solidFill>
-                <a:latin typeface="Cambria" pitchFamily="34" charset="0"/>
-                <a:ea typeface="Cambria" pitchFamily="34" charset="-122"/>
-                <a:cs typeface="Cambria" pitchFamily="34" charset="-120"/>
-              </a:rPr>
-              <a:t>Metro + more fields</a:t>
-            </a:r>
-            <a:endParaRPr lang="en-US" sz="1500" dirty="0"/>
-          </a:p>
-        </p:txBody>
-      </p:sp>
-      <p:sp>
-        <p:nvSpPr>
-          <p:cNvPr id="26" name="Text 22"/>
-          <p:cNvSpPr txBox="1"/>
-          <p:nvPr/>
-        </p:nvSpPr>
-        <p:spPr>
-          <a:xfrm>
-            <a:off x="9256014" y="3255264"/>
-            <a:ext cx="2201418" cy="1005840"/>
-          </a:xfrm>
-          <a:prstGeom prst="rect">
-            <a:avLst/>
-          </a:prstGeom>
-          <a:noFill/>
-          <a:ln/>
-        </p:spPr>
-        <p:txBody>
-          <a:bodyPr wrap="square" lIns="0" tIns="0" rIns="0" bIns="0" rtlCol="0" anchor="t"/>
-          <a:lstStyle/>
-          <a:p>
-            <a:pPr indent="0" marL="0">
-              <a:buNone/>
-            </a:pPr>
-            <a:r>
-              <a:rPr lang="en-US" sz="1200" dirty="0">
-                <a:solidFill>
-                  <a:srgbClr val="CFE3E6"/>
-                </a:solidFill>
-                <a:latin typeface="Calibri" pitchFamily="34" charset="0"/>
-                <a:ea typeface="Calibri" pitchFamily="34" charset="-122"/>
-                <a:cs typeface="Calibri" pitchFamily="34" charset="-120"/>
-              </a:rPr>
-              <a:t>Metro, railways, airports, water — one at a time</a:t>
-            </a:r>
-            <a:endParaRPr lang="en-US" sz="1200" dirty="0"/>
-          </a:p>
-        </p:txBody>
-      </p:sp>
-      <p:sp>
-        <p:nvSpPr>
-          <p:cNvPr id="27" name="Text 23"/>
-          <p:cNvSpPr txBox="1"/>
-          <p:nvPr/>
-        </p:nvSpPr>
-        <p:spPr>
-          <a:xfrm>
-            <a:off x="548640" y="4663440"/>
-            <a:ext cx="5029200" cy="274320"/>
-          </a:xfrm>
-          <a:prstGeom prst="rect">
-            <a:avLst/>
-          </a:prstGeom>
-          <a:noFill/>
-          <a:ln/>
-        </p:spPr>
-        <p:txBody>
-          <a:bodyPr wrap="square" lIns="0" tIns="0" rIns="0" bIns="0" rtlCol="0" anchor="ctr"/>
-          <a:lstStyle/>
-          <a:p>
-            <a:pPr indent="0" marL="0">
-              <a:buNone/>
-            </a:pPr>
-            <a:r>
-              <a:rPr lang="en-US" sz="1200" b="1" spc="300" kern="0" dirty="0">
-                <a:solidFill>
-                  <a:srgbClr val="E08A1E"/>
-                </a:solidFill>
-                <a:latin typeface="Calibri" pitchFamily="34" charset="0"/>
-                <a:ea typeface="Calibri" pitchFamily="34" charset="-122"/>
-                <a:cs typeface="Calibri" pitchFamily="34" charset="-120"/>
-              </a:rPr>
-              <a:t>WHO BENEFITS</a:t>
-            </a:r>
-            <a:endParaRPr lang="en-US" sz="1200" dirty="0"/>
-          </a:p>
-        </p:txBody>
-      </p:sp>
-      <p:sp>
-        <p:nvSpPr>
-          <p:cNvPr id="28" name="Text 24"/>
-          <p:cNvSpPr txBox="1"/>
-          <p:nvPr/>
-        </p:nvSpPr>
-        <p:spPr>
-          <a:xfrm>
-            <a:off x="548640" y="4983480"/>
-            <a:ext cx="5669280" cy="1325880"/>
-          </a:xfrm>
-          <a:prstGeom prst="rect">
-            <a:avLst/>
-          </a:prstGeom>
-          <a:noFill/>
-          <a:ln/>
-        </p:spPr>
-        <p:txBody>
-          <a:bodyPr wrap="square" lIns="0" tIns="0" rIns="0" bIns="0" rtlCol="0" anchor="t"/>
-          <a:lstStyle/>
-          <a:p>
-            <a:pPr marL="342900" indent="-342900">
-              <a:spcAft>
-                <a:spcPts val="500"/>
-              </a:spcAft>
-              <a:buSzPct val="100000"/>
-              <a:buChar char="•"/>
-            </a:pPr>
-            <a:r>
-              <a:rPr lang="en-US" sz="1200" dirty="0">
-                <a:solidFill>
-                  <a:srgbClr val="FFFFFF"/>
-                </a:solidFill>
-                <a:latin typeface="Calibri" pitchFamily="34" charset="0"/>
-                <a:ea typeface="Calibri" pitchFamily="34" charset="-122"/>
-                <a:cs typeface="Calibri" pitchFamily="34" charset="-120"/>
-              </a:rPr>
-              <a:t>Citizens: report a need by voice, in their language; see what is coming nearby</a:t>
-            </a:r>
-            <a:endParaRPr lang="en-US" sz="1200" dirty="0"/>
-          </a:p>
-          <a:p>
-            <a:pPr marL="342900" indent="-342900">
-              <a:spcAft>
-                <a:spcPts val="500"/>
-              </a:spcAft>
-              <a:buSzPct val="100000"/>
-              <a:buChar char="•"/>
-            </a:pPr>
-            <a:r>
-              <a:rPr lang="en-US" sz="1200" dirty="0">
-                <a:solidFill>
-                  <a:srgbClr val="FFFFFF"/>
-                </a:solidFill>
-                <a:latin typeface="Calibri" pitchFamily="34" charset="0"/>
-                <a:ea typeface="Calibri" pitchFamily="34" charset="-122"/>
-                <a:cs typeface="Calibri" pitchFamily="34" charset="-120"/>
-              </a:rPr>
-              <a:t>Policymakers: ranked, evidence-backed priorities; spending-versus-need view</a:t>
-            </a:r>
-            <a:endParaRPr lang="en-US" sz="1200" dirty="0"/>
-          </a:p>
-          <a:p>
-            <a:pPr marL="342900" indent="-342900">
-              <a:spcAft>
-                <a:spcPts val="500"/>
-              </a:spcAft>
-              <a:buSzPct val="100000"/>
-              <a:buChar char="•"/>
-            </a:pPr>
-            <a:r>
-              <a:rPr lang="en-US" sz="1200" dirty="0">
-                <a:solidFill>
-                  <a:srgbClr val="FFFFFF"/>
-                </a:solidFill>
-                <a:latin typeface="Calibri" pitchFamily="34" charset="0"/>
-                <a:ea typeface="Calibri" pitchFamily="34" charset="-122"/>
-                <a:cs typeface="Calibri" pitchFamily="34" charset="-120"/>
-              </a:rPr>
-              <a:t>Investors and journalists: cited timelines, delays and growth drivers</a:t>
-            </a:r>
-            <a:endParaRPr lang="en-US" sz="1200" dirty="0"/>
-          </a:p>
-        </p:txBody>
-      </p:sp>
-      <p:sp>
-        <p:nvSpPr>
-          <p:cNvPr id="29" name="Shape 25"/>
-          <p:cNvSpPr/>
-          <p:nvPr/>
-        </p:nvSpPr>
-        <p:spPr>
-          <a:xfrm>
-            <a:off x="6492240" y="4617720"/>
-            <a:ext cx="5148072" cy="1691640"/>
-          </a:xfrm>
-          <a:prstGeom prst="roundRect">
-            <a:avLst>
-              <a:gd name="adj" fmla="val 6486"/>
-            </a:avLst>
-          </a:prstGeom>
-          <a:solidFill>
-            <a:srgbClr val="E08A1E"/>
-          </a:solidFill>
-          <a:ln/>
-        </p:spPr>
-        <p:txBody>
-          <a:bodyPr/>
-          <a:p/>
-        </p:txBody>
-      </p:sp>
-      <p:sp>
-        <p:nvSpPr>
-          <p:cNvPr id="30" name="Text 26"/>
-          <p:cNvSpPr txBox="1"/>
-          <p:nvPr/>
-        </p:nvSpPr>
-        <p:spPr>
-          <a:xfrm>
-            <a:off x="6720840" y="4727448"/>
-            <a:ext cx="4663440" cy="320040"/>
-          </a:xfrm>
-          <a:prstGeom prst="rect">
-            <a:avLst/>
-          </a:prstGeom>
-          <a:noFill/>
-          <a:ln/>
-        </p:spPr>
-        <p:txBody>
-          <a:bodyPr wrap="square" lIns="0" tIns="0" rIns="0" bIns="0" rtlCol="0" anchor="ctr"/>
-          <a:lstStyle/>
-          <a:p>
-            <a:pPr indent="0" marL="0">
-              <a:buNone/>
-            </a:pPr>
-            <a:r>
-              <a:rPr lang="en-US" sz="1600" b="1" dirty="0">
-                <a:solidFill>
-                  <a:srgbClr val="FFFFFF"/>
-                </a:solidFill>
-                <a:latin typeface="Cambria" pitchFamily="34" charset="0"/>
-                <a:ea typeface="Cambria" pitchFamily="34" charset="-122"/>
-                <a:cs typeface="Cambria" pitchFamily="34" charset="-120"/>
-              </a:rPr>
-              <a:t>What we need next</a:t>
-            </a:r>
-            <a:endParaRPr lang="en-US" sz="1600" dirty="0"/>
-          </a:p>
-        </p:txBody>
-      </p:sp>
-      <p:sp>
-        <p:nvSpPr>
-          <p:cNvPr id="31" name="Text 27"/>
-          <p:cNvSpPr txBox="1"/>
-          <p:nvPr/>
-        </p:nvSpPr>
-        <p:spPr>
-          <a:xfrm>
-            <a:off x="6720840" y="5093208"/>
-            <a:ext cx="4663440" cy="1143000"/>
-          </a:xfrm>
-          <a:prstGeom prst="rect">
-            <a:avLst/>
-          </a:prstGeom>
-          <a:noFill/>
-          <a:ln/>
-        </p:spPr>
-        <p:txBody>
-          <a:bodyPr wrap="square" lIns="0" tIns="0" rIns="0" bIns="0" rtlCol="0" anchor="t"/>
-          <a:lstStyle/>
-          <a:p>
-            <a:pPr marL="342900" indent="-342900">
-              <a:spcAft>
-                <a:spcPts val="400"/>
-              </a:spcAft>
-              <a:buSzPct val="100000"/>
-              <a:buChar char="•"/>
-            </a:pPr>
-            <a:r>
-              <a:rPr lang="en-US" sz="1300" dirty="0">
-                <a:solidFill>
-                  <a:srgbClr val="FFFFFF"/>
-                </a:solidFill>
-                <a:latin typeface="Calibri" pitchFamily="34" charset="0"/>
-                <a:ea typeface="Calibri" pitchFamily="34" charset="-122"/>
-                <a:cs typeface="Calibri" pitchFamily="34" charset="-120"/>
-              </a:rPr>
-              <a:t>Access to PM GatiShakti data</a:t>
-            </a:r>
-            <a:endParaRPr lang="en-US" sz="1300" dirty="0"/>
-          </a:p>
-          <a:p>
-            <a:pPr marL="342900" indent="-342900">
-              <a:spcAft>
-                <a:spcPts val="400"/>
-              </a:spcAft>
-              <a:buSzPct val="100000"/>
-              <a:buChar char="•"/>
-            </a:pPr>
-            <a:r>
-              <a:rPr lang="en-US" sz="1300" dirty="0">
-                <a:solidFill>
-                  <a:srgbClr val="FFFFFF"/>
-                </a:solidFill>
-                <a:latin typeface="Calibri" pitchFamily="34" charset="0"/>
-                <a:ea typeface="Calibri" pitchFamily="34" charset="-122"/>
-                <a:cs typeface="Calibri" pitchFamily="34" charset="-120"/>
-              </a:rPr>
-              <a:t>A pilot state or city partner</a:t>
-            </a:r>
-            <a:endParaRPr lang="en-US" sz="1300" dirty="0"/>
-          </a:p>
-          <a:p>
-            <a:pPr marL="342900" indent="-342900">
-              <a:spcAft>
-                <a:spcPts val="400"/>
-              </a:spcAft>
-              <a:buSzPct val="100000"/>
-              <a:buChar char="•"/>
-            </a:pPr>
-            <a:r>
-              <a:rPr lang="en-US" sz="1300" dirty="0">
-                <a:solidFill>
-                  <a:srgbClr val="FFFFFF"/>
-                </a:solidFill>
-                <a:latin typeface="Calibri" pitchFamily="34" charset="0"/>
-                <a:ea typeface="Calibri" pitchFamily="34" charset="-122"/>
-                <a:cs typeface="Calibri" pitchFamily="34" charset="-120"/>
-              </a:rPr>
-              <a:t>Bhashini API access for 22-language intake</a:t>
-            </a:r>
-            <a:endParaRPr lang="en-US" sz="1300" dirty="0"/>
-          </a:p>
-        </p:txBody>
-      </p:sp>
-      <p:sp>
-        <p:nvSpPr>
-          <p:cNvPr id="32" name="Text 28"/>
-          <p:cNvSpPr txBox="1"/>
-          <p:nvPr/>
-        </p:nvSpPr>
-        <p:spPr>
-          <a:xfrm>
-            <a:off x="548640" y="6446520"/>
-            <a:ext cx="5486400" cy="274320"/>
-          </a:xfrm>
-          <a:prstGeom prst="rect">
-            <a:avLst/>
-          </a:prstGeom>
-          <a:noFill/>
-          <a:ln/>
-        </p:spPr>
-        <p:txBody>
-          <a:bodyPr wrap="square" lIns="0" tIns="0" rIns="0" bIns="0" rtlCol="0" anchor="ctr"/>
-          <a:lstStyle/>
-          <a:p>
-            <a:pPr indent="0" marL="0">
-              <a:buNone/>
-            </a:pPr>
-            <a:r>
-              <a:rPr lang="en-US" sz="1000" dirty="0">
-                <a:solidFill>
-                  <a:srgbClr val="7FA9B0"/>
-                </a:solidFill>
-                <a:latin typeface="Calibri" pitchFamily="34" charset="0"/>
-                <a:ea typeface="Calibri" pitchFamily="34" charset="-122"/>
-                <a:cs typeface="Calibri" pitchFamily="34" charset="-120"/>
-              </a:rPr>
-              <a:t>INFRA-AI  ·  Digital Public Good</a:t>
-            </a:r>
-            <a:endParaRPr lang="en-US" sz="1000" dirty="0"/>
-          </a:p>
-        </p:txBody>
-      </p:sp>
-      <p:sp>
-        <p:nvSpPr>
-          <p:cNvPr id="33" name="Text 29"/>
-          <p:cNvSpPr txBox="1"/>
-          <p:nvPr/>
-        </p:nvSpPr>
-        <p:spPr>
-          <a:xfrm>
-            <a:off x="11091672" y="6446520"/>
-            <a:ext cx="548640" cy="274320"/>
-          </a:xfrm>
-          <a:prstGeom prst="rect">
-            <a:avLst/>
-          </a:prstGeom>
-          <a:noFill/>
-          <a:ln/>
-        </p:spPr>
-        <p:txBody>
-          <a:bodyPr wrap="square" lIns="0" tIns="0" rIns="0" bIns="0" rtlCol="0" anchor="ctr"/>
-          <a:lstStyle/>
-          <a:p>
-            <a:pPr algn="r" indent="0" marL="0">
-              <a:buNone/>
-            </a:pPr>
-            <a:r>
-              <a:rPr lang="en-US" sz="1000" dirty="0">
-                <a:solidFill>
-                  <a:srgbClr val="7FA9B0"/>
-                </a:solidFill>
-                <a:latin typeface="Calibri" pitchFamily="34" charset="0"/>
-                <a:ea typeface="Calibri" pitchFamily="34" charset="-122"/>
-                <a:cs typeface="Calibri" pitchFamily="34" charset="-120"/>
-              </a:rPr>
-              <a:t>9</a:t>
-            </a:r>
-            <a:endParaRPr lang="en-US" sz="1000" dirty="0"/>
-          </a:p>
-        </p:txBody>
-      </p:sp>
-    </p:spTree>
-  </p:cSld>
-  <p:clrMapOvr>
-    <a:masterClrMapping/>
-  </p:clrMapOvr>
-</p:sld>
-</file>
-
 <file path=ppt/theme/theme1.xml><?xml version="1.0" encoding="utf-8"?>
 <a:theme xmlns:a="http://schemas.openxmlformats.org/drawingml/2006/main" name="Office Theme">
   <a:themeElements>

</xml_diff>

<commit_message>
docs(pitch): fix slide 3 title wrap and slide 7 card text size; add PDF export
Slide 3 title no longer wraps into the subtitle; slide 7 body text 12->14pt to fill its cards. PDF is the PowerPoint export of the same 8 slides.

Co-Authored-By: Claude Sonnet 5.5 <noreply@anthropic.com>
</commit_message>
<xml_diff>
--- a/docs/INFRA-AI-pitch.pptx
+++ b/docs/INFRA-AI-pitch.pptx
@@ -3031,13 +3031,13 @@
               </a:spcAft>
             </a:pPr>
             <a:r>
-              <a:rPr sz="3000" b="1">
+              <a:rPr sz="3400" b="1">
                 <a:solidFill>
                   <a:srgbClr val="14232B"/>
                 </a:solidFill>
                 <a:latin typeface="Cambria"/>
               </a:rPr>
-              <a:t>Problem statement 01: AI for Digital Public Infrastructure &amp; Governance</a:t>
+              <a:t>Problem statement 01</a:t>
             </a:r>
           </a:p>
         </p:txBody>
@@ -3076,7 +3076,7 @@
                 </a:solidFill>
                 <a:latin typeface="Calibri"/>
               </a:rPr>
-              <a:t>Build with AI: Code for Communities, Second Edition  ·  Theme: Innovation  ·  Our chosen problem</a:t>
+              <a:t>AI for Digital Public Infrastructure &amp; Governance  ·  Build with AI: Code for Communities, Second Edition</a:t>
             </a:r>
           </a:p>
         </p:txBody>
@@ -7745,7 +7745,7 @@
               <a:buNone/>
             </a:pPr>
             <a:r>
-              <a:rPr lang="en-US" sz="1200" dirty="0">
+              <a:rPr lang="en-US" sz="1400" dirty="0">
                 <a:solidFill>
                   <a:srgbClr val="5B6B72"/>
                 </a:solidFill>
@@ -7906,7 +7906,7 @@
               <a:buNone/>
             </a:pPr>
             <a:r>
-              <a:rPr lang="en-US" sz="1200" dirty="0">
+              <a:rPr lang="en-US" sz="1400" dirty="0">
                 <a:solidFill>
                   <a:srgbClr val="5B6B72"/>
                 </a:solidFill>
@@ -8067,7 +8067,7 @@
               <a:buNone/>
             </a:pPr>
             <a:r>
-              <a:rPr lang="en-US" sz="1200" dirty="0">
+              <a:rPr lang="en-US" sz="1400" dirty="0">
                 <a:solidFill>
                   <a:srgbClr val="5B6B72"/>
                 </a:solidFill>
@@ -8228,7 +8228,7 @@
               <a:buNone/>
             </a:pPr>
             <a:r>
-              <a:rPr lang="en-US" sz="1200" dirty="0">
+              <a:rPr lang="en-US" sz="1400" dirty="0">
                 <a:solidFill>
                   <a:srgbClr val="5B6B72"/>
                 </a:solidFill>

</xml_diff>